<commit_message>
Rewrite deck content to match original topics with stronger English
Co-Authored-By: Claude Opus 5.5 <noreply@anthropic.com>
Claude-Session: https://claude.ai/code/session_01TFmXfwWy7YkFL9ETqt4WJz
</commit_message>
<xml_diff>
--- a/NutriPill.pptx
+++ b/NutriPill.pptx
@@ -14,10 +14,9 @@
     <p:sldId id="262" r:id="rId8"/>
     <p:sldId id="263" r:id="rId9"/>
     <p:sldId id="264" r:id="rId10"/>
-    <p:sldId id="265" r:id="rId11"/>
   </p:sldIdLst>
   <p:notesMasterIdLst>
-    <p:notesMasterId r:id="rId12"/>
+    <p:notesMasterId r:id="rId11"/>
   </p:notesMasterIdLst>
   <p:sldSz cx="12192000" cy="6858000"/>
   <p:notesSz cx="6858000" cy="12192000"/>
@@ -116,12 +115,12 @@
   <p:extLst>
     <p:ext uri="{521415D9-36F7-43E2-AB2F-B90AF26B5E84}">
       <p14:sectionLst xmlns:p14="http://schemas.microsoft.com/office/powerpoint/2010/main">
-        <p14:section name="Welcome" id="{897b4e0f-b83a-ccbf-4645-4e638564f09e}">
+        <p14:section name="Welcome" id="{7618d354-20c1-b2da-a740-03744aef400d}">
           <p14:sldIdLst>
             <p14:sldId id="256"/>
           </p14:sldIdLst>
         </p14:section>
-        <p14:section name="The idea" id="{3b4e8863-c5f9-cf60-c8c7-e04fc08a1ca5}">
+        <p14:section name="The idea" id="{9c33d551-94bf-8a37-9215-53f94cbc8e53}">
           <p14:sldIdLst>
             <p14:sldId id="257"/>
             <p14:sldId id="258"/>
@@ -129,17 +128,12 @@
             <p14:sldId id="260"/>
           </p14:sldIdLst>
         </p14:section>
-        <p14:section name="The business" id="{545b4e2e-fddf-791b-7c5e-068c4ed03f93}">
+        <p14:section name="The business" id="{4ed206d7-a2ad-d083-f884-9ca144e82f40}">
           <p14:sldIdLst>
             <p14:sldId id="261"/>
             <p14:sldId id="262"/>
             <p14:sldId id="263"/>
             <p14:sldId id="264"/>
-          </p14:sldIdLst>
-        </p14:section>
-        <p14:section name="Close" id="{f5be6d5e-47af-ae35-376e-fb7d7d1ca0a8}">
-          <p14:sldIdLst>
-            <p14:sldId id="265"/>
           </p14:sldIdLst>
         </p14:section>
       </p14:sectionLst>
@@ -546,7 +540,7 @@
           <a:p>
             <a:r>
               <a:rPr lang="en-US" dirty="0"/>
-              <a:t>Hi everyone! We are Dani, Max, William and Miguel, and today we are going to present our business idea: NutriPill. Essential nutrients — anytime, anywhere.</a:t>
+              <a:t>Good morning, everyone. We are Dani, Max, William and Miguel, and today we would like to present our business proposal: NutriPill, a product that brings essential nutrients to people with busy lives. Over the next few minutes, we will explain the problem we have identified, our solution, who it is for, and how we plan to turn this idea into a successful brand.</a:t>
             </a:r>
             <a:endParaRPr lang="en-US" dirty="0"/>
           </a:p>
@@ -570,94 +564,6 @@
             <a:fld id="{F7021451-1387-4CA6-816F-3879F97B5CBC}" type="slidenum">
               <a:rPr lang="en-US"/>
               <a:t>1</a:t>
-            </a:fld>
-            <a:endParaRPr lang="en-US"/>
-          </a:p>
-        </p:txBody>
-      </p:sp>
-    </p:spTree>
-    <p:extLst>
-      <p:ext uri="{BB962C8B-B14F-4D97-AF65-F5344CB8AC3E}">
-        <p14:creationId xmlns:p14="http://schemas.microsoft.com/office/powerpoint/2010/main" val="1024086991"/>
-      </p:ext>
-    </p:extLst>
-  </p:cSld>
-  <p:clrMapOvr>
-    <a:masterClrMapping/>
-  </p:clrMapOvr>
-</p:notes>
-</file>
-
-<file path=ppt/notesSlides/notesSlide10.xml><?xml version="1.0" encoding="utf-8"?>
-<p:notes xmlns:a="http://schemas.openxmlformats.org/drawingml/2006/main" xmlns:r="http://schemas.openxmlformats.org/officeDocument/2006/relationships" xmlns:p="http://schemas.openxmlformats.org/presentationml/2006/main">
-  <p:cSld>
-    <p:spTree>
-      <p:nvGrpSpPr>
-        <p:cNvPr id="1" name=""/>
-        <p:cNvGrpSpPr/>
-        <p:nvPr/>
-      </p:nvGrpSpPr>
-      <p:grpSpPr>
-        <a:xfrm>
-          <a:off x="0" y="0"/>
-          <a:ext cx="0" cy="0"/>
-          <a:chOff x="0" y="0"/>
-          <a:chExt cx="0" cy="0"/>
-        </a:xfrm>
-      </p:grpSpPr>
-      <p:sp>
-        <p:nvSpPr>
-          <p:cNvPr id="2" name="Slide Image Placeholder 1"/>
-          <p:cNvSpPr>
-            <a:spLocks noGrp="1" noRot="1" noChangeAspect="1"/>
-          </p:cNvSpPr>
-          <p:nvPr>
-            <p:ph type="sldImg"/>
-          </p:nvPr>
-        </p:nvSpPr>
-        <p:spPr/>
-      </p:sp>
-      <p:sp>
-        <p:nvSpPr>
-          <p:cNvPr id="3" name="Notes Placeholder 2"/>
-          <p:cNvSpPr>
-            <a:spLocks noGrp="1"/>
-          </p:cNvSpPr>
-          <p:nvPr>
-            <p:ph type="body" idx="1"/>
-          </p:nvPr>
-        </p:nvSpPr>
-        <p:spPr/>
-        <p:txBody>
-          <a:bodyPr/>
-          <a:lstStyle/>
-          <a:p>
-            <a:r>
-              <a:rPr lang="en-US" dirty="0"/>
-              <a:t>Thank you for listening! NutriPill: essential nutrients, anytime, anywhere. Do you have any questions?</a:t>
-            </a:r>
-            <a:endParaRPr lang="en-US" dirty="0"/>
-          </a:p>
-        </p:txBody>
-      </p:sp>
-      <p:sp>
-        <p:nvSpPr>
-          <p:cNvPr id="4" name="Slide Number Placeholder 3"/>
-          <p:cNvSpPr>
-            <a:spLocks noGrp="1"/>
-          </p:cNvSpPr>
-          <p:nvPr>
-            <p:ph type="sldNum" sz="quarter" idx="10"/>
-          </p:nvPr>
-        </p:nvSpPr>
-        <p:spPr/>
-        <p:txBody>
-          <a:bodyPr/>
-          <a:lstStyle/>
-          <a:p>
-            <a:fld id="{F7021451-1387-4CA6-816F-3879F97B5CBC}" type="slidenum">
-              <a:rPr lang="en-US"/>
-              <a:t>10</a:t>
             </a:fld>
             <a:endParaRPr lang="en-US"/>
           </a:p>
@@ -722,7 +628,7 @@
           <a:p>
             <a:r>
               <a:rPr lang="en-US" dirty="0"/>
-              <a:t>Have you ever been too busy to eat? Imagine a pill that gives you essential nutrients when you don't have time for a meal. Meet NutriPill: small, simple, and designed for your busy lifestyle.</a:t>
+              <a:t>Let's start with a simple question: have you ever been so busy that you simply didn't have time to eat? Most of us have experienced this at some point. Now, imagine a pill that could give your body the essential nutrients it needs on those days when there is no time for a proper meal. That is exactly what NutriPill is: a convenient way to get essential nutrients on the go. It is small, simple, and designed to fit perfectly into a busy lifestyle.</a:t>
             </a:r>
             <a:endParaRPr lang="en-US" dirty="0"/>
           </a:p>
@@ -810,7 +716,7 @@
           <a:p>
             <a:r>
               <a:rPr lang="en-US" dirty="0"/>
-              <a:t>Nowadays many people have very busy schedules. Students and workers often skip meals because they are in a hurry. This leads to low energy, difficulty concentrating and poor nutrition. They need a quick and convenient way to get essential nutrients.</a:t>
+              <a:t>So, what is the problem? Nowadays, many people have such busy schedules that they don't have enough time to prepare or eat proper meals. Students and workers, in particular, often skip meals because they are always in a hurry. As a result, they suffer from low energy, they find it difficult to concentrate, and, over time, their nutrition becomes poor. Clearly, what these people need is a quick and convenient way to get essential nutrients when there is simply no time to eat.</a:t>
             </a:r>
             <a:endParaRPr lang="en-US" dirty="0"/>
           </a:p>
@@ -898,7 +804,7 @@
           <a:p>
             <a:r>
               <a:rPr lang="en-US" dirty="0"/>
-              <a:t>NutriPill is an innovative and convenient pill that provides essential nutrients when people don't have time to eat. It is small, easy to carry, and perfect for busy students and workers. Our goal is to help people keep their energy up. It doesn't replace a complete meal, but it's a practical way to supplement nutrition when life gets busy.</a:t>
+              <a:t>This is where our solution comes in. NutriPill is an innovative and convenient pill designed to provide essential nutrients when people don't have time to eat. It is small, easy to carry, and perfect for busy students and workers. Our main goal is to help people maintain their energy and get extra nutrients throughout the day. However, we want to be honest: NutriPill does not replace a complete meal. Instead, it offers a practical way to supplement your nutrition when life gets busy.</a:t>
             </a:r>
             <a:endParaRPr lang="en-US" dirty="0"/>
           </a:p>
@@ -986,7 +892,7 @@
           <a:p>
             <a:r>
               <a:rPr lang="en-US" dirty="0"/>
-              <a:t>NutriPill is designed for busy people who don't always have time to eat properly. Our main target audience is students, workers, athletes, and people with hectic lifestyles who need a quick way to supplement their nutrition during the day.</a:t>
+              <a:t>But who exactly is our brand directed to? NutriPill is designed for busy people who don't always have time to eat properly. Our main target audience includes students, who spend long days in class and studying; workers, who often skip lunch because of tight deadlines and meetings; athletes, who need a steady supply of nutrients for their training; and, in general, anyone with a hectic lifestyle. It is especially useful for those who need a quick and convenient way to supplement their nutrition during a busy day.</a:t>
             </a:r>
             <a:endParaRPr lang="en-US" dirty="0"/>
           </a:p>
@@ -1074,7 +980,7 @@
           <a:p>
             <a:r>
               <a:rPr lang="en-US" dirty="0"/>
-              <a:t>Our business model is based on three pillars. Revenue: direct sales and experiences connected to the product. Channels: a strong presence on social media like Instagram, TikTok and YouTube, plus in-person experiences. Pricing: affordable, but with added value — an accessible premium option.</a:t>
+              <a:t>Now let's move on to our action plan. Our business model is built on three key pillars. Firstly, revenue: we will generate income through direct sales of NutriPill, as well as through experiences linked to the product. Secondly, channels: we will build a strong presence on the main social networks, combined with face-to-face experiences, so that people can get to know the brand in person. Finally, pricing: our prices will be affordable but with added value. In other words, NutriPill will be a premium option that remains accessible to everyone.</a:t>
             </a:r>
             <a:endParaRPr lang="en-US" dirty="0"/>
           </a:p>
@@ -1162,7 +1068,7 @@
           <a:p>
             <a:r>
               <a:rPr lang="en-US" dirty="0"/>
-              <a:t>To grow, we have a four-step strategy. One: create inspiring content on social media showing a real lifestyle. Two: work with local influencers who represent our brand's philosophy. Three: create memorable experiences like events, personalized kits and collaborations. Four: build an active community by inviting customers to be part of the brand.</a:t>
+              <a:t>Of course, having a good product is not enough; we also need a clear growth strategy. It consists of four steps. First of all, we will create inspiring content on social media that shows a real, everyday lifestyle. Next, we will work with local influencers who truly represent our brand's philosophy. After that, we will create memorable experiences, such as events, personalised kits and collaborations. Last but not least, we will actively build a community by inviting our customers to become a real part of the brand.</a:t>
             </a:r>
             <a:endParaRPr lang="en-US" dirty="0"/>
           </a:p>
@@ -1250,7 +1156,7 @@
           <a:p>
             <a:r>
               <a:rPr lang="en-US" dirty="0"/>
-              <a:t>We are looking for brands that want to grow with us. We propose a strategic partnership where our partners gain visibility, a strong position with a young audience and connection with new customers. With your support we can develop joint products and experiences, increase our reach through campaigns, and build more credibility and growth.</a:t>
+              <a:t>This brings us to our proposal. We are looking for brands that want to grow with us. What we propose is a strategic partnership in which our partners gain visibility, a stronger position among young consumers, and a connection with new audiences. With your support, we can develop joint products and experiences, increase our reach through advertising campaigns, and generate greater credibility and growth for both of us.</a:t>
             </a:r>
             <a:endParaRPr lang="en-US" dirty="0"/>
           </a:p>
@@ -1338,7 +1244,7 @@
           <a:p>
             <a:r>
               <a:rPr lang="en-US" dirty="0"/>
-              <a:t>Finally, our goals. In six months, we want to build an active community around NutriPill. In twelve months, we want to grow our digital reach and double our customer base. In the long term, we want to become a leader in the local market and expand nationwide.</a:t>
+              <a:t>Finally, we would like to share what we expect to achieve. In six months, we aim to consolidate an active community around our brand. In twelve months, we hope to increase our digital reach and double our customer base. And in the long term, our goal is to establish ourselves as a leading brand in the local market, with expansion at a national level. To sum up, NutriPill is a simple solution to a very common problem. Thank you very much for your attention. Do you have any questions?</a:t>
             </a:r>
             <a:endParaRPr lang="en-US" dirty="0"/>
           </a:p>
@@ -2235,7 +2141,7 @@
           <a:ln/>
         </p:spPr>
         <p:txBody>
-          <a:bodyPr wrap="square" lIns="0" tIns="0" rIns="0" bIns="0" rtlCol="0" anchor="ctr"/>
+          <a:bodyPr wrap="square" lIns="0" tIns="0" rIns="0" bIns="0" rtlCol="0" anchor="t"/>
           <a:lstStyle/>
           <a:p>
             <a:pPr indent="0" marL="0">
@@ -2250,7 +2156,7 @@
                 <a:ea typeface="Calibri" pitchFamily="34" charset="-122"/>
                 <a:cs typeface="Calibri" pitchFamily="34" charset="-120"/>
               </a:rPr>
-              <a:t>ENGLISH PRESENTATION  ·  BUSINESS PROPOSAL</a:t>
+              <a:t>BUSINESS PROPOSAL</a:t>
             </a:r>
             <a:endParaRPr lang="en-US" sz="1300" dirty="0"/>
           </a:p>
@@ -2274,7 +2180,7 @@
           <a:ln/>
         </p:spPr>
         <p:txBody>
-          <a:bodyPr wrap="square" lIns="0" tIns="0" rIns="0" bIns="0" rtlCol="0" anchor="ctr"/>
+          <a:bodyPr wrap="square" lIns="0" tIns="0" rIns="0" bIns="0" rtlCol="0" anchor="t"/>
           <a:lstStyle/>
           <a:p>
             <a:pPr indent="0" marL="0">
@@ -2327,7 +2233,7 @@
           <a:ln/>
         </p:spPr>
         <p:txBody>
-          <a:bodyPr wrap="square" lIns="0" tIns="0" rIns="0" bIns="0" rtlCol="0" anchor="ctr"/>
+          <a:bodyPr wrap="square" lIns="0" tIns="0" rIns="0" bIns="0" rtlCol="0" anchor="t"/>
           <a:lstStyle/>
           <a:p>
             <a:pPr indent="0" marL="0">
@@ -2342,7 +2248,7 @@
                 <a:ea typeface="Calibri" pitchFamily="34" charset="-122"/>
                 <a:cs typeface="Calibri" pitchFamily="34" charset="-120"/>
               </a:rPr>
-              <a:t>Essential nutrients. Anytime. Anywhere.</a:t>
+              <a:t>Essential nutrients for busy lives</a:t>
             </a:r>
             <a:endParaRPr lang="en-US" sz="2400" dirty="0"/>
           </a:p>
@@ -2947,474 +2853,6 @@
 </p:sld>
 </file>
 
-<file path=ppt/slides/slide10.xml><?xml version="1.0" encoding="utf-8"?>
-<p:sld xmlns:a="http://schemas.openxmlformats.org/drawingml/2006/main" xmlns:r="http://schemas.openxmlformats.org/officeDocument/2006/relationships" xmlns:p="http://schemas.openxmlformats.org/presentationml/2006/main">
-  <p:cSld name="Slide 10">
-    <p:spTree>
-      <p:nvGrpSpPr>
-        <p:cNvPr id="1" name=""/>
-        <p:cNvGrpSpPr/>
-        <p:nvPr/>
-      </p:nvGrpSpPr>
-      <p:grpSpPr>
-        <a:xfrm>
-          <a:off x="0" y="0"/>
-          <a:ext cx="0" cy="0"/>
-          <a:chOff x="0" y="0"/>
-          <a:chExt cx="0" cy="0"/>
-        </a:xfrm>
-      </p:grpSpPr>
-      <p:pic>
-        <p:nvPicPr>
-          <p:cNvPr id="2" name="a1_hero" descr="NutriPill capsule illustration">    </p:cNvPr>
-          <p:cNvPicPr>
-            <a:picLocks noChangeAspect="1"/>
-          </p:cNvPicPr>
-          <p:nvPr/>
-        </p:nvPicPr>
-        <p:blipFill>
-          <a:blip r:embed="rId1"/>
-          <a:stretch>
-            <a:fillRect/>
-          </a:stretch>
-        </p:blipFill>
-        <p:spPr>
-          <a:xfrm>
-            <a:off x="3355848" y="-182880"/>
-            <a:ext cx="5486400" cy="5486400"/>
-          </a:xfrm>
-          <a:prstGeom prst="rect">
-            <a:avLst/>
-          </a:prstGeom>
-        </p:spPr>
-      </p:pic>
-      <p:sp>
-        <p:nvSpPr>
-          <p:cNvPr id="3" name="a2_title"/>
-          <p:cNvSpPr txBox="1"/>
-          <p:nvPr/>
-        </p:nvSpPr>
-        <p:spPr>
-          <a:xfrm>
-            <a:off x="1371600" y="4160520"/>
-            <a:ext cx="9445752" cy="1005840"/>
-          </a:xfrm>
-          <a:prstGeom prst="rect">
-            <a:avLst/>
-          </a:prstGeom>
-          <a:noFill/>
-          <a:ln/>
-        </p:spPr>
-        <p:txBody>
-          <a:bodyPr wrap="square" lIns="0" tIns="0" rIns="0" bIns="0" rtlCol="0" anchor="ctr"/>
-          <a:lstStyle/>
-          <a:p>
-            <a:pPr algn="ctr" indent="0" marL="0">
-              <a:buNone/>
-            </a:pPr>
-            <a:r>
-              <a:rPr lang="en-US" sz="6000" b="1" dirty="0">
-                <a:solidFill>
-                  <a:srgbClr val="FFFFFF"/>
-                </a:solidFill>
-                <a:latin typeface="Arial Black" pitchFamily="34" charset="0"/>
-                <a:ea typeface="Arial Black" pitchFamily="34" charset="-122"/>
-                <a:cs typeface="Arial Black" pitchFamily="34" charset="-120"/>
-              </a:rPr>
-              <a:t>Thank you!</a:t>
-            </a:r>
-            <a:endParaRPr lang="en-US" sz="6000" dirty="0"/>
-          </a:p>
-        </p:txBody>
-      </p:sp>
-      <p:sp>
-        <p:nvSpPr>
-          <p:cNvPr id="4" name="a3_q"/>
-          <p:cNvSpPr txBox="1"/>
-          <p:nvPr/>
-        </p:nvSpPr>
-        <p:spPr>
-          <a:xfrm>
-            <a:off x="1371600" y="5120640"/>
-            <a:ext cx="9445752" cy="502920"/>
-          </a:xfrm>
-          <a:prstGeom prst="rect">
-            <a:avLst/>
-          </a:prstGeom>
-          <a:noFill/>
-          <a:ln/>
-        </p:spPr>
-        <p:txBody>
-          <a:bodyPr wrap="square" lIns="0" tIns="0" rIns="0" bIns="0" rtlCol="0" anchor="ctr"/>
-          <a:lstStyle/>
-          <a:p>
-            <a:pPr algn="ctr" indent="0" marL="0">
-              <a:buNone/>
-            </a:pPr>
-            <a:r>
-              <a:rPr lang="en-US" sz="2400" i="1" dirty="0">
-                <a:solidFill>
-                  <a:srgbClr val="14C9A1"/>
-                </a:solidFill>
-                <a:latin typeface="Calibri" pitchFamily="34" charset="0"/>
-                <a:ea typeface="Calibri" pitchFamily="34" charset="-122"/>
-                <a:cs typeface="Calibri" pitchFamily="34" charset="-120"/>
-              </a:rPr>
-              <a:t>Any questions?</a:t>
-            </a:r>
-            <a:endParaRPr lang="en-US" sz="2400" dirty="0"/>
-          </a:p>
-        </p:txBody>
-      </p:sp>
-      <p:pic>
-        <p:nvPicPr>
-          <p:cNvPr id="5" name="a4_logo" descr="NutriPill logo">    </p:cNvPr>
-          <p:cNvPicPr>
-            <a:picLocks noChangeAspect="1"/>
-          </p:cNvPicPr>
-          <p:nvPr/>
-        </p:nvPicPr>
-        <p:blipFill>
-          <a:blip r:embed="rId2"/>
-          <a:stretch>
-            <a:fillRect/>
-          </a:stretch>
-        </p:blipFill>
-        <p:spPr>
-          <a:xfrm>
-            <a:off x="5294376" y="5897880"/>
-            <a:ext cx="1609344" cy="448056"/>
-          </a:xfrm>
-          <a:prstGeom prst="rect">
-            <a:avLst/>
-          </a:prstGeom>
-        </p:spPr>
-      </p:pic>
-    </p:spTree>
-  </p:cSld>
-  <p:clrMapOvr>
-    <a:masterClrMapping/>
-  </p:clrMapOvr>
-  <p:transition spd="slow">
-    <p:push dir="u"/>
-  </p:transition>
-  <p:timing>
-    <p:tnLst>
-      <p:par>
-        <p:cTn id="1" dur="indefinite" restart="never" nodeType="tmRoot">
-          <p:childTnLst>
-            <p:seq concurrent="1" nextAc="seek">
-              <p:cTn id="2" dur="indefinite" nodeType="mainSeq">
-                <p:childTnLst>
-                  <p:par>
-                    <p:cTn id="23" fill="hold">
-                      <p:stCondLst>
-                        <p:cond delay="indefinite"/>
-                        <p:cond evt="onBegin" delay="0">
-                          <p:tn val="2"/>
-                        </p:cond>
-                      </p:stCondLst>
-                      <p:childTnLst>
-                        <p:par>
-                          <p:cTn id="3" fill="hold">
-                            <p:stCondLst>
-                              <p:cond delay="0"/>
-                            </p:stCondLst>
-                            <p:childTnLst>
-                              <p:par>
-                                <p:cTn id="4" presetID="42" presetClass="entr" presetSubtype="0" fill="hold" grpId="0" nodeType="afterEffect">
-                                  <p:stCondLst>
-                                    <p:cond delay="0"/>
-                                  </p:stCondLst>
-                                  <p:childTnLst>
-                                    <p:set>
-                                      <p:cBhvr>
-                                        <p:cTn id="5" dur="1" fill="hold">
-                                          <p:stCondLst>
-                                            <p:cond delay="0"/>
-                                          </p:stCondLst>
-                                        </p:cTn>
-                                        <p:tgtEl>
-                                          <p:spTgt spid="2"/>
-                                        </p:tgtEl>
-                                        <p:attrNameLst>
-                                          <p:attrName>style.visibility</p:attrName>
-                                        </p:attrNameLst>
-                                      </p:cBhvr>
-                                      <p:to>
-                                        <p:strVal val="visible"/>
-                                      </p:to>
-                                    </p:set>
-                                    <p:animEffect transition="in" filter="fade">
-                                      <p:cBhvr>
-                                        <p:cTn id="6" dur="600"/>
-                                        <p:tgtEl>
-                                          <p:spTgt spid="2"/>
-                                        </p:tgtEl>
-                                      </p:cBhvr>
-                                    </p:animEffect>
-                                    <p:anim calcmode="lin" valueType="num">
-                                      <p:cBhvr>
-                                        <p:cTn id="7" dur="600" decel="100000" fill="hold"/>
-                                        <p:tgtEl>
-                                          <p:spTgt spid="2"/>
-                                        </p:tgtEl>
-                                        <p:attrNameLst>
-                                          <p:attrName>ppt_y</p:attrName>
-                                        </p:attrNameLst>
-                                      </p:cBhvr>
-                                      <p:tavLst>
-                                        <p:tav tm="0">
-                                          <p:val>
-                                            <p:strVal val="#ppt_y+0.04"/>
-                                          </p:val>
-                                        </p:tav>
-                                        <p:tav tm="100000">
-                                          <p:val>
-                                            <p:strVal val="#ppt_y"/>
-                                          </p:val>
-                                        </p:tav>
-                                      </p:tavLst>
-                                    </p:anim>
-                                  </p:childTnLst>
-                                </p:cTn>
-                              </p:par>
-                            </p:childTnLst>
-                          </p:cTn>
-                        </p:par>
-                        <p:par>
-                          <p:cTn id="8" fill="hold">
-                            <p:stCondLst>
-                              <p:cond delay="0"/>
-                            </p:stCondLst>
-                            <p:childTnLst>
-                              <p:par>
-                                <p:cTn id="9" presetID="42" presetClass="entr" presetSubtype="0" fill="hold" grpId="0" nodeType="afterEffect">
-                                  <p:stCondLst>
-                                    <p:cond delay="0"/>
-                                  </p:stCondLst>
-                                  <p:childTnLst>
-                                    <p:set>
-                                      <p:cBhvr>
-                                        <p:cTn id="10" dur="1" fill="hold">
-                                          <p:stCondLst>
-                                            <p:cond delay="0"/>
-                                          </p:stCondLst>
-                                        </p:cTn>
-                                        <p:tgtEl>
-                                          <p:spTgt spid="3"/>
-                                        </p:tgtEl>
-                                        <p:attrNameLst>
-                                          <p:attrName>style.visibility</p:attrName>
-                                        </p:attrNameLst>
-                                      </p:cBhvr>
-                                      <p:to>
-                                        <p:strVal val="visible"/>
-                                      </p:to>
-                                    </p:set>
-                                    <p:animEffect transition="in" filter="fade">
-                                      <p:cBhvr>
-                                        <p:cTn id="11" dur="600"/>
-                                        <p:tgtEl>
-                                          <p:spTgt spid="3"/>
-                                        </p:tgtEl>
-                                      </p:cBhvr>
-                                    </p:animEffect>
-                                    <p:anim calcmode="lin" valueType="num">
-                                      <p:cBhvr>
-                                        <p:cTn id="12" dur="600" decel="100000" fill="hold"/>
-                                        <p:tgtEl>
-                                          <p:spTgt spid="3"/>
-                                        </p:tgtEl>
-                                        <p:attrNameLst>
-                                          <p:attrName>ppt_y</p:attrName>
-                                        </p:attrNameLst>
-                                      </p:cBhvr>
-                                      <p:tavLst>
-                                        <p:tav tm="0">
-                                          <p:val>
-                                            <p:strVal val="#ppt_y+0.04"/>
-                                          </p:val>
-                                        </p:tav>
-                                        <p:tav tm="100000">
-                                          <p:val>
-                                            <p:strVal val="#ppt_y"/>
-                                          </p:val>
-                                        </p:tav>
-                                      </p:tavLst>
-                                    </p:anim>
-                                  </p:childTnLst>
-                                </p:cTn>
-                              </p:par>
-                            </p:childTnLst>
-                          </p:cTn>
-                        </p:par>
-                        <p:par>
-                          <p:cTn id="13" fill="hold">
-                            <p:stCondLst>
-                              <p:cond delay="0"/>
-                            </p:stCondLst>
-                            <p:childTnLst>
-                              <p:par>
-                                <p:cTn id="14" presetID="42" presetClass="entr" presetSubtype="0" fill="hold" grpId="0" nodeType="afterEffect">
-                                  <p:stCondLst>
-                                    <p:cond delay="0"/>
-                                  </p:stCondLst>
-                                  <p:childTnLst>
-                                    <p:set>
-                                      <p:cBhvr>
-                                        <p:cTn id="15" dur="1" fill="hold">
-                                          <p:stCondLst>
-                                            <p:cond delay="0"/>
-                                          </p:stCondLst>
-                                        </p:cTn>
-                                        <p:tgtEl>
-                                          <p:spTgt spid="4"/>
-                                        </p:tgtEl>
-                                        <p:attrNameLst>
-                                          <p:attrName>style.visibility</p:attrName>
-                                        </p:attrNameLst>
-                                      </p:cBhvr>
-                                      <p:to>
-                                        <p:strVal val="visible"/>
-                                      </p:to>
-                                    </p:set>
-                                    <p:animEffect transition="in" filter="fade">
-                                      <p:cBhvr>
-                                        <p:cTn id="16" dur="600"/>
-                                        <p:tgtEl>
-                                          <p:spTgt spid="4"/>
-                                        </p:tgtEl>
-                                      </p:cBhvr>
-                                    </p:animEffect>
-                                    <p:anim calcmode="lin" valueType="num">
-                                      <p:cBhvr>
-                                        <p:cTn id="17" dur="600" decel="100000" fill="hold"/>
-                                        <p:tgtEl>
-                                          <p:spTgt spid="4"/>
-                                        </p:tgtEl>
-                                        <p:attrNameLst>
-                                          <p:attrName>ppt_y</p:attrName>
-                                        </p:attrNameLst>
-                                      </p:cBhvr>
-                                      <p:tavLst>
-                                        <p:tav tm="0">
-                                          <p:val>
-                                            <p:strVal val="#ppt_y+0.04"/>
-                                          </p:val>
-                                        </p:tav>
-                                        <p:tav tm="100000">
-                                          <p:val>
-                                            <p:strVal val="#ppt_y"/>
-                                          </p:val>
-                                        </p:tav>
-                                      </p:tavLst>
-                                    </p:anim>
-                                  </p:childTnLst>
-                                </p:cTn>
-                              </p:par>
-                            </p:childTnLst>
-                          </p:cTn>
-                        </p:par>
-                        <p:par>
-                          <p:cTn id="18" fill="hold">
-                            <p:stCondLst>
-                              <p:cond delay="0"/>
-                            </p:stCondLst>
-                            <p:childTnLst>
-                              <p:par>
-                                <p:cTn id="19" presetID="42" presetClass="entr" presetSubtype="0" fill="hold" grpId="0" nodeType="afterEffect">
-                                  <p:stCondLst>
-                                    <p:cond delay="0"/>
-                                  </p:stCondLst>
-                                  <p:childTnLst>
-                                    <p:set>
-                                      <p:cBhvr>
-                                        <p:cTn id="20" dur="1" fill="hold">
-                                          <p:stCondLst>
-                                            <p:cond delay="0"/>
-                                          </p:stCondLst>
-                                        </p:cTn>
-                                        <p:tgtEl>
-                                          <p:spTgt spid="5"/>
-                                        </p:tgtEl>
-                                        <p:attrNameLst>
-                                          <p:attrName>style.visibility</p:attrName>
-                                        </p:attrNameLst>
-                                      </p:cBhvr>
-                                      <p:to>
-                                        <p:strVal val="visible"/>
-                                      </p:to>
-                                    </p:set>
-                                    <p:animEffect transition="in" filter="fade">
-                                      <p:cBhvr>
-                                        <p:cTn id="21" dur="600"/>
-                                        <p:tgtEl>
-                                          <p:spTgt spid="5"/>
-                                        </p:tgtEl>
-                                      </p:cBhvr>
-                                    </p:animEffect>
-                                    <p:anim calcmode="lin" valueType="num">
-                                      <p:cBhvr>
-                                        <p:cTn id="22" dur="600" decel="100000" fill="hold"/>
-                                        <p:tgtEl>
-                                          <p:spTgt spid="5"/>
-                                        </p:tgtEl>
-                                        <p:attrNameLst>
-                                          <p:attrName>ppt_y</p:attrName>
-                                        </p:attrNameLst>
-                                      </p:cBhvr>
-                                      <p:tavLst>
-                                        <p:tav tm="0">
-                                          <p:val>
-                                            <p:strVal val="#ppt_y+0.04"/>
-                                          </p:val>
-                                        </p:tav>
-                                        <p:tav tm="100000">
-                                          <p:val>
-                                            <p:strVal val="#ppt_y"/>
-                                          </p:val>
-                                        </p:tav>
-                                      </p:tavLst>
-                                    </p:anim>
-                                  </p:childTnLst>
-                                </p:cTn>
-                              </p:par>
-                            </p:childTnLst>
-                          </p:cTn>
-                        </p:par>
-                      </p:childTnLst>
-                    </p:cTn>
-                  </p:par>
-                </p:childTnLst>
-              </p:cTn>
-              <p:prevCondLst>
-                <p:cond evt="onPrev" delay="0">
-                  <p:tgtEl>
-                    <p:sldTgt/>
-                  </p:tgtEl>
-                </p:cond>
-              </p:prevCondLst>
-              <p:nextCondLst>
-                <p:cond evt="onNext" delay="0">
-                  <p:tgtEl>
-                    <p:sldTgt/>
-                  </p:tgtEl>
-                </p:cond>
-              </p:nextCondLst>
-            </p:seq>
-          </p:childTnLst>
-        </p:cTn>
-      </p:par>
-    </p:tnLst>
-    <p:bldLst>
-      <p:bldP spid="3" grpId="0" animBg="1"/>
-      <p:bldP spid="4" grpId="0" animBg="1"/>
-    </p:bldLst>
-  </p:timing>
-</p:sld>
-</file>
-
 <file path=ppt/slides/slide2.xml><?xml version="1.0" encoding="utf-8"?>
 <p:sld xmlns:a="http://schemas.openxmlformats.org/drawingml/2006/main" xmlns:r="http://schemas.openxmlformats.org/officeDocument/2006/relationships" xmlns:p="http://schemas.openxmlformats.org/presentationml/2006/main">
   <p:cSld name="Slide 2">
@@ -3464,7 +2902,7 @@
                   <a:schemeClr val="accent1"/>
                 </a:solidFill>
               </a:rPr>
-              <a:t>INTRODUCTION</a:t>
+              <a:t>01 / 08</a:t>
             </a:r>
             <a:endParaRPr lang="en-US" sz="1300" dirty="0"/>
           </a:p>
@@ -3505,7 +2943,7 @@
                 <a:ea typeface="Arial Black" pitchFamily="34" charset="-122"/>
                 <a:cs typeface="Arial Black" pitchFamily="34" charset="-120"/>
               </a:rPr>
-              <a:t>Have you ever been too busy to eat?</a:t>
+              <a:t>Introduction</a:t>
             </a:r>
             <a:endParaRPr lang="en-US" sz="3600" dirty="0"/>
           </a:p>
@@ -3537,14 +2975,14 @@
       </p:pic>
       <p:sp>
         <p:nvSpPr>
-          <p:cNvPr id="5" name="a2_text"/>
+          <p:cNvPr id="5" name="a2_q"/>
           <p:cNvSpPr txBox="1"/>
           <p:nvPr/>
         </p:nvSpPr>
         <p:spPr>
           <a:xfrm>
-            <a:off x="548640" y="2057400"/>
-            <a:ext cx="6309360" cy="1188720"/>
+            <a:off x="548640" y="1874520"/>
+            <a:ext cx="6400800" cy="914400"/>
           </a:xfrm>
           <a:prstGeom prst="rect">
             <a:avLst/>
@@ -3553,14 +2991,14 @@
           <a:ln/>
         </p:spPr>
         <p:txBody>
-          <a:bodyPr wrap="square" lIns="0" tIns="0" rIns="0" bIns="0" rtlCol="0" anchor="ctr"/>
+          <a:bodyPr wrap="square" lIns="0" tIns="0" rIns="0" bIns="0" rtlCol="0" anchor="t"/>
           <a:lstStyle/>
           <a:p>
             <a:pPr indent="0" marL="0">
               <a:buNone/>
             </a:pPr>
             <a:r>
-              <a:rPr lang="en-US" sz="2400" dirty="0">
+              <a:rPr lang="en-US" sz="2400" b="1" dirty="0">
                 <a:solidFill>
                   <a:srgbClr val="0B1F3A"/>
                 </a:solidFill>
@@ -3568,7 +3006,7 @@
                 <a:ea typeface="Calibri" pitchFamily="34" charset="-122"/>
                 <a:cs typeface="Calibri" pitchFamily="34" charset="-120"/>
               </a:rPr>
-              <a:t>Imagine a pill that provides essential nutrients when you don't have time for a meal.</a:t>
+              <a:t>Have you ever been so busy that you simply didn't have time to eat?</a:t>
             </a:r>
             <a:endParaRPr lang="en-US" sz="2400" dirty="0"/>
           </a:p>
@@ -3576,18 +3014,57 @@
       </p:sp>
       <p:sp>
         <p:nvSpPr>
-          <p:cNvPr id="6" name="a3_card"/>
+          <p:cNvPr id="6" name="a2_text"/>
+          <p:cNvSpPr txBox="1"/>
+          <p:nvPr/>
+        </p:nvSpPr>
+        <p:spPr>
+          <a:xfrm>
+            <a:off x="548640" y="2788920"/>
+            <a:ext cx="6400800" cy="822960"/>
+          </a:xfrm>
+          <a:prstGeom prst="rect">
+            <a:avLst/>
+          </a:prstGeom>
+          <a:noFill/>
+          <a:ln/>
+        </p:spPr>
+        <p:txBody>
+          <a:bodyPr wrap="square" lIns="0" tIns="0" rIns="0" bIns="0" rtlCol="0" anchor="t"/>
+          <a:lstStyle/>
+          <a:p>
+            <a:pPr indent="0" marL="0">
+              <a:buNone/>
+            </a:pPr>
+            <a:r>
+              <a:rPr lang="en-US" sz="1800" dirty="0">
+                <a:solidFill>
+                  <a:srgbClr val="5B6B80"/>
+                </a:solidFill>
+                <a:latin typeface="Calibri" pitchFamily="34" charset="0"/>
+                <a:ea typeface="Calibri" pitchFamily="34" charset="-122"/>
+                <a:cs typeface="Calibri" pitchFamily="34" charset="-120"/>
+              </a:rPr>
+              <a:t>Imagine a pill that could give your body the essential nutrients it needs on those days when there is no time for a proper meal.</a:t>
+            </a:r>
+            <a:endParaRPr lang="en-US" sz="1800" dirty="0"/>
+          </a:p>
+        </p:txBody>
+      </p:sp>
+      <p:sp>
+        <p:nvSpPr>
+          <p:cNvPr id="7" name="a3_card"/>
           <p:cNvSpPr/>
           <p:nvPr/>
         </p:nvSpPr>
         <p:spPr>
           <a:xfrm>
-            <a:off x="548640" y="3611880"/>
-            <a:ext cx="6309360" cy="2331720"/>
+            <a:off x="548640" y="3840480"/>
+            <a:ext cx="6400800" cy="2286000"/>
           </a:xfrm>
           <a:prstGeom prst="roundRect">
             <a:avLst>
-              <a:gd name="adj" fmla="val 7059"/>
+              <a:gd name="adj" fmla="val 7200"/>
             </a:avLst>
           </a:prstGeom>
           <a:solidFill>
@@ -3605,7 +3082,7 @@
       </p:sp>
       <p:pic>
         <p:nvPicPr>
-          <p:cNvPr id="7" name="a3_logo" descr="NutriPill logo">    </p:cNvPr>
+          <p:cNvPr id="8" name="a3_logo" descr="NutriPill logo">    </p:cNvPr>
           <p:cNvPicPr>
             <a:picLocks noChangeAspect="1"/>
           </p:cNvPicPr>
@@ -3619,7 +3096,7 @@
         </p:blipFill>
         <p:spPr>
           <a:xfrm>
-            <a:off x="868680" y="3886200"/>
+            <a:off x="868680" y="4069080"/>
             <a:ext cx="1975104" cy="548640"/>
           </a:xfrm>
           <a:prstGeom prst="rect">
@@ -3629,14 +3106,14 @@
       </p:pic>
       <p:sp>
         <p:nvSpPr>
-          <p:cNvPr id="8" name="a3_text"/>
+          <p:cNvPr id="9" name="a3_text"/>
           <p:cNvSpPr txBox="1"/>
           <p:nvPr/>
         </p:nvSpPr>
         <p:spPr>
           <a:xfrm>
-            <a:off x="868680" y="4526280"/>
-            <a:ext cx="5669280" cy="685800"/>
+            <a:off x="868680" y="4663440"/>
+            <a:ext cx="5806440" cy="731520"/>
           </a:xfrm>
           <a:prstGeom prst="rect">
             <a:avLst/>
@@ -3645,14 +3122,14 @@
           <a:ln/>
         </p:spPr>
         <p:txBody>
-          <a:bodyPr wrap="square" lIns="0" tIns="0" rIns="0" bIns="0" rtlCol="0" anchor="ctr"/>
+          <a:bodyPr wrap="square" lIns="0" tIns="0" rIns="0" bIns="0" rtlCol="0" anchor="t"/>
           <a:lstStyle/>
           <a:p>
             <a:pPr indent="0" marL="0">
               <a:buNone/>
             </a:pPr>
             <a:r>
-              <a:rPr lang="en-US" sz="1600" dirty="0">
+              <a:rPr lang="en-US" sz="1500" dirty="0">
                 <a:solidFill>
                   <a:srgbClr val="5B6B80"/>
                 </a:solidFill>
@@ -3660,21 +3137,21 @@
                 <a:ea typeface="Calibri" pitchFamily="34" charset="-122"/>
                 <a:cs typeface="Calibri" pitchFamily="34" charset="-120"/>
               </a:rPr>
-              <a:t>A convenient way to get essential nutrients on the go — designed for your busy lifestyle.</a:t>
+              <a:t>Meet NutriPill: a convenient way to get essential nutrients on the go. Small, simple, and designed to fit perfectly into your busy lifestyle.</a:t>
             </a:r>
-            <a:endParaRPr lang="en-US" sz="1600" dirty="0"/>
+            <a:endParaRPr lang="en-US" sz="1500" dirty="0"/>
           </a:p>
         </p:txBody>
       </p:sp>
       <p:sp>
         <p:nvSpPr>
-          <p:cNvPr id="9" name="a4_chip"/>
+          <p:cNvPr id="10" name="a4_chip"/>
           <p:cNvSpPr/>
           <p:nvPr/>
         </p:nvSpPr>
         <p:spPr>
           <a:xfrm>
-            <a:off x="868680" y="5303520"/>
+            <a:off x="868680" y="5486400"/>
             <a:ext cx="1234440" cy="411480"/>
           </a:xfrm>
           <a:prstGeom prst="roundRect">
@@ -3690,13 +3167,13 @@
       </p:sp>
       <p:sp>
         <p:nvSpPr>
-          <p:cNvPr id="10" name="a4_chiptext"/>
+          <p:cNvPr id="11" name="a4_chiptext"/>
           <p:cNvSpPr txBox="1"/>
           <p:nvPr/>
         </p:nvSpPr>
         <p:spPr>
           <a:xfrm>
-            <a:off x="868680" y="5303520"/>
+            <a:off x="868680" y="5486400"/>
             <a:ext cx="1234440" cy="411480"/>
           </a:xfrm>
           <a:prstGeom prst="rect">
@@ -3729,13 +3206,13 @@
       </p:sp>
       <p:sp>
         <p:nvSpPr>
-          <p:cNvPr id="11" name="a5_chip"/>
+          <p:cNvPr id="12" name="a5_chip"/>
           <p:cNvSpPr/>
           <p:nvPr/>
         </p:nvSpPr>
         <p:spPr>
           <a:xfrm>
-            <a:off x="2240280" y="5303520"/>
+            <a:off x="2240280" y="5486400"/>
             <a:ext cx="1234440" cy="411480"/>
           </a:xfrm>
           <a:prstGeom prst="roundRect">
@@ -3751,13 +3228,13 @@
       </p:sp>
       <p:sp>
         <p:nvSpPr>
-          <p:cNvPr id="12" name="a5_chiptext"/>
+          <p:cNvPr id="13" name="a5_chiptext"/>
           <p:cNvSpPr txBox="1"/>
           <p:nvPr/>
         </p:nvSpPr>
         <p:spPr>
           <a:xfrm>
-            <a:off x="2240280" y="5303520"/>
+            <a:off x="2240280" y="5486400"/>
             <a:ext cx="1234440" cy="411480"/>
           </a:xfrm>
           <a:prstGeom prst="rect">
@@ -3790,13 +3267,13 @@
       </p:sp>
       <p:sp>
         <p:nvSpPr>
-          <p:cNvPr id="13" name="a6_chip"/>
+          <p:cNvPr id="14" name="a6_chip"/>
           <p:cNvSpPr/>
           <p:nvPr/>
         </p:nvSpPr>
         <p:spPr>
           <a:xfrm>
-            <a:off x="3611880" y="5303520"/>
+            <a:off x="3611880" y="5486400"/>
             <a:ext cx="1234440" cy="411480"/>
           </a:xfrm>
           <a:prstGeom prst="roundRect">
@@ -3812,13 +3289,13 @@
       </p:sp>
       <p:sp>
         <p:nvSpPr>
-          <p:cNvPr id="14" name="a6_chiptext"/>
+          <p:cNvPr id="15" name="a6_chiptext"/>
           <p:cNvSpPr txBox="1"/>
           <p:nvPr/>
         </p:nvSpPr>
         <p:spPr>
           <a:xfrm>
-            <a:off x="3611880" y="5303520"/>
+            <a:off x="3611880" y="5486400"/>
             <a:ext cx="1234440" cy="411480"/>
           </a:xfrm>
           <a:prstGeom prst="rect">
@@ -3911,7 +3388,7 @@
               <p:cTn id="2" dur="indefinite" nodeType="mainSeq">
                 <p:childTnLst>
                   <p:par>
-                    <p:cTn id="68" fill="hold">
+                    <p:cTn id="73" fill="hold">
                       <p:stCondLst>
                         <p:cond delay="indefinite"/>
                         <p:cond evt="onBegin" delay="0">
@@ -4194,7 +3671,7 @@
                             </p:stCondLst>
                             <p:childTnLst>
                               <p:par>
-                                <p:cTn id="24" presetID="42" presetClass="entr" presetSubtype="0" fill="hold" grpId="0" nodeType="afterEffect">
+                                <p:cTn id="24" presetID="42" presetClass="entr" presetSubtype="0" fill="hold" grpId="0" nodeType="withEffect">
                                   <p:stCondLst>
                                     <p:cond delay="0"/>
                                   </p:stCondLst>
@@ -4261,7 +3738,7 @@
                             </p:stCondLst>
                             <p:childTnLst>
                               <p:par>
-                                <p:cTn id="29" presetID="42" presetClass="entr" presetSubtype="0" fill="hold" grpId="0" nodeType="withEffect">
+                                <p:cTn id="29" presetID="42" presetClass="entr" presetSubtype="0" fill="hold" grpId="0" nodeType="afterEffect">
                                   <p:stCondLst>
                                     <p:cond delay="0"/>
                                   </p:stCondLst>
@@ -4395,7 +3872,7 @@
                             </p:stCondLst>
                             <p:childTnLst>
                               <p:par>
-                                <p:cTn id="39" presetID="42" presetClass="entr" presetSubtype="0" fill="hold" grpId="0" nodeType="afterEffect">
+                                <p:cTn id="39" presetID="42" presetClass="entr" presetSubtype="0" fill="hold" grpId="0" nodeType="withEffect">
                                   <p:stCondLst>
                                     <p:cond delay="0"/>
                                   </p:stCondLst>
@@ -4462,7 +3939,7 @@
                             </p:stCondLst>
                             <p:childTnLst>
                               <p:par>
-                                <p:cTn id="44" presetID="42" presetClass="entr" presetSubtype="0" fill="hold" grpId="0" nodeType="withEffect">
+                                <p:cTn id="44" presetID="42" presetClass="entr" presetSubtype="0" fill="hold" grpId="0" nodeType="afterEffect">
                                   <p:stCondLst>
                                     <p:cond delay="0"/>
                                   </p:stCondLst>
@@ -4529,7 +4006,7 @@
                             </p:stCondLst>
                             <p:childTnLst>
                               <p:par>
-                                <p:cTn id="49" presetID="42" presetClass="entr" presetSubtype="0" fill="hold" grpId="0" nodeType="afterEffect">
+                                <p:cTn id="49" presetID="42" presetClass="entr" presetSubtype="0" fill="hold" grpId="0" nodeType="withEffect">
                                   <p:stCondLst>
                                     <p:cond delay="0"/>
                                   </p:stCondLst>
@@ -4596,7 +4073,7 @@
                             </p:stCondLst>
                             <p:childTnLst>
                               <p:par>
-                                <p:cTn id="54" presetID="42" presetClass="entr" presetSubtype="0" fill="hold" grpId="0" nodeType="withEffect">
+                                <p:cTn id="54" presetID="42" presetClass="entr" presetSubtype="0" fill="hold" grpId="0" nodeType="afterEffect">
                                   <p:stCondLst>
                                     <p:cond delay="0"/>
                                   </p:stCondLst>
@@ -4663,7 +4140,7 @@
                             </p:stCondLst>
                             <p:childTnLst>
                               <p:par>
-                                <p:cTn id="59" presetID="42" presetClass="entr" presetSubtype="0" fill="hold" grpId="0" nodeType="afterEffect">
+                                <p:cTn id="59" presetID="42" presetClass="entr" presetSubtype="0" fill="hold" grpId="0" nodeType="withEffect">
                                   <p:stCondLst>
                                     <p:cond delay="0"/>
                                   </p:stCondLst>
@@ -4730,7 +4207,7 @@
                             </p:stCondLst>
                             <p:childTnLst>
                               <p:par>
-                                <p:cTn id="64" presetID="42" presetClass="entr" presetSubtype="0" fill="hold" grpId="0" nodeType="withEffect">
+                                <p:cTn id="64" presetID="42" presetClass="entr" presetSubtype="0" fill="hold" grpId="0" nodeType="afterEffect">
                                   <p:stCondLst>
                                     <p:cond delay="0"/>
                                   </p:stCondLst>
@@ -4766,6 +4243,73 @@
                                         <p:cTn id="67" dur="600" decel="100000" fill="hold"/>
                                         <p:tgtEl>
                                           <p:spTgt spid="14"/>
+                                        </p:tgtEl>
+                                        <p:attrNameLst>
+                                          <p:attrName>ppt_y</p:attrName>
+                                        </p:attrNameLst>
+                                      </p:cBhvr>
+                                      <p:tavLst>
+                                        <p:tav tm="0">
+                                          <p:val>
+                                            <p:strVal val="#ppt_y+0.04"/>
+                                          </p:val>
+                                        </p:tav>
+                                        <p:tav tm="100000">
+                                          <p:val>
+                                            <p:strVal val="#ppt_y"/>
+                                          </p:val>
+                                        </p:tav>
+                                      </p:tavLst>
+                                    </p:anim>
+                                  </p:childTnLst>
+                                </p:cTn>
+                              </p:par>
+                            </p:childTnLst>
+                          </p:cTn>
+                        </p:par>
+                        <p:par>
+                          <p:cTn id="68" fill="hold">
+                            <p:stCondLst>
+                              <p:cond delay="0"/>
+                            </p:stCondLst>
+                            <p:childTnLst>
+                              <p:par>
+                                <p:cTn id="69" presetID="42" presetClass="entr" presetSubtype="0" fill="hold" grpId="0" nodeType="withEffect">
+                                  <p:stCondLst>
+                                    <p:cond delay="0"/>
+                                  </p:stCondLst>
+                                  <p:childTnLst>
+                                    <p:set>
+                                      <p:cBhvr>
+                                        <p:cTn id="70" dur="1" fill="hold">
+                                          <p:stCondLst>
+                                            <p:cond delay="0"/>
+                                          </p:stCondLst>
+                                        </p:cTn>
+                                        <p:tgtEl>
+                                          <p:spTgt spid="15"/>
+                                        </p:tgtEl>
+                                        <p:attrNameLst>
+                                          <p:attrName>style.visibility</p:attrName>
+                                        </p:attrNameLst>
+                                      </p:cBhvr>
+                                      <p:to>
+                                        <p:strVal val="visible"/>
+                                      </p:to>
+                                    </p:set>
+                                    <p:animEffect transition="in" filter="fade">
+                                      <p:cBhvr>
+                                        <p:cTn id="71" dur="600"/>
+                                        <p:tgtEl>
+                                          <p:spTgt spid="15"/>
+                                        </p:tgtEl>
+                                      </p:cBhvr>
+                                    </p:animEffect>
+                                    <p:anim calcmode="lin" valueType="num">
+                                      <p:cBhvr>
+                                        <p:cTn id="72" dur="600" decel="100000" fill="hold"/>
+                                        <p:tgtEl>
+                                          <p:spTgt spid="15"/>
                                         </p:tgtEl>
                                         <p:attrNameLst>
                                           <p:attrName>ppt_y</p:attrName>
@@ -4819,13 +4363,14 @@
       <p:bldP spid="3" grpId="0" animBg="1"/>
       <p:bldP spid="5" grpId="0" animBg="1"/>
       <p:bldP spid="6" grpId="0" animBg="1"/>
-      <p:bldP spid="8" grpId="0" animBg="1"/>
+      <p:bldP spid="7" grpId="0" animBg="1"/>
       <p:bldP spid="9" grpId="0" animBg="1"/>
       <p:bldP spid="10" grpId="0" animBg="1"/>
       <p:bldP spid="11" grpId="0" animBg="1"/>
       <p:bldP spid="12" grpId="0" animBg="1"/>
       <p:bldP spid="13" grpId="0" animBg="1"/>
       <p:bldP spid="14" grpId="0" animBg="1"/>
+      <p:bldP spid="15" grpId="0" animBg="1"/>
     </p:bldLst>
   </p:timing>
 </p:sld>
@@ -4880,7 +4425,7 @@
                   <a:schemeClr val="accent1"/>
                 </a:solidFill>
               </a:rPr>
-              <a:t>THE PROBLEM</a:t>
+              <a:t>02 / 08</a:t>
             </a:r>
             <a:endParaRPr lang="en-US" sz="1300" dirty="0"/>
           </a:p>
@@ -4921,7 +4466,7 @@
                 <a:ea typeface="Arial Black" pitchFamily="34" charset="-122"/>
                 <a:cs typeface="Arial Black" pitchFamily="34" charset="-120"/>
               </a:rPr>
-              <a:t>No time to eat properly</a:t>
+              <a:t>The Problem</a:t>
             </a:r>
             <a:endParaRPr lang="en-US" sz="3600" dirty="0"/>
           </a:p>
@@ -4935,8 +4480,8 @@
         </p:nvSpPr>
         <p:spPr>
           <a:xfrm>
-            <a:off x="548640" y="1920240"/>
-            <a:ext cx="7772400" cy="822960"/>
+            <a:off x="548640" y="1783080"/>
+            <a:ext cx="10515600" cy="960120"/>
           </a:xfrm>
           <a:prstGeom prst="rect">
             <a:avLst/>
@@ -4945,14 +4490,14 @@
           <a:ln/>
         </p:spPr>
         <p:txBody>
-          <a:bodyPr wrap="square" lIns="0" tIns="0" rIns="0" bIns="0" rtlCol="0" anchor="ctr"/>
+          <a:bodyPr wrap="square" lIns="0" tIns="0" rIns="0" bIns="0" rtlCol="0" anchor="t"/>
           <a:lstStyle/>
           <a:p>
             <a:pPr indent="0" marL="0">
               <a:buNone/>
             </a:pPr>
             <a:r>
-              <a:rPr lang="en-US" sz="2000" dirty="0">
+              <a:rPr lang="en-US" sz="1800" dirty="0">
                 <a:solidFill>
                   <a:srgbClr val="B8C7D9"/>
                 </a:solidFill>
@@ -4960,9 +4505,9 @@
                 <a:ea typeface="Calibri" pitchFamily="34" charset="-122"/>
                 <a:cs typeface="Calibri" pitchFamily="34" charset="-120"/>
               </a:rPr>
-              <a:t>Busy schedules mean many students and workers skip meals because they are always in a hurry.</a:t>
+              <a:t>Nowadays, many people have such busy schedules that they don't have enough time to prepare or eat proper meals. Students and workers, in particular, often skip meals because they are always in a hurry.</a:t>
             </a:r>
-            <a:endParaRPr lang="en-US" sz="2000" dirty="0"/>
+            <a:endParaRPr lang="en-US" sz="1800" dirty="0"/>
           </a:p>
         </p:txBody>
       </p:sp>
@@ -4974,12 +4519,12 @@
         </p:nvSpPr>
         <p:spPr>
           <a:xfrm>
-            <a:off x="548640" y="3017520"/>
-            <a:ext cx="3474720" cy="2240280"/>
+            <a:off x="548640" y="2971800"/>
+            <a:ext cx="3474720" cy="2331720"/>
           </a:xfrm>
           <a:prstGeom prst="roundRect">
             <a:avLst>
-              <a:gd name="adj" fmla="val 7347"/>
+              <a:gd name="adj" fmla="val 7059"/>
             </a:avLst>
           </a:prstGeom>
           <a:solidFill>
@@ -5005,7 +4550,7 @@
         </p:nvSpPr>
         <p:spPr>
           <a:xfrm>
-            <a:off x="868680" y="3291840"/>
+            <a:off x="868680" y="3200400"/>
             <a:ext cx="731520" cy="731520"/>
           </a:xfrm>
           <a:prstGeom prst="ellipse">
@@ -5033,7 +4578,7 @@
         </p:blipFill>
         <p:spPr>
           <a:xfrm>
-            <a:off x="1066190" y="3489350"/>
+            <a:off x="1066190" y="3397910"/>
             <a:ext cx="336499" cy="336499"/>
           </a:xfrm>
           <a:prstGeom prst="rect">
@@ -5049,8 +4594,8 @@
         </p:nvSpPr>
         <p:spPr>
           <a:xfrm>
-            <a:off x="868680" y="4160520"/>
-            <a:ext cx="2834640" cy="411480"/>
+            <a:off x="868680" y="4069080"/>
+            <a:ext cx="2926080" cy="411480"/>
           </a:xfrm>
           <a:prstGeom prst="rect">
             <a:avLst/>
@@ -5059,14 +4604,14 @@
           <a:ln/>
         </p:spPr>
         <p:txBody>
-          <a:bodyPr wrap="square" lIns="0" tIns="0" rIns="0" bIns="0" rtlCol="0" anchor="ctr"/>
+          <a:bodyPr wrap="square" lIns="0" tIns="0" rIns="0" bIns="0" rtlCol="0" anchor="t"/>
           <a:lstStyle/>
           <a:p>
             <a:pPr indent="0" marL="0">
               <a:buNone/>
             </a:pPr>
             <a:r>
-              <a:rPr lang="en-US" sz="2000" b="1" dirty="0">
+              <a:rPr lang="en-US" sz="1900" b="1" dirty="0">
                 <a:solidFill>
                   <a:srgbClr val="FFFFFF"/>
                 </a:solidFill>
@@ -5076,7 +4621,7 @@
               </a:rPr>
               <a:t>Low energy</a:t>
             </a:r>
-            <a:endParaRPr lang="en-US" sz="2000" dirty="0"/>
+            <a:endParaRPr lang="en-US" sz="1900" dirty="0"/>
           </a:p>
         </p:txBody>
       </p:sp>
@@ -5088,8 +4633,8 @@
         </p:nvSpPr>
         <p:spPr>
           <a:xfrm>
-            <a:off x="868680" y="4572000"/>
-            <a:ext cx="2834640" cy="594360"/>
+            <a:off x="868680" y="4480560"/>
+            <a:ext cx="2880360" cy="731520"/>
           </a:xfrm>
           <a:prstGeom prst="rect">
             <a:avLst/>
@@ -5098,7 +4643,7 @@
           <a:ln/>
         </p:spPr>
         <p:txBody>
-          <a:bodyPr wrap="square" lIns="0" tIns="0" rIns="0" bIns="0" rtlCol="0" anchor="ctr"/>
+          <a:bodyPr wrap="square" lIns="0" tIns="0" rIns="0" bIns="0" rtlCol="0" anchor="t"/>
           <a:lstStyle/>
           <a:p>
             <a:pPr indent="0" marL="0">
@@ -5113,7 +4658,7 @@
                 <a:ea typeface="Calibri" pitchFamily="34" charset="-122"/>
                 <a:cs typeface="Calibri" pitchFamily="34" charset="-120"/>
               </a:rPr>
-              <a:t>Skipping meals leaves you tired before the day is over.</a:t>
+              <a:t>Without regular meals, the body runs out of fuel long before the day is over.</a:t>
             </a:r>
             <a:endParaRPr lang="en-US" sz="1400" dirty="0"/>
           </a:p>
@@ -5127,12 +4672,12 @@
         </p:nvSpPr>
         <p:spPr>
           <a:xfrm>
-            <a:off x="4297680" y="3017520"/>
-            <a:ext cx="3474720" cy="2240280"/>
+            <a:off x="4297680" y="2971800"/>
+            <a:ext cx="3474720" cy="2331720"/>
           </a:xfrm>
           <a:prstGeom prst="roundRect">
             <a:avLst>
-              <a:gd name="adj" fmla="val 7347"/>
+              <a:gd name="adj" fmla="val 7059"/>
             </a:avLst>
           </a:prstGeom>
           <a:solidFill>
@@ -5158,7 +4703,7 @@
         </p:nvSpPr>
         <p:spPr>
           <a:xfrm>
-            <a:off x="4617720" y="3291840"/>
+            <a:off x="4617720" y="3200400"/>
             <a:ext cx="731520" cy="731520"/>
           </a:xfrm>
           <a:prstGeom prst="ellipse">
@@ -5186,7 +4731,7 @@
         </p:blipFill>
         <p:spPr>
           <a:xfrm>
-            <a:off x="4815230" y="3489350"/>
+            <a:off x="4815230" y="3397910"/>
             <a:ext cx="336499" cy="336499"/>
           </a:xfrm>
           <a:prstGeom prst="rect">
@@ -5202,8 +4747,8 @@
         </p:nvSpPr>
         <p:spPr>
           <a:xfrm>
-            <a:off x="4617720" y="4160520"/>
-            <a:ext cx="2834640" cy="411480"/>
+            <a:off x="4617720" y="4069080"/>
+            <a:ext cx="2926080" cy="411480"/>
           </a:xfrm>
           <a:prstGeom prst="rect">
             <a:avLst/>
@@ -5212,14 +4757,14 @@
           <a:ln/>
         </p:spPr>
         <p:txBody>
-          <a:bodyPr wrap="square" lIns="0" tIns="0" rIns="0" bIns="0" rtlCol="0" anchor="ctr"/>
+          <a:bodyPr wrap="square" lIns="0" tIns="0" rIns="0" bIns="0" rtlCol="0" anchor="t"/>
           <a:lstStyle/>
           <a:p>
             <a:pPr indent="0" marL="0">
               <a:buNone/>
             </a:pPr>
             <a:r>
-              <a:rPr lang="en-US" sz="2000" b="1" dirty="0">
+              <a:rPr lang="en-US" sz="1900" b="1" dirty="0">
                 <a:solidFill>
                   <a:srgbClr val="FFFFFF"/>
                 </a:solidFill>
@@ -5227,9 +4772,9 @@
                 <a:ea typeface="Calibri" pitchFamily="34" charset="-122"/>
                 <a:cs typeface="Calibri" pitchFamily="34" charset="-120"/>
               </a:rPr>
-              <a:t>Poor focus</a:t>
+              <a:t>Difficulty concentrating</a:t>
             </a:r>
-            <a:endParaRPr lang="en-US" sz="2000" dirty="0"/>
+            <a:endParaRPr lang="en-US" sz="1900" dirty="0"/>
           </a:p>
         </p:txBody>
       </p:sp>
@@ -5241,8 +4786,8 @@
         </p:nvSpPr>
         <p:spPr>
           <a:xfrm>
-            <a:off x="4617720" y="4572000"/>
-            <a:ext cx="2834640" cy="594360"/>
+            <a:off x="4617720" y="4480560"/>
+            <a:ext cx="2880360" cy="731520"/>
           </a:xfrm>
           <a:prstGeom prst="rect">
             <a:avLst/>
@@ -5251,7 +4796,7 @@
           <a:ln/>
         </p:spPr>
         <p:txBody>
-          <a:bodyPr wrap="square" lIns="0" tIns="0" rIns="0" bIns="0" rtlCol="0" anchor="ctr"/>
+          <a:bodyPr wrap="square" lIns="0" tIns="0" rIns="0" bIns="0" rtlCol="0" anchor="t"/>
           <a:lstStyle/>
           <a:p>
             <a:pPr indent="0" marL="0">
@@ -5266,7 +4811,7 @@
                 <a:ea typeface="Calibri" pitchFamily="34" charset="-122"/>
                 <a:cs typeface="Calibri" pitchFamily="34" charset="-120"/>
               </a:rPr>
-              <a:t>It becomes harder to concentrate in class or at work.</a:t>
+              <a:t>Skipping meals makes it much harder to stay focused in class or at work.</a:t>
             </a:r>
             <a:endParaRPr lang="en-US" sz="1400" dirty="0"/>
           </a:p>
@@ -5280,12 +4825,12 @@
         </p:nvSpPr>
         <p:spPr>
           <a:xfrm>
-            <a:off x="8046720" y="3017520"/>
-            <a:ext cx="3474720" cy="2240280"/>
+            <a:off x="8046720" y="2971800"/>
+            <a:ext cx="3474720" cy="2331720"/>
           </a:xfrm>
           <a:prstGeom prst="roundRect">
             <a:avLst>
-              <a:gd name="adj" fmla="val 7347"/>
+              <a:gd name="adj" fmla="val 7059"/>
             </a:avLst>
           </a:prstGeom>
           <a:solidFill>
@@ -5311,7 +4856,7 @@
         </p:nvSpPr>
         <p:spPr>
           <a:xfrm>
-            <a:off x="8366760" y="3291840"/>
+            <a:off x="8366760" y="3200400"/>
             <a:ext cx="731520" cy="731520"/>
           </a:xfrm>
           <a:prstGeom prst="ellipse">
@@ -5339,7 +4884,7 @@
         </p:blipFill>
         <p:spPr>
           <a:xfrm>
-            <a:off x="8564270" y="3489350"/>
+            <a:off x="8564270" y="3397910"/>
             <a:ext cx="336499" cy="336499"/>
           </a:xfrm>
           <a:prstGeom prst="rect">
@@ -5355,8 +4900,8 @@
         </p:nvSpPr>
         <p:spPr>
           <a:xfrm>
-            <a:off x="8366760" y="4160520"/>
-            <a:ext cx="2834640" cy="411480"/>
+            <a:off x="8366760" y="4069080"/>
+            <a:ext cx="2926080" cy="411480"/>
           </a:xfrm>
           <a:prstGeom prst="rect">
             <a:avLst/>
@@ -5365,14 +4910,14 @@
           <a:ln/>
         </p:spPr>
         <p:txBody>
-          <a:bodyPr wrap="square" lIns="0" tIns="0" rIns="0" bIns="0" rtlCol="0" anchor="ctr"/>
+          <a:bodyPr wrap="square" lIns="0" tIns="0" rIns="0" bIns="0" rtlCol="0" anchor="t"/>
           <a:lstStyle/>
           <a:p>
             <a:pPr indent="0" marL="0">
               <a:buNone/>
             </a:pPr>
             <a:r>
-              <a:rPr lang="en-US" sz="2000" b="1" dirty="0">
+              <a:rPr lang="en-US" sz="1900" b="1" dirty="0">
                 <a:solidFill>
                   <a:srgbClr val="FFFFFF"/>
                 </a:solidFill>
@@ -5382,7 +4927,7 @@
               </a:rPr>
               <a:t>Poor nutrition</a:t>
             </a:r>
-            <a:endParaRPr lang="en-US" sz="2000" dirty="0"/>
+            <a:endParaRPr lang="en-US" sz="1900" dirty="0"/>
           </a:p>
         </p:txBody>
       </p:sp>
@@ -5394,8 +4939,8 @@
         </p:nvSpPr>
         <p:spPr>
           <a:xfrm>
-            <a:off x="8366760" y="4572000"/>
-            <a:ext cx="2834640" cy="594360"/>
+            <a:off x="8366760" y="4480560"/>
+            <a:ext cx="2880360" cy="731520"/>
           </a:xfrm>
           <a:prstGeom prst="rect">
             <a:avLst/>
@@ -5404,7 +4949,7 @@
           <a:ln/>
         </p:spPr>
         <p:txBody>
-          <a:bodyPr wrap="square" lIns="0" tIns="0" rIns="0" bIns="0" rtlCol="0" anchor="ctr"/>
+          <a:bodyPr wrap="square" lIns="0" tIns="0" rIns="0" bIns="0" rtlCol="0" anchor="t"/>
           <a:lstStyle/>
           <a:p>
             <a:pPr indent="0" marL="0">
@@ -5419,7 +4964,7 @@
                 <a:ea typeface="Calibri" pitchFamily="34" charset="-122"/>
                 <a:cs typeface="Calibri" pitchFamily="34" charset="-120"/>
               </a:rPr>
-              <a:t>Your body misses the nutrients it needs every day.</a:t>
+              <a:t>Over time, the body misses out on the nutrients it needs to stay healthy.</a:t>
             </a:r>
             <a:endParaRPr lang="en-US" sz="1400" dirty="0"/>
           </a:p>
@@ -5472,7 +5017,7 @@
               <a:buNone/>
             </a:pPr>
             <a:r>
-              <a:rPr lang="en-US" sz="1800" b="1" dirty="0">
+              <a:rPr lang="en-US" sz="1700" b="1" dirty="0">
                 <a:solidFill>
                   <a:srgbClr val="0B1F3A"/>
                 </a:solidFill>
@@ -5480,9 +5025,9 @@
                 <a:ea typeface="Calibri" pitchFamily="34" charset="-122"/>
                 <a:cs typeface="Calibri" pitchFamily="34" charset="-120"/>
               </a:rPr>
-              <a:t>They need a quick and convenient way to get essential nutrients.</a:t>
+              <a:t>What they need is a quick and convenient way to get essential nutrients when there is no time to eat.</a:t>
             </a:r>
-            <a:endParaRPr lang="en-US" sz="1800" dirty="0"/>
+            <a:endParaRPr lang="en-US" sz="1700" dirty="0"/>
           </a:p>
         </p:txBody>
       </p:sp>
@@ -6992,7 +6537,7 @@
                   <a:schemeClr val="accent1"/>
                 </a:solidFill>
               </a:rPr>
-              <a:t>OUR SOLUTION</a:t>
+              <a:t>03 / 08</a:t>
             </a:r>
             <a:endParaRPr lang="en-US" sz="1300" dirty="0"/>
           </a:p>
@@ -7033,7 +6578,7 @@
                 <a:ea typeface="Arial Black" pitchFamily="34" charset="-122"/>
                 <a:cs typeface="Arial Black" pitchFamily="34" charset="-120"/>
               </a:rPr>
-              <a:t>Meet NutriPill</a:t>
+              <a:t>Our Solution</a:t>
             </a:r>
             <a:endParaRPr lang="en-US" sz="3600" dirty="0"/>
           </a:p>
@@ -7144,8 +6689,8 @@
         </p:nvSpPr>
         <p:spPr>
           <a:xfrm>
-            <a:off x="5897880" y="2103120"/>
-            <a:ext cx="2011680" cy="365760"/>
+            <a:off x="5897880" y="2057400"/>
+            <a:ext cx="2057400" cy="411480"/>
           </a:xfrm>
           <a:prstGeom prst="rect">
             <a:avLst/>
@@ -7154,14 +6699,14 @@
           <a:ln/>
         </p:spPr>
         <p:txBody>
-          <a:bodyPr wrap="square" lIns="0" tIns="0" rIns="0" bIns="0" rtlCol="0" anchor="ctr"/>
+          <a:bodyPr wrap="square" lIns="0" tIns="0" rIns="0" bIns="0" rtlCol="0" anchor="t"/>
           <a:lstStyle/>
           <a:p>
             <a:pPr indent="0" marL="0">
               <a:buNone/>
             </a:pPr>
             <a:r>
-              <a:rPr lang="en-US" sz="1700" b="1" dirty="0">
+              <a:rPr lang="en-US" sz="1500" b="1" dirty="0">
                 <a:solidFill>
                   <a:srgbClr val="0B1F3A"/>
                 </a:solidFill>
@@ -7171,7 +6716,7 @@
               </a:rPr>
               <a:t>Innovative</a:t>
             </a:r>
-            <a:endParaRPr lang="en-US" sz="1700" dirty="0"/>
+            <a:endParaRPr lang="en-US" sz="1500" dirty="0"/>
           </a:p>
         </p:txBody>
       </p:sp>
@@ -7184,7 +6729,7 @@
         <p:spPr>
           <a:xfrm>
             <a:off x="5897880" y="2468880"/>
-            <a:ext cx="2011680" cy="685800"/>
+            <a:ext cx="2011680" cy="731520"/>
           </a:xfrm>
           <a:prstGeom prst="rect">
             <a:avLst/>
@@ -7193,7 +6738,7 @@
           <a:ln/>
         </p:spPr>
         <p:txBody>
-          <a:bodyPr wrap="square" lIns="0" tIns="0" rIns="0" bIns="0" rtlCol="0" anchor="ctr"/>
+          <a:bodyPr wrap="square" lIns="0" tIns="0" rIns="0" bIns="0" rtlCol="0" anchor="t"/>
           <a:lstStyle/>
           <a:p>
             <a:pPr indent="0" marL="0">
@@ -7208,7 +6753,7 @@
                 <a:ea typeface="Calibri" pitchFamily="34" charset="-122"/>
                 <a:cs typeface="Calibri" pitchFamily="34" charset="-120"/>
               </a:rPr>
-              <a:t>A new way to get essential nutrients in seconds.</a:t>
+              <a:t>A brand-new way of getting essential nutrients in seconds.</a:t>
             </a:r>
             <a:endParaRPr lang="en-US" sz="1400" dirty="0"/>
           </a:p>
@@ -7295,8 +6840,8 @@
         </p:nvSpPr>
         <p:spPr>
           <a:xfrm>
-            <a:off x="9372600" y="2103120"/>
-            <a:ext cx="2011680" cy="365760"/>
+            <a:off x="9372600" y="2057400"/>
+            <a:ext cx="2057400" cy="411480"/>
           </a:xfrm>
           <a:prstGeom prst="rect">
             <a:avLst/>
@@ -7305,14 +6850,14 @@
           <a:ln/>
         </p:spPr>
         <p:txBody>
-          <a:bodyPr wrap="square" lIns="0" tIns="0" rIns="0" bIns="0" rtlCol="0" anchor="ctr"/>
+          <a:bodyPr wrap="square" lIns="0" tIns="0" rIns="0" bIns="0" rtlCol="0" anchor="t"/>
           <a:lstStyle/>
           <a:p>
             <a:pPr indent="0" marL="0">
               <a:buNone/>
             </a:pPr>
             <a:r>
-              <a:rPr lang="en-US" sz="1700" b="1" dirty="0">
+              <a:rPr lang="en-US" sz="1500" b="1" dirty="0">
                 <a:solidFill>
                   <a:srgbClr val="0B1F3A"/>
                 </a:solidFill>
@@ -7320,9 +6865,9 @@
                 <a:ea typeface="Calibri" pitchFamily="34" charset="-122"/>
                 <a:cs typeface="Calibri" pitchFamily="34" charset="-120"/>
               </a:rPr>
-              <a:t>Small &amp; portable</a:t>
+              <a:t>Small and easy to carry</a:t>
             </a:r>
-            <a:endParaRPr lang="en-US" sz="1700" dirty="0"/>
+            <a:endParaRPr lang="en-US" sz="1500" dirty="0"/>
           </a:p>
         </p:txBody>
       </p:sp>
@@ -7335,7 +6880,7 @@
         <p:spPr>
           <a:xfrm>
             <a:off x="9372600" y="2468880"/>
-            <a:ext cx="2011680" cy="685800"/>
+            <a:ext cx="2011680" cy="731520"/>
           </a:xfrm>
           <a:prstGeom prst="rect">
             <a:avLst/>
@@ -7344,7 +6889,7 @@
           <a:ln/>
         </p:spPr>
         <p:txBody>
-          <a:bodyPr wrap="square" lIns="0" tIns="0" rIns="0" bIns="0" rtlCol="0" anchor="ctr"/>
+          <a:bodyPr wrap="square" lIns="0" tIns="0" rIns="0" bIns="0" rtlCol="0" anchor="t"/>
           <a:lstStyle/>
           <a:p>
             <a:pPr indent="0" marL="0">
@@ -7359,7 +6904,7 @@
                 <a:ea typeface="Calibri" pitchFamily="34" charset="-122"/>
                 <a:cs typeface="Calibri" pitchFamily="34" charset="-120"/>
               </a:rPr>
-              <a:t>Easy to carry in your bag or pocket.</a:t>
+              <a:t>It fits easily into a pocket, backpack or bag.</a:t>
             </a:r>
             <a:endParaRPr lang="en-US" sz="1400" dirty="0"/>
           </a:p>
@@ -7446,8 +6991,8 @@
         </p:nvSpPr>
         <p:spPr>
           <a:xfrm>
-            <a:off x="5897880" y="3794760"/>
-            <a:ext cx="2011680" cy="365760"/>
+            <a:off x="5897880" y="3749040"/>
+            <a:ext cx="2057400" cy="411480"/>
           </a:xfrm>
           <a:prstGeom prst="rect">
             <a:avLst/>
@@ -7456,14 +7001,14 @@
           <a:ln/>
         </p:spPr>
         <p:txBody>
-          <a:bodyPr wrap="square" lIns="0" tIns="0" rIns="0" bIns="0" rtlCol="0" anchor="ctr"/>
+          <a:bodyPr wrap="square" lIns="0" tIns="0" rIns="0" bIns="0" rtlCol="0" anchor="t"/>
           <a:lstStyle/>
           <a:p>
             <a:pPr indent="0" marL="0">
               <a:buNone/>
             </a:pPr>
             <a:r>
-              <a:rPr lang="en-US" sz="1700" b="1" dirty="0">
+              <a:rPr lang="en-US" sz="1500" b="1" dirty="0">
                 <a:solidFill>
                   <a:srgbClr val="0B1F3A"/>
                 </a:solidFill>
@@ -7471,9 +7016,9 @@
                 <a:ea typeface="Calibri" pitchFamily="34" charset="-122"/>
                 <a:cs typeface="Calibri" pitchFamily="34" charset="-120"/>
               </a:rPr>
-              <a:t>Keeps you going</a:t>
+              <a:t>Keeps your energy up</a:t>
             </a:r>
-            <a:endParaRPr lang="en-US" sz="1700" dirty="0"/>
+            <a:endParaRPr lang="en-US" sz="1500" dirty="0"/>
           </a:p>
         </p:txBody>
       </p:sp>
@@ -7486,7 +7031,7 @@
         <p:spPr>
           <a:xfrm>
             <a:off x="5897880" y="4160520"/>
-            <a:ext cx="2011680" cy="685800"/>
+            <a:ext cx="2011680" cy="731520"/>
           </a:xfrm>
           <a:prstGeom prst="rect">
             <a:avLst/>
@@ -7495,7 +7040,7 @@
           <a:ln/>
         </p:spPr>
         <p:txBody>
-          <a:bodyPr wrap="square" lIns="0" tIns="0" rIns="0" bIns="0" rtlCol="0" anchor="ctr"/>
+          <a:bodyPr wrap="square" lIns="0" tIns="0" rIns="0" bIns="0" rtlCol="0" anchor="t"/>
           <a:lstStyle/>
           <a:p>
             <a:pPr indent="0" marL="0">
@@ -7510,7 +7055,7 @@
                 <a:ea typeface="Calibri" pitchFamily="34" charset="-122"/>
                 <a:cs typeface="Calibri" pitchFamily="34" charset="-120"/>
               </a:rPr>
-              <a:t>Helps you maintain your energy all day.</a:t>
+              <a:t>It helps you maintain your energy throughout the day.</a:t>
             </a:r>
             <a:endParaRPr lang="en-US" sz="1400" dirty="0"/>
           </a:p>
@@ -7597,8 +7142,8 @@
         </p:nvSpPr>
         <p:spPr>
           <a:xfrm>
-            <a:off x="9372600" y="3794760"/>
-            <a:ext cx="2011680" cy="365760"/>
+            <a:off x="9372600" y="3749040"/>
+            <a:ext cx="2057400" cy="411480"/>
           </a:xfrm>
           <a:prstGeom prst="rect">
             <a:avLst/>
@@ -7607,14 +7152,14 @@
           <a:ln/>
         </p:spPr>
         <p:txBody>
-          <a:bodyPr wrap="square" lIns="0" tIns="0" rIns="0" bIns="0" rtlCol="0" anchor="ctr"/>
+          <a:bodyPr wrap="square" lIns="0" tIns="0" rIns="0" bIns="0" rtlCol="0" anchor="t"/>
           <a:lstStyle/>
           <a:p>
             <a:pPr indent="0" marL="0">
               <a:buNone/>
             </a:pPr>
             <a:r>
-              <a:rPr lang="en-US" sz="1700" b="1" dirty="0">
+              <a:rPr lang="en-US" sz="1500" b="1" dirty="0">
                 <a:solidFill>
                   <a:srgbClr val="0B1F3A"/>
                 </a:solidFill>
@@ -7622,9 +7167,9 @@
                 <a:ea typeface="Calibri" pitchFamily="34" charset="-122"/>
                 <a:cs typeface="Calibri" pitchFamily="34" charset="-120"/>
               </a:rPr>
-              <a:t>Built for busy days</a:t>
+              <a:t>Perfect for busy people</a:t>
             </a:r>
-            <a:endParaRPr lang="en-US" sz="1700" dirty="0"/>
+            <a:endParaRPr lang="en-US" sz="1500" dirty="0"/>
           </a:p>
         </p:txBody>
       </p:sp>
@@ -7637,7 +7182,7 @@
         <p:spPr>
           <a:xfrm>
             <a:off x="9372600" y="4160520"/>
-            <a:ext cx="2011680" cy="685800"/>
+            <a:ext cx="2011680" cy="731520"/>
           </a:xfrm>
           <a:prstGeom prst="rect">
             <a:avLst/>
@@ -7646,7 +7191,7 @@
           <a:ln/>
         </p:spPr>
         <p:txBody>
-          <a:bodyPr wrap="square" lIns="0" tIns="0" rIns="0" bIns="0" rtlCol="0" anchor="ctr"/>
+          <a:bodyPr wrap="square" lIns="0" tIns="0" rIns="0" bIns="0" rtlCol="0" anchor="t"/>
           <a:lstStyle/>
           <a:p>
             <a:pPr indent="0" marL="0">
@@ -7661,7 +7206,7 @@
                 <a:ea typeface="Calibri" pitchFamily="34" charset="-122"/>
                 <a:cs typeface="Calibri" pitchFamily="34" charset="-120"/>
               </a:rPr>
-              <a:t>Perfect for students and workers.</a:t>
+              <a:t>Ideal for students and workers with demanding schedules.</a:t>
             </a:r>
             <a:endParaRPr lang="en-US" sz="1400" dirty="0"/>
           </a:p>
@@ -7722,7 +7267,7 @@
                 <a:ea typeface="Calibri" pitchFamily="34" charset="-122"/>
                 <a:cs typeface="Calibri" pitchFamily="34" charset="-120"/>
               </a:rPr>
-              <a:t>Good to know: </a:t>
+              <a:t>Please note: </a:t>
             </a:r>
             <a:pPr indent="0" marL="0">
               <a:buNone/>
@@ -7736,7 +7281,7 @@
                 <a:ea typeface="Calibri" pitchFamily="34" charset="-122"/>
                 <a:cs typeface="Calibri" pitchFamily="34" charset="-120"/>
               </a:rPr>
-              <a:t>NutriPill doesn't replace a complete meal — it supplements your nutrition when life gets busy.</a:t>
+              <a:t>although NutriPill does not replace a complete meal, it offers a practical way to supplement your nutrition when life gets busy.</a:t>
             </a:r>
             <a:endParaRPr lang="en-US" sz="1400" dirty="0"/>
           </a:p>
@@ -9586,7 +9131,7 @@
                   <a:schemeClr val="accent1"/>
                 </a:solidFill>
               </a:rPr>
-              <a:t>TARGET AUDIENCE</a:t>
+              <a:t>04 / 08</a:t>
             </a:r>
             <a:endParaRPr lang="en-US" sz="1300" dirty="0"/>
           </a:p>
@@ -9627,7 +9172,7 @@
                 <a:ea typeface="Arial Black" pitchFamily="34" charset="-122"/>
                 <a:cs typeface="Arial Black" pitchFamily="34" charset="-120"/>
               </a:rPr>
-              <a:t>Who is NutriPill for?</a:t>
+              <a:t>Who Is Our Brand Directed To?</a:t>
             </a:r>
             <a:endParaRPr lang="en-US" sz="3600" dirty="0"/>
           </a:p>
@@ -9641,8 +9186,8 @@
         </p:nvSpPr>
         <p:spPr>
           <a:xfrm>
-            <a:off x="548640" y="1828800"/>
-            <a:ext cx="8229600" cy="548640"/>
+            <a:off x="548640" y="1783080"/>
+            <a:ext cx="10515600" cy="777240"/>
           </a:xfrm>
           <a:prstGeom prst="rect">
             <a:avLst/>
@@ -9651,14 +9196,14 @@
           <a:ln/>
         </p:spPr>
         <p:txBody>
-          <a:bodyPr wrap="square" lIns="0" tIns="0" rIns="0" bIns="0" rtlCol="0" anchor="ctr"/>
+          <a:bodyPr wrap="square" lIns="0" tIns="0" rIns="0" bIns="0" rtlCol="0" anchor="t"/>
           <a:lstStyle/>
           <a:p>
             <a:pPr indent="0" marL="0">
               <a:buNone/>
             </a:pPr>
             <a:r>
-              <a:rPr lang="en-US" sz="2000" dirty="0">
+              <a:rPr lang="en-US" sz="1800" dirty="0">
                 <a:solidFill>
                   <a:srgbClr val="B8C7D9"/>
                 </a:solidFill>
@@ -9666,9 +9211,9 @@
                 <a:ea typeface="Calibri" pitchFamily="34" charset="-122"/>
                 <a:cs typeface="Calibri" pitchFamily="34" charset="-120"/>
               </a:rPr>
-              <a:t>Busy people who don't always have time to eat properly.</a:t>
+              <a:t>NutriPill is designed for busy people who don't always have time to eat properly, especially those who need a quick and convenient way to supplement their nutrition during a hectic day.</a:t>
             </a:r>
-            <a:endParaRPr lang="en-US" sz="2000" dirty="0"/>
+            <a:endParaRPr lang="en-US" sz="1800" dirty="0"/>
           </a:p>
         </p:txBody>
       </p:sp>
@@ -9680,8 +9225,8 @@
         </p:nvSpPr>
         <p:spPr>
           <a:xfrm>
-            <a:off x="548640" y="2743200"/>
-            <a:ext cx="2560320" cy="3108960"/>
+            <a:off x="548640" y="2788920"/>
+            <a:ext cx="2560320" cy="3337560"/>
           </a:xfrm>
           <a:prstGeom prst="roundRect">
             <a:avLst>
@@ -9753,7 +9298,7 @@
         </p:nvSpPr>
         <p:spPr>
           <a:xfrm>
-            <a:off x="731520" y="4297680"/>
+            <a:off x="731520" y="4251960"/>
             <a:ext cx="2194560" cy="457200"/>
           </a:xfrm>
           <a:prstGeom prst="rect">
@@ -9763,14 +9308,14 @@
           <a:ln/>
         </p:spPr>
         <p:txBody>
-          <a:bodyPr wrap="square" lIns="0" tIns="0" rIns="0" bIns="0" rtlCol="0" anchor="ctr"/>
+          <a:bodyPr wrap="square" lIns="0" tIns="0" rIns="0" bIns="0" rtlCol="0" anchor="t"/>
           <a:lstStyle/>
           <a:p>
             <a:pPr algn="ctr" indent="0" marL="0">
               <a:buNone/>
             </a:pPr>
             <a:r>
-              <a:rPr lang="en-US" sz="2000" b="1" dirty="0">
+              <a:rPr lang="en-US" sz="1900" b="1" dirty="0">
                 <a:solidFill>
                   <a:srgbClr val="0B1F3A"/>
                 </a:solidFill>
@@ -9780,7 +9325,7 @@
               </a:rPr>
               <a:t>Students</a:t>
             </a:r>
-            <a:endParaRPr lang="en-US" sz="2000" dirty="0"/>
+            <a:endParaRPr lang="en-US" sz="1900" dirty="0"/>
           </a:p>
         </p:txBody>
       </p:sp>
@@ -9792,8 +9337,8 @@
         </p:nvSpPr>
         <p:spPr>
           <a:xfrm>
-            <a:off x="777240" y="4754880"/>
-            <a:ext cx="2103120" cy="822960"/>
+            <a:off x="749808" y="4709160"/>
+            <a:ext cx="2157984" cy="1188720"/>
           </a:xfrm>
           <a:prstGeom prst="rect">
             <a:avLst/>
@@ -9802,7 +9347,7 @@
           <a:ln/>
         </p:spPr>
         <p:txBody>
-          <a:bodyPr wrap="square" lIns="0" tIns="0" rIns="0" bIns="0" rtlCol="0" anchor="ctr"/>
+          <a:bodyPr wrap="square" lIns="0" tIns="0" rIns="0" bIns="0" rtlCol="0" anchor="t"/>
           <a:lstStyle/>
           <a:p>
             <a:pPr algn="ctr" indent="0" marL="0">
@@ -9817,7 +9362,7 @@
                 <a:ea typeface="Calibri" pitchFamily="34" charset="-122"/>
                 <a:cs typeface="Calibri" pitchFamily="34" charset="-120"/>
               </a:rPr>
-              <a:t>Long days of classes, exams and homework.</a:t>
+              <a:t>Long days of classes, exams and homework often leave little time for lunch.</a:t>
             </a:r>
             <a:endParaRPr lang="en-US" sz="1400" dirty="0"/>
           </a:p>
@@ -9831,8 +9376,8 @@
         </p:nvSpPr>
         <p:spPr>
           <a:xfrm>
-            <a:off x="3364992" y="2743200"/>
-            <a:ext cx="2560320" cy="3108960"/>
+            <a:off x="3364992" y="2788920"/>
+            <a:ext cx="2560320" cy="3337560"/>
           </a:xfrm>
           <a:prstGeom prst="roundRect">
             <a:avLst>
@@ -9904,7 +9449,7 @@
         </p:nvSpPr>
         <p:spPr>
           <a:xfrm>
-            <a:off x="3547872" y="4297680"/>
+            <a:off x="3547872" y="4251960"/>
             <a:ext cx="2194560" cy="457200"/>
           </a:xfrm>
           <a:prstGeom prst="rect">
@@ -9914,14 +9459,14 @@
           <a:ln/>
         </p:spPr>
         <p:txBody>
-          <a:bodyPr wrap="square" lIns="0" tIns="0" rIns="0" bIns="0" rtlCol="0" anchor="ctr"/>
+          <a:bodyPr wrap="square" lIns="0" tIns="0" rIns="0" bIns="0" rtlCol="0" anchor="t"/>
           <a:lstStyle/>
           <a:p>
             <a:pPr algn="ctr" indent="0" marL="0">
               <a:buNone/>
             </a:pPr>
             <a:r>
-              <a:rPr lang="en-US" sz="2000" b="1" dirty="0">
+              <a:rPr lang="en-US" sz="1900" b="1" dirty="0">
                 <a:solidFill>
                   <a:srgbClr val="0B1F3A"/>
                 </a:solidFill>
@@ -9931,7 +9476,7 @@
               </a:rPr>
               <a:t>Workers</a:t>
             </a:r>
-            <a:endParaRPr lang="en-US" sz="2000" dirty="0"/>
+            <a:endParaRPr lang="en-US" sz="1900" dirty="0"/>
           </a:p>
         </p:txBody>
       </p:sp>
@@ -9943,8 +9488,8 @@
         </p:nvSpPr>
         <p:spPr>
           <a:xfrm>
-            <a:off x="3593592" y="4754880"/>
-            <a:ext cx="2103120" cy="822960"/>
+            <a:off x="3566160" y="4709160"/>
+            <a:ext cx="2157984" cy="1188720"/>
           </a:xfrm>
           <a:prstGeom prst="rect">
             <a:avLst/>
@@ -9953,7 +9498,7 @@
           <a:ln/>
         </p:spPr>
         <p:txBody>
-          <a:bodyPr wrap="square" lIns="0" tIns="0" rIns="0" bIns="0" rtlCol="0" anchor="ctr"/>
+          <a:bodyPr wrap="square" lIns="0" tIns="0" rIns="0" bIns="0" rtlCol="0" anchor="t"/>
           <a:lstStyle/>
           <a:p>
             <a:pPr algn="ctr" indent="0" marL="0">
@@ -9968,7 +9513,7 @@
                 <a:ea typeface="Calibri" pitchFamily="34" charset="-122"/>
                 <a:cs typeface="Calibri" pitchFamily="34" charset="-120"/>
               </a:rPr>
-              <a:t>Meetings, deadlines and no lunch break.</a:t>
+              <a:t>Tight deadlines and back-to-back meetings mean meals are often skipped.</a:t>
             </a:r>
             <a:endParaRPr lang="en-US" sz="1400" dirty="0"/>
           </a:p>
@@ -9982,8 +9527,8 @@
         </p:nvSpPr>
         <p:spPr>
           <a:xfrm>
-            <a:off x="6181344" y="2743200"/>
-            <a:ext cx="2560320" cy="3108960"/>
+            <a:off x="6181344" y="2788920"/>
+            <a:ext cx="2560320" cy="3337560"/>
           </a:xfrm>
           <a:prstGeom prst="roundRect">
             <a:avLst>
@@ -10055,7 +9600,7 @@
         </p:nvSpPr>
         <p:spPr>
           <a:xfrm>
-            <a:off x="6364224" y="4297680"/>
+            <a:off x="6364224" y="4251960"/>
             <a:ext cx="2194560" cy="457200"/>
           </a:xfrm>
           <a:prstGeom prst="rect">
@@ -10065,14 +9610,14 @@
           <a:ln/>
         </p:spPr>
         <p:txBody>
-          <a:bodyPr wrap="square" lIns="0" tIns="0" rIns="0" bIns="0" rtlCol="0" anchor="ctr"/>
+          <a:bodyPr wrap="square" lIns="0" tIns="0" rIns="0" bIns="0" rtlCol="0" anchor="t"/>
           <a:lstStyle/>
           <a:p>
             <a:pPr algn="ctr" indent="0" marL="0">
               <a:buNone/>
             </a:pPr>
             <a:r>
-              <a:rPr lang="en-US" sz="2000" b="1" dirty="0">
+              <a:rPr lang="en-US" sz="1900" b="1" dirty="0">
                 <a:solidFill>
                   <a:srgbClr val="0B1F3A"/>
                 </a:solidFill>
@@ -10082,7 +9627,7 @@
               </a:rPr>
               <a:t>Athletes</a:t>
             </a:r>
-            <a:endParaRPr lang="en-US" sz="2000" dirty="0"/>
+            <a:endParaRPr lang="en-US" sz="1900" dirty="0"/>
           </a:p>
         </p:txBody>
       </p:sp>
@@ -10094,8 +9639,8 @@
         </p:nvSpPr>
         <p:spPr>
           <a:xfrm>
-            <a:off x="6409944" y="4754880"/>
-            <a:ext cx="2103120" cy="822960"/>
+            <a:off x="6382512" y="4709160"/>
+            <a:ext cx="2157984" cy="1188720"/>
           </a:xfrm>
           <a:prstGeom prst="rect">
             <a:avLst/>
@@ -10104,7 +9649,7 @@
           <a:ln/>
         </p:spPr>
         <p:txBody>
-          <a:bodyPr wrap="square" lIns="0" tIns="0" rIns="0" bIns="0" rtlCol="0" anchor="ctr"/>
+          <a:bodyPr wrap="square" lIns="0" tIns="0" rIns="0" bIns="0" rtlCol="0" anchor="t"/>
           <a:lstStyle/>
           <a:p>
             <a:pPr algn="ctr" indent="0" marL="0">
@@ -10119,7 +9664,7 @@
                 <a:ea typeface="Calibri" pitchFamily="34" charset="-122"/>
                 <a:cs typeface="Calibri" pitchFamily="34" charset="-120"/>
               </a:rPr>
-              <a:t>Extra nutrients for training days.</a:t>
+              <a:t>Intense training requires a steady supply of essential nutrients.</a:t>
             </a:r>
             <a:endParaRPr lang="en-US" sz="1400" dirty="0"/>
           </a:p>
@@ -10133,8 +9678,8 @@
         </p:nvSpPr>
         <p:spPr>
           <a:xfrm>
-            <a:off x="8997696" y="2743200"/>
-            <a:ext cx="2560320" cy="3108960"/>
+            <a:off x="8997696" y="2788920"/>
+            <a:ext cx="2560320" cy="3337560"/>
           </a:xfrm>
           <a:prstGeom prst="roundRect">
             <a:avLst>
@@ -10206,7 +9751,7 @@
         </p:nvSpPr>
         <p:spPr>
           <a:xfrm>
-            <a:off x="9180576" y="4297680"/>
+            <a:off x="9180576" y="4251960"/>
             <a:ext cx="2194560" cy="457200"/>
           </a:xfrm>
           <a:prstGeom prst="rect">
@@ -10216,14 +9761,14 @@
           <a:ln/>
         </p:spPr>
         <p:txBody>
-          <a:bodyPr wrap="square" lIns="0" tIns="0" rIns="0" bIns="0" rtlCol="0" anchor="ctr"/>
+          <a:bodyPr wrap="square" lIns="0" tIns="0" rIns="0" bIns="0" rtlCol="0" anchor="t"/>
           <a:lstStyle/>
           <a:p>
             <a:pPr algn="ctr" indent="0" marL="0">
               <a:buNone/>
             </a:pPr>
             <a:r>
-              <a:rPr lang="en-US" sz="2000" b="1" dirty="0">
+              <a:rPr lang="en-US" sz="1900" b="1" dirty="0">
                 <a:solidFill>
                   <a:srgbClr val="0B1F3A"/>
                 </a:solidFill>
@@ -10233,7 +9778,7 @@
               </a:rPr>
               <a:t>Hectic lifestyles</a:t>
             </a:r>
-            <a:endParaRPr lang="en-US" sz="2000" dirty="0"/>
+            <a:endParaRPr lang="en-US" sz="1900" dirty="0"/>
           </a:p>
         </p:txBody>
       </p:sp>
@@ -10245,8 +9790,8 @@
         </p:nvSpPr>
         <p:spPr>
           <a:xfrm>
-            <a:off x="9226296" y="4754880"/>
-            <a:ext cx="2103120" cy="822960"/>
+            <a:off x="9198864" y="4709160"/>
+            <a:ext cx="2157984" cy="1188720"/>
           </a:xfrm>
           <a:prstGeom prst="rect">
             <a:avLst/>
@@ -10255,7 +9800,7 @@
           <a:ln/>
         </p:spPr>
         <p:txBody>
-          <a:bodyPr wrap="square" lIns="0" tIns="0" rIns="0" bIns="0" rtlCol="0" anchor="ctr"/>
+          <a:bodyPr wrap="square" lIns="0" tIns="0" rIns="0" bIns="0" rtlCol="0" anchor="t"/>
           <a:lstStyle/>
           <a:p>
             <a:pPr algn="ctr" indent="0" marL="0">
@@ -10270,7 +9815,7 @@
                 <a:ea typeface="Calibri" pitchFamily="34" charset="-122"/>
                 <a:cs typeface="Calibri" pitchFamily="34" charset="-120"/>
               </a:rPr>
-              <a:t>Anyone who is always on the move.</a:t>
+              <a:t>Anyone who is constantly on the move and short on time.</a:t>
             </a:r>
             <a:endParaRPr lang="en-US" sz="1400" dirty="0"/>
           </a:p>
@@ -11985,7 +11530,7 @@
                   <a:schemeClr val="accent1"/>
                 </a:solidFill>
               </a:rPr>
-              <a:t>ACTION PLAN</a:t>
+              <a:t>05 / 08</a:t>
             </a:r>
             <a:endParaRPr lang="en-US" sz="1300" dirty="0"/>
           </a:p>
@@ -12026,7 +11571,7 @@
                 <a:ea typeface="Arial Black" pitchFamily="34" charset="-122"/>
                 <a:cs typeface="Arial Black" pitchFamily="34" charset="-120"/>
               </a:rPr>
-              <a:t>Three pillars of our business model</a:t>
+              <a:t>Action Plan</a:t>
             </a:r>
             <a:endParaRPr lang="en-US" sz="3600" dirty="0"/>
           </a:p>
@@ -12034,14 +11579,53 @@
       </p:sp>
       <p:sp>
         <p:nvSpPr>
-          <p:cNvPr id="4" name="a1_card"/>
+          <p:cNvPr id="4" name="a1_sub"/>
+          <p:cNvSpPr txBox="1"/>
+          <p:nvPr/>
+        </p:nvSpPr>
+        <p:spPr>
+          <a:xfrm>
+            <a:off x="548640" y="1691640"/>
+            <a:ext cx="10058400" cy="411480"/>
+          </a:xfrm>
+          <a:prstGeom prst="rect">
+            <a:avLst/>
+          </a:prstGeom>
+          <a:noFill/>
+          <a:ln/>
+        </p:spPr>
+        <p:txBody>
+          <a:bodyPr wrap="square" lIns="0" tIns="0" rIns="0" bIns="0" rtlCol="0" anchor="t"/>
+          <a:lstStyle/>
+          <a:p>
+            <a:pPr indent="0" marL="0">
+              <a:buNone/>
+            </a:pPr>
+            <a:r>
+              <a:rPr lang="en-US" sz="1800" dirty="0">
+                <a:solidFill>
+                  <a:srgbClr val="5B6B80"/>
+                </a:solidFill>
+                <a:latin typeface="Calibri" pitchFamily="34" charset="0"/>
+                <a:ea typeface="Calibri" pitchFamily="34" charset="-122"/>
+                <a:cs typeface="Calibri" pitchFamily="34" charset="-120"/>
+              </a:rPr>
+              <a:t>Our business model is built on three key pillars:</a:t>
+            </a:r>
+            <a:endParaRPr lang="en-US" sz="1800" dirty="0"/>
+          </a:p>
+        </p:txBody>
+      </p:sp>
+      <p:sp>
+        <p:nvSpPr>
+          <p:cNvPr id="5" name="a2_card"/>
           <p:cNvSpPr/>
           <p:nvPr/>
         </p:nvSpPr>
         <p:spPr>
           <a:xfrm>
-            <a:off x="548640" y="2057400"/>
-            <a:ext cx="3474720" cy="3977640"/>
+            <a:off x="548640" y="2286000"/>
+            <a:ext cx="3474720" cy="3840480"/>
           </a:xfrm>
           <a:prstGeom prst="roundRect">
             <a:avLst>
@@ -12063,13 +11647,13 @@
       </p:sp>
       <p:sp>
         <p:nvSpPr>
-          <p:cNvPr id="5" name="a1_num"/>
+          <p:cNvPr id="6" name="a2_num"/>
           <p:cNvSpPr txBox="1"/>
           <p:nvPr/>
         </p:nvSpPr>
         <p:spPr>
           <a:xfrm>
-            <a:off x="2743200" y="2240280"/>
+            <a:off x="2743200" y="2468880"/>
             <a:ext cx="1097280" cy="731520"/>
           </a:xfrm>
           <a:prstGeom prst="rect">
@@ -12079,7 +11663,7 @@
           <a:ln/>
         </p:spPr>
         <p:txBody>
-          <a:bodyPr wrap="square" lIns="0" tIns="0" rIns="0" bIns="0" rtlCol="0" anchor="ctr"/>
+          <a:bodyPr wrap="square" lIns="0" tIns="0" rIns="0" bIns="0" rtlCol="0" anchor="t"/>
           <a:lstStyle/>
           <a:p>
             <a:pPr algn="r" indent="0" marL="0">
@@ -12102,13 +11686,13 @@
       </p:sp>
       <p:sp>
         <p:nvSpPr>
-          <p:cNvPr id="6" name="a1_circle"/>
+          <p:cNvPr id="7" name="a2_circle"/>
           <p:cNvSpPr/>
           <p:nvPr/>
         </p:nvSpPr>
         <p:spPr>
           <a:xfrm>
-            <a:off x="914400" y="2377440"/>
+            <a:off x="914400" y="2560320"/>
             <a:ext cx="914400" cy="914400"/>
           </a:xfrm>
           <a:prstGeom prst="ellipse">
@@ -12122,7 +11706,7 @@
       </p:sp>
       <p:pic>
         <p:nvPicPr>
-          <p:cNvPr id="7" name="a1_icon" descr="coins">    </p:cNvPr>
+          <p:cNvPr id="8" name="a2_icon" descr="coins">    </p:cNvPr>
           <p:cNvPicPr>
             <a:picLocks noChangeAspect="1"/>
           </p:cNvPicPr>
@@ -12136,7 +11720,7 @@
         </p:blipFill>
         <p:spPr>
           <a:xfrm>
-            <a:off x="1161288" y="2624328"/>
+            <a:off x="1161288" y="2807208"/>
             <a:ext cx="420624" cy="420624"/>
           </a:xfrm>
           <a:prstGeom prst="rect">
@@ -12146,13 +11730,13 @@
       </p:pic>
       <p:sp>
         <p:nvSpPr>
-          <p:cNvPr id="8" name="a1_h"/>
+          <p:cNvPr id="9" name="a2_h"/>
           <p:cNvSpPr txBox="1"/>
           <p:nvPr/>
         </p:nvSpPr>
         <p:spPr>
           <a:xfrm>
-            <a:off x="914400" y="3566160"/>
+            <a:off x="914400" y="3657600"/>
             <a:ext cx="2743200" cy="502920"/>
           </a:xfrm>
           <a:prstGeom prst="rect">
@@ -12162,7 +11746,7 @@
           <a:ln/>
         </p:spPr>
         <p:txBody>
-          <a:bodyPr wrap="square" lIns="0" tIns="0" rIns="0" bIns="0" rtlCol="0" anchor="ctr"/>
+          <a:bodyPr wrap="square" lIns="0" tIns="0" rIns="0" bIns="0" rtlCol="0" anchor="t"/>
           <a:lstStyle/>
           <a:p>
             <a:pPr indent="0" marL="0">
@@ -12185,14 +11769,14 @@
       </p:sp>
       <p:sp>
         <p:nvSpPr>
-          <p:cNvPr id="9" name="a1_d"/>
+          <p:cNvPr id="10" name="a2_d"/>
           <p:cNvSpPr txBox="1"/>
           <p:nvPr/>
         </p:nvSpPr>
         <p:spPr>
           <a:xfrm>
-            <a:off x="914400" y="4114800"/>
-            <a:ext cx="2743200" cy="1097280"/>
+            <a:off x="914400" y="4160520"/>
+            <a:ext cx="2788920" cy="1234440"/>
           </a:xfrm>
           <a:prstGeom prst="rect">
             <a:avLst/>
@@ -12201,7 +11785,7 @@
           <a:ln/>
         </p:spPr>
         <p:txBody>
-          <a:bodyPr wrap="square" lIns="0" tIns="0" rIns="0" bIns="0" rtlCol="0" anchor="ctr"/>
+          <a:bodyPr wrap="square" lIns="0" tIns="0" rIns="0" bIns="0" rtlCol="0" anchor="t"/>
           <a:lstStyle/>
           <a:p>
             <a:pPr indent="0" marL="0">
@@ -12216,7 +11800,7 @@
                 <a:ea typeface="Calibri" pitchFamily="34" charset="-122"/>
                 <a:cs typeface="Calibri" pitchFamily="34" charset="-120"/>
               </a:rPr>
-              <a:t>Direct sales of NutriPill plus brand experiences linked to the product.</a:t>
+              <a:t>We will generate income through direct sales of NutriPill, as well as experiences linked to the product.</a:t>
             </a:r>
             <a:endParaRPr lang="en-US" sz="1600" dirty="0"/>
           </a:p>
@@ -12224,14 +11808,14 @@
       </p:sp>
       <p:sp>
         <p:nvSpPr>
-          <p:cNvPr id="10" name="a2_card"/>
+          <p:cNvPr id="11" name="a3_card"/>
           <p:cNvSpPr/>
           <p:nvPr/>
         </p:nvSpPr>
         <p:spPr>
           <a:xfrm>
-            <a:off x="4297680" y="2057400"/>
-            <a:ext cx="3474720" cy="3977640"/>
+            <a:off x="4297680" y="2286000"/>
+            <a:ext cx="3474720" cy="3840480"/>
           </a:xfrm>
           <a:prstGeom prst="roundRect">
             <a:avLst>
@@ -12253,13 +11837,13 @@
       </p:sp>
       <p:sp>
         <p:nvSpPr>
-          <p:cNvPr id="11" name="a2_num"/>
+          <p:cNvPr id="12" name="a3_num"/>
           <p:cNvSpPr txBox="1"/>
           <p:nvPr/>
         </p:nvSpPr>
         <p:spPr>
           <a:xfrm>
-            <a:off x="6492240" y="2240280"/>
+            <a:off x="6492240" y="2468880"/>
             <a:ext cx="1097280" cy="731520"/>
           </a:xfrm>
           <a:prstGeom prst="rect">
@@ -12269,7 +11853,7 @@
           <a:ln/>
         </p:spPr>
         <p:txBody>
-          <a:bodyPr wrap="square" lIns="0" tIns="0" rIns="0" bIns="0" rtlCol="0" anchor="ctr"/>
+          <a:bodyPr wrap="square" lIns="0" tIns="0" rIns="0" bIns="0" rtlCol="0" anchor="t"/>
           <a:lstStyle/>
           <a:p>
             <a:pPr algn="r" indent="0" marL="0">
@@ -12292,13 +11876,13 @@
       </p:sp>
       <p:sp>
         <p:nvSpPr>
-          <p:cNvPr id="12" name="a2_circle"/>
+          <p:cNvPr id="13" name="a3_circle"/>
           <p:cNvSpPr/>
           <p:nvPr/>
         </p:nvSpPr>
         <p:spPr>
           <a:xfrm>
-            <a:off x="4663440" y="2377440"/>
+            <a:off x="4663440" y="2560320"/>
             <a:ext cx="914400" cy="914400"/>
           </a:xfrm>
           <a:prstGeom prst="ellipse">
@@ -12312,7 +11896,7 @@
       </p:sp>
       <p:pic>
         <p:nvPicPr>
-          <p:cNvPr id="13" name="a2_icon" descr="share">    </p:cNvPr>
+          <p:cNvPr id="14" name="a3_icon" descr="share">    </p:cNvPr>
           <p:cNvPicPr>
             <a:picLocks noChangeAspect="1"/>
           </p:cNvPicPr>
@@ -12326,7 +11910,7 @@
         </p:blipFill>
         <p:spPr>
           <a:xfrm>
-            <a:off x="4910328" y="2624328"/>
+            <a:off x="4910328" y="2807208"/>
             <a:ext cx="420624" cy="420624"/>
           </a:xfrm>
           <a:prstGeom prst="rect">
@@ -12336,13 +11920,13 @@
       </p:pic>
       <p:sp>
         <p:nvSpPr>
-          <p:cNvPr id="14" name="a2_h"/>
+          <p:cNvPr id="15" name="a3_h"/>
           <p:cNvSpPr txBox="1"/>
           <p:nvPr/>
         </p:nvSpPr>
         <p:spPr>
           <a:xfrm>
-            <a:off x="4663440" y="3566160"/>
+            <a:off x="4663440" y="3657600"/>
             <a:ext cx="2743200" cy="502920"/>
           </a:xfrm>
           <a:prstGeom prst="rect">
@@ -12352,7 +11936,7 @@
           <a:ln/>
         </p:spPr>
         <p:txBody>
-          <a:bodyPr wrap="square" lIns="0" tIns="0" rIns="0" bIns="0" rtlCol="0" anchor="ctr"/>
+          <a:bodyPr wrap="square" lIns="0" tIns="0" rIns="0" bIns="0" rtlCol="0" anchor="t"/>
           <a:lstStyle/>
           <a:p>
             <a:pPr indent="0" marL="0">
@@ -12375,14 +11959,14 @@
       </p:sp>
       <p:sp>
         <p:nvSpPr>
-          <p:cNvPr id="15" name="a2_d"/>
+          <p:cNvPr id="16" name="a3_d"/>
           <p:cNvSpPr txBox="1"/>
           <p:nvPr/>
         </p:nvSpPr>
         <p:spPr>
           <a:xfrm>
-            <a:off x="4663440" y="4114800"/>
-            <a:ext cx="2743200" cy="1097280"/>
+            <a:off x="4663440" y="4160520"/>
+            <a:ext cx="2788920" cy="1234440"/>
           </a:xfrm>
           <a:prstGeom prst="rect">
             <a:avLst/>
@@ -12391,7 +11975,7 @@
           <a:ln/>
         </p:spPr>
         <p:txBody>
-          <a:bodyPr wrap="square" lIns="0" tIns="0" rIns="0" bIns="0" rtlCol="0" anchor="ctr"/>
+          <a:bodyPr wrap="square" lIns="0" tIns="0" rIns="0" bIns="0" rtlCol="0" anchor="t"/>
           <a:lstStyle/>
           <a:p>
             <a:pPr indent="0" marL="0">
@@ -12406,7 +11990,7 @@
                 <a:ea typeface="Calibri" pitchFamily="34" charset="-122"/>
                 <a:cs typeface="Calibri" pitchFamily="34" charset="-120"/>
               </a:rPr>
-              <a:t>A strong presence on the main social networks, plus in-person experiences.</a:t>
+              <a:t>We will build a strong presence on the main social networks, combined with face-to-face experiences.</a:t>
             </a:r>
             <a:endParaRPr lang="en-US" sz="1600" dirty="0"/>
           </a:p>
@@ -12414,14 +11998,14 @@
       </p:sp>
       <p:sp>
         <p:nvSpPr>
-          <p:cNvPr id="16" name="a3_card"/>
+          <p:cNvPr id="17" name="a4_card"/>
           <p:cNvSpPr/>
           <p:nvPr/>
         </p:nvSpPr>
         <p:spPr>
           <a:xfrm>
-            <a:off x="8046720" y="2057400"/>
-            <a:ext cx="3474720" cy="3977640"/>
+            <a:off x="8046720" y="2286000"/>
+            <a:ext cx="3474720" cy="3840480"/>
           </a:xfrm>
           <a:prstGeom prst="roundRect">
             <a:avLst>
@@ -12443,13 +12027,13 @@
       </p:sp>
       <p:sp>
         <p:nvSpPr>
-          <p:cNvPr id="17" name="a3_num"/>
+          <p:cNvPr id="18" name="a4_num"/>
           <p:cNvSpPr txBox="1"/>
           <p:nvPr/>
         </p:nvSpPr>
         <p:spPr>
           <a:xfrm>
-            <a:off x="10241280" y="2240280"/>
+            <a:off x="10241280" y="2468880"/>
             <a:ext cx="1097280" cy="731520"/>
           </a:xfrm>
           <a:prstGeom prst="rect">
@@ -12459,7 +12043,7 @@
           <a:ln/>
         </p:spPr>
         <p:txBody>
-          <a:bodyPr wrap="square" lIns="0" tIns="0" rIns="0" bIns="0" rtlCol="0" anchor="ctr"/>
+          <a:bodyPr wrap="square" lIns="0" tIns="0" rIns="0" bIns="0" rtlCol="0" anchor="t"/>
           <a:lstStyle/>
           <a:p>
             <a:pPr algn="r" indent="0" marL="0">
@@ -12482,13 +12066,13 @@
       </p:sp>
       <p:sp>
         <p:nvSpPr>
-          <p:cNvPr id="18" name="a3_circle"/>
+          <p:cNvPr id="19" name="a4_circle"/>
           <p:cNvSpPr/>
           <p:nvPr/>
         </p:nvSpPr>
         <p:spPr>
           <a:xfrm>
-            <a:off x="8412480" y="2377440"/>
+            <a:off x="8412480" y="2560320"/>
             <a:ext cx="914400" cy="914400"/>
           </a:xfrm>
           <a:prstGeom prst="ellipse">
@@ -12502,7 +12086,7 @@
       </p:sp>
       <p:pic>
         <p:nvPicPr>
-          <p:cNvPr id="19" name="a3_icon" descr="tag">    </p:cNvPr>
+          <p:cNvPr id="20" name="a4_icon" descr="tag">    </p:cNvPr>
           <p:cNvPicPr>
             <a:picLocks noChangeAspect="1"/>
           </p:cNvPicPr>
@@ -12516,7 +12100,7 @@
         </p:blipFill>
         <p:spPr>
           <a:xfrm>
-            <a:off x="8659368" y="2624328"/>
+            <a:off x="8659368" y="2807208"/>
             <a:ext cx="420624" cy="420624"/>
           </a:xfrm>
           <a:prstGeom prst="rect">
@@ -12526,13 +12110,13 @@
       </p:pic>
       <p:sp>
         <p:nvSpPr>
-          <p:cNvPr id="20" name="a3_h"/>
+          <p:cNvPr id="21" name="a4_h"/>
           <p:cNvSpPr txBox="1"/>
           <p:nvPr/>
         </p:nvSpPr>
         <p:spPr>
           <a:xfrm>
-            <a:off x="8412480" y="3566160"/>
+            <a:off x="8412480" y="3657600"/>
             <a:ext cx="2743200" cy="502920"/>
           </a:xfrm>
           <a:prstGeom prst="rect">
@@ -12542,7 +12126,7 @@
           <a:ln/>
         </p:spPr>
         <p:txBody>
-          <a:bodyPr wrap="square" lIns="0" tIns="0" rIns="0" bIns="0" rtlCol="0" anchor="ctr"/>
+          <a:bodyPr wrap="square" lIns="0" tIns="0" rIns="0" bIns="0" rtlCol="0" anchor="t"/>
           <a:lstStyle/>
           <a:p>
             <a:pPr indent="0" marL="0">
@@ -12565,14 +12149,14 @@
       </p:sp>
       <p:sp>
         <p:nvSpPr>
-          <p:cNvPr id="21" name="a3_d"/>
+          <p:cNvPr id="22" name="a4_d"/>
           <p:cNvSpPr txBox="1"/>
           <p:nvPr/>
         </p:nvSpPr>
         <p:spPr>
           <a:xfrm>
-            <a:off x="8412480" y="4114800"/>
-            <a:ext cx="2743200" cy="1097280"/>
+            <a:off x="8412480" y="4160520"/>
+            <a:ext cx="2788920" cy="1234440"/>
           </a:xfrm>
           <a:prstGeom prst="rect">
             <a:avLst/>
@@ -12581,7 +12165,7 @@
           <a:ln/>
         </p:spPr>
         <p:txBody>
-          <a:bodyPr wrap="square" lIns="0" tIns="0" rIns="0" bIns="0" rtlCol="0" anchor="ctr"/>
+          <a:bodyPr wrap="square" lIns="0" tIns="0" rIns="0" bIns="0" rtlCol="0" anchor="t"/>
           <a:lstStyle/>
           <a:p>
             <a:pPr indent="0" marL="0">
@@ -12596,7 +12180,7 @@
                 <a:ea typeface="Calibri" pitchFamily="34" charset="-122"/>
                 <a:cs typeface="Calibri" pitchFamily="34" charset="-120"/>
               </a:rPr>
-              <a:t>Affordable but with added value: an accessible premium option.</a:t>
+              <a:t>Our prices will be affordable but with added value: a premium option that remains accessible to everyone.</a:t>
             </a:r>
             <a:endParaRPr lang="en-US" sz="1600" dirty="0"/>
           </a:p>
@@ -12604,7 +12188,7 @@
       </p:sp>
       <p:pic>
         <p:nvPicPr>
-          <p:cNvPr id="22" name="a2_social" descr="instagram">    </p:cNvPr>
+          <p:cNvPr id="23" name="a3_social" descr="instagram">    </p:cNvPr>
           <p:cNvPicPr>
             <a:picLocks noChangeAspect="1"/>
           </p:cNvPicPr>
@@ -12618,7 +12202,7 @@
         </p:blipFill>
         <p:spPr>
           <a:xfrm>
-            <a:off x="4389120" y="5349240"/>
+            <a:off x="4663440" y="5486400"/>
             <a:ext cx="384048" cy="384048"/>
           </a:xfrm>
           <a:prstGeom prst="rect">
@@ -12628,7 +12212,7 @@
       </p:pic>
       <p:pic>
         <p:nvPicPr>
-          <p:cNvPr id="23" name="a2_social" descr="tiktok">    </p:cNvPr>
+          <p:cNvPr id="24" name="a3_social" descr="tiktok">    </p:cNvPr>
           <p:cNvPicPr>
             <a:picLocks noChangeAspect="1"/>
           </p:cNvPicPr>
@@ -12642,7 +12226,7 @@
         </p:blipFill>
         <p:spPr>
           <a:xfrm>
-            <a:off x="4983480" y="5349240"/>
+            <a:off x="5257800" y="5486400"/>
             <a:ext cx="384048" cy="384048"/>
           </a:xfrm>
           <a:prstGeom prst="rect">
@@ -12652,7 +12236,7 @@
       </p:pic>
       <p:pic>
         <p:nvPicPr>
-          <p:cNvPr id="24" name="a2_social" descr="youtube">    </p:cNvPr>
+          <p:cNvPr id="25" name="a3_social" descr="youtube">    </p:cNvPr>
           <p:cNvPicPr>
             <a:picLocks noChangeAspect="1"/>
           </p:cNvPicPr>
@@ -12666,7 +12250,7 @@
         </p:blipFill>
         <p:spPr>
           <a:xfrm>
-            <a:off x="5577840" y="5349240"/>
+            <a:off x="5852160" y="5486400"/>
             <a:ext cx="384048" cy="384048"/>
           </a:xfrm>
           <a:prstGeom prst="rect">
@@ -12736,7 +12320,7 @@
               <p:cTn id="2" dur="indefinite" nodeType="mainSeq">
                 <p:childTnLst>
                   <p:par>
-                    <p:cTn id="118" fill="hold">
+                    <p:cTn id="123" fill="hold">
                       <p:stCondLst>
                         <p:cond delay="indefinite"/>
                         <p:cond evt="onBegin" delay="0">
@@ -12952,7 +12536,7 @@
                             </p:stCondLst>
                             <p:childTnLst>
                               <p:par>
-                                <p:cTn id="19" presetID="42" presetClass="entr" presetSubtype="0" fill="hold" grpId="0" nodeType="withEffect">
+                                <p:cTn id="19" presetID="42" presetClass="entr" presetSubtype="0" fill="hold" grpId="0" nodeType="afterEffect">
                                   <p:stCondLst>
                                     <p:cond delay="0"/>
                                   </p:stCondLst>
@@ -13287,7 +12871,7 @@
                             </p:stCondLst>
                             <p:childTnLst>
                               <p:par>
-                                <p:cTn id="44" presetID="42" presetClass="entr" presetSubtype="0" fill="hold" grpId="0" nodeType="afterEffect">
+                                <p:cTn id="44" presetID="42" presetClass="entr" presetSubtype="0" fill="hold" grpId="0" nodeType="withEffect">
                                   <p:stCondLst>
                                     <p:cond delay="0"/>
                                   </p:stCondLst>
@@ -13354,7 +12938,7 @@
                             </p:stCondLst>
                             <p:childTnLst>
                               <p:par>
-                                <p:cTn id="49" presetID="42" presetClass="entr" presetSubtype="0" fill="hold" grpId="0" nodeType="withEffect">
+                                <p:cTn id="49" presetID="42" presetClass="entr" presetSubtype="0" fill="hold" grpId="0" nodeType="afterEffect">
                                   <p:stCondLst>
                                     <p:cond delay="0"/>
                                   </p:stCondLst>
@@ -13702,7 +13286,7 @@
                                           </p:stCondLst>
                                         </p:cTn>
                                         <p:tgtEl>
-                                          <p:spTgt spid="22"/>
+                                          <p:spTgt spid="16"/>
                                         </p:tgtEl>
                                         <p:attrNameLst>
                                           <p:attrName>style.visibility</p:attrName>
@@ -13716,7 +13300,7 @@
                                       <p:cBhvr>
                                         <p:cTn id="76" dur="600"/>
                                         <p:tgtEl>
-                                          <p:spTgt spid="22"/>
+                                          <p:spTgt spid="16"/>
                                         </p:tgtEl>
                                       </p:cBhvr>
                                     </p:animEffect>
@@ -13724,7 +13308,7 @@
                                       <p:cBhvr>
                                         <p:cTn id="77" dur="600" decel="100000" fill="hold"/>
                                         <p:tgtEl>
-                                          <p:spTgt spid="22"/>
+                                          <p:spTgt spid="16"/>
                                         </p:tgtEl>
                                         <p:attrNameLst>
                                           <p:attrName>ppt_y</p:attrName>
@@ -13890,7 +13474,7 @@
                             </p:stCondLst>
                             <p:childTnLst>
                               <p:par>
-                                <p:cTn id="89" presetID="42" presetClass="entr" presetSubtype="0" fill="hold" grpId="0" nodeType="afterEffect">
+                                <p:cTn id="89" presetID="42" presetClass="entr" presetSubtype="0" fill="hold" grpId="0" nodeType="withEffect">
                                   <p:stCondLst>
                                     <p:cond delay="0"/>
                                   </p:stCondLst>
@@ -13903,7 +13487,7 @@
                                           </p:stCondLst>
                                         </p:cTn>
                                         <p:tgtEl>
-                                          <p:spTgt spid="16"/>
+                                          <p:spTgt spid="25"/>
                                         </p:tgtEl>
                                         <p:attrNameLst>
                                           <p:attrName>style.visibility</p:attrName>
@@ -13917,7 +13501,7 @@
                                       <p:cBhvr>
                                         <p:cTn id="91" dur="600"/>
                                         <p:tgtEl>
-                                          <p:spTgt spid="16"/>
+                                          <p:spTgt spid="25"/>
                                         </p:tgtEl>
                                       </p:cBhvr>
                                     </p:animEffect>
@@ -13925,7 +13509,7 @@
                                       <p:cBhvr>
                                         <p:cTn id="92" dur="600" decel="100000" fill="hold"/>
                                         <p:tgtEl>
-                                          <p:spTgt spid="16"/>
+                                          <p:spTgt spid="25"/>
                                         </p:tgtEl>
                                         <p:attrNameLst>
                                           <p:attrName>ppt_y</p:attrName>
@@ -13957,7 +13541,7 @@
                             </p:stCondLst>
                             <p:childTnLst>
                               <p:par>
-                                <p:cTn id="94" presetID="42" presetClass="entr" presetSubtype="0" fill="hold" grpId="0" nodeType="withEffect">
+                                <p:cTn id="94" presetID="42" presetClass="entr" presetSubtype="0" fill="hold" grpId="0" nodeType="afterEffect">
                                   <p:stCondLst>
                                     <p:cond delay="0"/>
                                   </p:stCondLst>
@@ -14261,6 +13845,73 @@
                                         <p:cTn id="117" dur="600" decel="100000" fill="hold"/>
                                         <p:tgtEl>
                                           <p:spTgt spid="21"/>
+                                        </p:tgtEl>
+                                        <p:attrNameLst>
+                                          <p:attrName>ppt_y</p:attrName>
+                                        </p:attrNameLst>
+                                      </p:cBhvr>
+                                      <p:tavLst>
+                                        <p:tav tm="0">
+                                          <p:val>
+                                            <p:strVal val="#ppt_y+0.04"/>
+                                          </p:val>
+                                        </p:tav>
+                                        <p:tav tm="100000">
+                                          <p:val>
+                                            <p:strVal val="#ppt_y"/>
+                                          </p:val>
+                                        </p:tav>
+                                      </p:tavLst>
+                                    </p:anim>
+                                  </p:childTnLst>
+                                </p:cTn>
+                              </p:par>
+                            </p:childTnLst>
+                          </p:cTn>
+                        </p:par>
+                        <p:par>
+                          <p:cTn id="118" fill="hold">
+                            <p:stCondLst>
+                              <p:cond delay="0"/>
+                            </p:stCondLst>
+                            <p:childTnLst>
+                              <p:par>
+                                <p:cTn id="119" presetID="42" presetClass="entr" presetSubtype="0" fill="hold" grpId="0" nodeType="withEffect">
+                                  <p:stCondLst>
+                                    <p:cond delay="0"/>
+                                  </p:stCondLst>
+                                  <p:childTnLst>
+                                    <p:set>
+                                      <p:cBhvr>
+                                        <p:cTn id="120" dur="1" fill="hold">
+                                          <p:stCondLst>
+                                            <p:cond delay="0"/>
+                                          </p:stCondLst>
+                                        </p:cTn>
+                                        <p:tgtEl>
+                                          <p:spTgt spid="22"/>
+                                        </p:tgtEl>
+                                        <p:attrNameLst>
+                                          <p:attrName>style.visibility</p:attrName>
+                                        </p:attrNameLst>
+                                      </p:cBhvr>
+                                      <p:to>
+                                        <p:strVal val="visible"/>
+                                      </p:to>
+                                    </p:set>
+                                    <p:animEffect transition="in" filter="fade">
+                                      <p:cBhvr>
+                                        <p:cTn id="121" dur="600"/>
+                                        <p:tgtEl>
+                                          <p:spTgt spid="22"/>
+                                        </p:tgtEl>
+                                      </p:cBhvr>
+                                    </p:animEffect>
+                                    <p:anim calcmode="lin" valueType="num">
+                                      <p:cBhvr>
+                                        <p:cTn id="122" dur="600" decel="100000" fill="hold"/>
+                                        <p:tgtEl>
+                                          <p:spTgt spid="22"/>
                                         </p:tgtEl>
                                         <p:attrNameLst>
                                           <p:attrName>ppt_y</p:attrName>
@@ -14315,18 +13966,19 @@
       <p:bldP spid="4" grpId="0" animBg="1"/>
       <p:bldP spid="5" grpId="0" animBg="1"/>
       <p:bldP spid="6" grpId="0" animBg="1"/>
-      <p:bldP spid="8" grpId="0" animBg="1"/>
+      <p:bldP spid="7" grpId="0" animBg="1"/>
       <p:bldP spid="9" grpId="0" animBg="1"/>
       <p:bldP spid="10" grpId="0" animBg="1"/>
       <p:bldP spid="11" grpId="0" animBg="1"/>
       <p:bldP spid="12" grpId="0" animBg="1"/>
-      <p:bldP spid="14" grpId="0" animBg="1"/>
+      <p:bldP spid="13" grpId="0" animBg="1"/>
       <p:bldP spid="15" grpId="0" animBg="1"/>
       <p:bldP spid="16" grpId="0" animBg="1"/>
       <p:bldP spid="17" grpId="0" animBg="1"/>
       <p:bldP spid="18" grpId="0" animBg="1"/>
-      <p:bldP spid="20" grpId="0" animBg="1"/>
+      <p:bldP spid="19" grpId="0" animBg="1"/>
       <p:bldP spid="21" grpId="0" animBg="1"/>
+      <p:bldP spid="22" grpId="0" animBg="1"/>
     </p:bldLst>
   </p:timing>
 </p:sld>
@@ -14381,7 +14033,7 @@
                   <a:schemeClr val="accent1"/>
                 </a:solidFill>
               </a:rPr>
-              <a:t>GROWTH STRATEGY</a:t>
+              <a:t>06 / 08</a:t>
             </a:r>
             <a:endParaRPr lang="en-US" sz="1300" dirty="0"/>
           </a:p>
@@ -14422,7 +14074,7 @@
                 <a:ea typeface="Arial Black" pitchFamily="34" charset="-122"/>
                 <a:cs typeface="Arial Black" pitchFamily="34" charset="-120"/>
               </a:rPr>
-              <a:t>How we will grow</a:t>
+              <a:t>Growth Strategy</a:t>
             </a:r>
             <a:endParaRPr lang="en-US" sz="3600" dirty="0"/>
           </a:p>
@@ -14436,7 +14088,7 @@
         </p:nvSpPr>
         <p:spPr>
           <a:xfrm>
-            <a:off x="1097280" y="2880360"/>
+            <a:off x="1097280" y="2606040"/>
             <a:ext cx="9966960" cy="0"/>
           </a:xfrm>
           <a:prstGeom prst="line">
@@ -14459,7 +14111,7 @@
         </p:nvSpPr>
         <p:spPr>
           <a:xfrm>
-            <a:off x="594360" y="2377440"/>
+            <a:off x="594360" y="2103120"/>
             <a:ext cx="1005840" cy="1005840"/>
           </a:xfrm>
           <a:prstGeom prst="ellipse">
@@ -14478,7 +14130,7 @@
       </p:sp>
       <p:pic>
         <p:nvPicPr>
-          <p:cNvPr id="6" name="a2_icon" descr="Inspiring content">    </p:cNvPr>
+          <p:cNvPr id="6" name="a2_icon" descr="Create inspiring content">    </p:cNvPr>
           <p:cNvPicPr>
             <a:picLocks noChangeAspect="1"/>
           </p:cNvPicPr>
@@ -14492,7 +14144,7 @@
         </p:blipFill>
         <p:spPr>
           <a:xfrm>
-            <a:off x="850392" y="2633472"/>
+            <a:off x="850392" y="2359152"/>
             <a:ext cx="493776" cy="493776"/>
           </a:xfrm>
           <a:prstGeom prst="rect">
@@ -14508,7 +14160,7 @@
         </p:nvSpPr>
         <p:spPr>
           <a:xfrm>
-            <a:off x="548640" y="3657600"/>
+            <a:off x="548640" y="3383280"/>
             <a:ext cx="2560320" cy="457200"/>
           </a:xfrm>
           <a:prstGeom prst="rect">
@@ -14518,7 +14170,7 @@
           <a:ln/>
         </p:spPr>
         <p:txBody>
-          <a:bodyPr wrap="square" lIns="0" tIns="0" rIns="0" bIns="0" rtlCol="0" anchor="ctr"/>
+          <a:bodyPr wrap="square" lIns="0" tIns="0" rIns="0" bIns="0" rtlCol="0" anchor="t"/>
           <a:lstStyle/>
           <a:p>
             <a:pPr indent="0" marL="0">
@@ -14547,8 +14199,8 @@
         </p:nvSpPr>
         <p:spPr>
           <a:xfrm>
-            <a:off x="548640" y="4114800"/>
-            <a:ext cx="2560320" cy="457200"/>
+            <a:off x="548640" y="3840480"/>
+            <a:ext cx="2606040" cy="777240"/>
           </a:xfrm>
           <a:prstGeom prst="rect">
             <a:avLst/>
@@ -14557,14 +14209,14 @@
           <a:ln/>
         </p:spPr>
         <p:txBody>
-          <a:bodyPr wrap="square" lIns="0" tIns="0" rIns="0" bIns="0" rtlCol="0" anchor="ctr"/>
+          <a:bodyPr wrap="square" lIns="0" tIns="0" rIns="0" bIns="0" rtlCol="0" anchor="t"/>
           <a:lstStyle/>
           <a:p>
             <a:pPr indent="0" marL="0">
               <a:buNone/>
             </a:pPr>
             <a:r>
-              <a:rPr lang="en-US" sz="2000" b="1" dirty="0">
+              <a:rPr lang="en-US" sz="1900" b="1" dirty="0">
                 <a:solidFill>
                   <a:srgbClr val="FFFFFF"/>
                 </a:solidFill>
@@ -14572,9 +14224,9 @@
                 <a:ea typeface="Calibri" pitchFamily="34" charset="-122"/>
                 <a:cs typeface="Calibri" pitchFamily="34" charset="-120"/>
               </a:rPr>
-              <a:t>Inspiring content</a:t>
+              <a:t>Create inspiring content</a:t>
             </a:r>
-            <a:endParaRPr lang="en-US" sz="2000" dirty="0"/>
+            <a:endParaRPr lang="en-US" sz="1900" dirty="0"/>
           </a:p>
         </p:txBody>
       </p:sp>
@@ -14586,8 +14238,8 @@
         </p:nvSpPr>
         <p:spPr>
           <a:xfrm>
-            <a:off x="548640" y="4617720"/>
-            <a:ext cx="2468880" cy="868680"/>
+            <a:off x="548640" y="4663440"/>
+            <a:ext cx="2560320" cy="1188720"/>
           </a:xfrm>
           <a:prstGeom prst="rect">
             <a:avLst/>
@@ -14596,7 +14248,7 @@
           <a:ln/>
         </p:spPr>
         <p:txBody>
-          <a:bodyPr wrap="square" lIns="0" tIns="0" rIns="0" bIns="0" rtlCol="0" anchor="ctr"/>
+          <a:bodyPr wrap="square" lIns="0" tIns="0" rIns="0" bIns="0" rtlCol="0" anchor="t"/>
           <a:lstStyle/>
           <a:p>
             <a:pPr indent="0" marL="0">
@@ -14611,7 +14263,7 @@
                 <a:ea typeface="Calibri" pitchFamily="34" charset="-122"/>
                 <a:cs typeface="Calibri" pitchFamily="34" charset="-120"/>
               </a:rPr>
-              <a:t>Social media posts that show a real, healthy lifestyle.</a:t>
+              <a:t>We will share content on social media that shows a real, everyday lifestyle.</a:t>
             </a:r>
             <a:endParaRPr lang="en-US" sz="1500" dirty="0"/>
           </a:p>
@@ -14625,7 +14277,7 @@
         </p:nvSpPr>
         <p:spPr>
           <a:xfrm>
-            <a:off x="3429000" y="2377440"/>
+            <a:off x="3429000" y="2103120"/>
             <a:ext cx="1005840" cy="1005840"/>
           </a:xfrm>
           <a:prstGeom prst="ellipse">
@@ -14644,7 +14296,7 @@
       </p:sp>
       <p:pic>
         <p:nvPicPr>
-          <p:cNvPr id="11" name="a3_icon" descr="Local influencers">    </p:cNvPr>
+          <p:cNvPr id="11" name="a3_icon" descr="Work with local influencers">    </p:cNvPr>
           <p:cNvPicPr>
             <a:picLocks noChangeAspect="1"/>
           </p:cNvPicPr>
@@ -14658,7 +14310,7 @@
         </p:blipFill>
         <p:spPr>
           <a:xfrm>
-            <a:off x="3685032" y="2633472"/>
+            <a:off x="3685032" y="2359152"/>
             <a:ext cx="493776" cy="493776"/>
           </a:xfrm>
           <a:prstGeom prst="rect">
@@ -14674,7 +14326,7 @@
         </p:nvSpPr>
         <p:spPr>
           <a:xfrm>
-            <a:off x="3383280" y="3657600"/>
+            <a:off x="3383280" y="3383280"/>
             <a:ext cx="2560320" cy="457200"/>
           </a:xfrm>
           <a:prstGeom prst="rect">
@@ -14684,7 +14336,7 @@
           <a:ln/>
         </p:spPr>
         <p:txBody>
-          <a:bodyPr wrap="square" lIns="0" tIns="0" rIns="0" bIns="0" rtlCol="0" anchor="ctr"/>
+          <a:bodyPr wrap="square" lIns="0" tIns="0" rIns="0" bIns="0" rtlCol="0" anchor="t"/>
           <a:lstStyle/>
           <a:p>
             <a:pPr indent="0" marL="0">
@@ -14713,8 +14365,8 @@
         </p:nvSpPr>
         <p:spPr>
           <a:xfrm>
-            <a:off x="3383280" y="4114800"/>
-            <a:ext cx="2560320" cy="457200"/>
+            <a:off x="3383280" y="3840480"/>
+            <a:ext cx="2606040" cy="777240"/>
           </a:xfrm>
           <a:prstGeom prst="rect">
             <a:avLst/>
@@ -14723,14 +14375,14 @@
           <a:ln/>
         </p:spPr>
         <p:txBody>
-          <a:bodyPr wrap="square" lIns="0" tIns="0" rIns="0" bIns="0" rtlCol="0" anchor="ctr"/>
+          <a:bodyPr wrap="square" lIns="0" tIns="0" rIns="0" bIns="0" rtlCol="0" anchor="t"/>
           <a:lstStyle/>
           <a:p>
             <a:pPr indent="0" marL="0">
               <a:buNone/>
             </a:pPr>
             <a:r>
-              <a:rPr lang="en-US" sz="2000" b="1" dirty="0">
+              <a:rPr lang="en-US" sz="1900" b="1" dirty="0">
                 <a:solidFill>
                   <a:srgbClr val="FFFFFF"/>
                 </a:solidFill>
@@ -14738,9 +14390,9 @@
                 <a:ea typeface="Calibri" pitchFamily="34" charset="-122"/>
                 <a:cs typeface="Calibri" pitchFamily="34" charset="-120"/>
               </a:rPr>
-              <a:t>Local influencers</a:t>
+              <a:t>Work with local influencers</a:t>
             </a:r>
-            <a:endParaRPr lang="en-US" sz="2000" dirty="0"/>
+            <a:endParaRPr lang="en-US" sz="1900" dirty="0"/>
           </a:p>
         </p:txBody>
       </p:sp>
@@ -14752,8 +14404,8 @@
         </p:nvSpPr>
         <p:spPr>
           <a:xfrm>
-            <a:off x="3383280" y="4617720"/>
-            <a:ext cx="2468880" cy="868680"/>
+            <a:off x="3383280" y="4663440"/>
+            <a:ext cx="2560320" cy="1188720"/>
           </a:xfrm>
           <a:prstGeom prst="rect">
             <a:avLst/>
@@ -14762,7 +14414,7 @@
           <a:ln/>
         </p:spPr>
         <p:txBody>
-          <a:bodyPr wrap="square" lIns="0" tIns="0" rIns="0" bIns="0" rtlCol="0" anchor="ctr"/>
+          <a:bodyPr wrap="square" lIns="0" tIns="0" rIns="0" bIns="0" rtlCol="0" anchor="t"/>
           <a:lstStyle/>
           <a:p>
             <a:pPr indent="0" marL="0">
@@ -14777,7 +14429,7 @@
                 <a:ea typeface="Calibri" pitchFamily="34" charset="-122"/>
                 <a:cs typeface="Calibri" pitchFamily="34" charset="-120"/>
               </a:rPr>
-              <a:t>Partners who represent the brand's philosophy.</a:t>
+              <a:t>We will partner with influencers who truly represent our brand's philosophy.</a:t>
             </a:r>
             <a:endParaRPr lang="en-US" sz="1500" dirty="0"/>
           </a:p>
@@ -14791,7 +14443,7 @@
         </p:nvSpPr>
         <p:spPr>
           <a:xfrm>
-            <a:off x="6263640" y="2377440"/>
+            <a:off x="6263640" y="2103120"/>
             <a:ext cx="1005840" cy="1005840"/>
           </a:xfrm>
           <a:prstGeom prst="ellipse">
@@ -14810,7 +14462,7 @@
       </p:sp>
       <p:pic>
         <p:nvPicPr>
-          <p:cNvPr id="16" name="a4_icon" descr="Memorable experiences">    </p:cNvPr>
+          <p:cNvPr id="16" name="a4_icon" descr="Create memorable experiences">    </p:cNvPr>
           <p:cNvPicPr>
             <a:picLocks noChangeAspect="1"/>
           </p:cNvPicPr>
@@ -14824,7 +14476,7 @@
         </p:blipFill>
         <p:spPr>
           <a:xfrm>
-            <a:off x="6519672" y="2633472"/>
+            <a:off x="6519672" y="2359152"/>
             <a:ext cx="493776" cy="493776"/>
           </a:xfrm>
           <a:prstGeom prst="rect">
@@ -14840,7 +14492,7 @@
         </p:nvSpPr>
         <p:spPr>
           <a:xfrm>
-            <a:off x="6217920" y="3657600"/>
+            <a:off x="6217920" y="3383280"/>
             <a:ext cx="2560320" cy="457200"/>
           </a:xfrm>
           <a:prstGeom prst="rect">
@@ -14850,7 +14502,7 @@
           <a:ln/>
         </p:spPr>
         <p:txBody>
-          <a:bodyPr wrap="square" lIns="0" tIns="0" rIns="0" bIns="0" rtlCol="0" anchor="ctr"/>
+          <a:bodyPr wrap="square" lIns="0" tIns="0" rIns="0" bIns="0" rtlCol="0" anchor="t"/>
           <a:lstStyle/>
           <a:p>
             <a:pPr indent="0" marL="0">
@@ -14879,8 +14531,8 @@
         </p:nvSpPr>
         <p:spPr>
           <a:xfrm>
-            <a:off x="6217920" y="4114800"/>
-            <a:ext cx="2560320" cy="457200"/>
+            <a:off x="6217920" y="3840480"/>
+            <a:ext cx="2606040" cy="777240"/>
           </a:xfrm>
           <a:prstGeom prst="rect">
             <a:avLst/>
@@ -14889,14 +14541,14 @@
           <a:ln/>
         </p:spPr>
         <p:txBody>
-          <a:bodyPr wrap="square" lIns="0" tIns="0" rIns="0" bIns="0" rtlCol="0" anchor="ctr"/>
+          <a:bodyPr wrap="square" lIns="0" tIns="0" rIns="0" bIns="0" rtlCol="0" anchor="t"/>
           <a:lstStyle/>
           <a:p>
             <a:pPr indent="0" marL="0">
               <a:buNone/>
             </a:pPr>
             <a:r>
-              <a:rPr lang="en-US" sz="2000" b="1" dirty="0">
+              <a:rPr lang="en-US" sz="1900" b="1" dirty="0">
                 <a:solidFill>
                   <a:srgbClr val="FFFFFF"/>
                 </a:solidFill>
@@ -14904,9 +14556,9 @@
                 <a:ea typeface="Calibri" pitchFamily="34" charset="-122"/>
                 <a:cs typeface="Calibri" pitchFamily="34" charset="-120"/>
               </a:rPr>
-              <a:t>Memorable experiences</a:t>
+              <a:t>Create memorable experiences</a:t>
             </a:r>
-            <a:endParaRPr lang="en-US" sz="2000" dirty="0"/>
+            <a:endParaRPr lang="en-US" sz="1900" dirty="0"/>
           </a:p>
         </p:txBody>
       </p:sp>
@@ -14918,8 +14570,8 @@
         </p:nvSpPr>
         <p:spPr>
           <a:xfrm>
-            <a:off x="6217920" y="4617720"/>
-            <a:ext cx="2468880" cy="868680"/>
+            <a:off x="6217920" y="4663440"/>
+            <a:ext cx="2560320" cy="1188720"/>
           </a:xfrm>
           <a:prstGeom prst="rect">
             <a:avLst/>
@@ -14928,7 +14580,7 @@
           <a:ln/>
         </p:spPr>
         <p:txBody>
-          <a:bodyPr wrap="square" lIns="0" tIns="0" rIns="0" bIns="0" rtlCol="0" anchor="ctr"/>
+          <a:bodyPr wrap="square" lIns="0" tIns="0" rIns="0" bIns="0" rtlCol="0" anchor="t"/>
           <a:lstStyle/>
           <a:p>
             <a:pPr indent="0" marL="0">
@@ -14943,7 +14595,7 @@
                 <a:ea typeface="Calibri" pitchFamily="34" charset="-122"/>
                 <a:cs typeface="Calibri" pitchFamily="34" charset="-120"/>
               </a:rPr>
-              <a:t>Events, personalized kits and collaborations.</a:t>
+              <a:t>We will organise events, offer personalised kits and develop collaborations.</a:t>
             </a:r>
             <a:endParaRPr lang="en-US" sz="1500" dirty="0"/>
           </a:p>
@@ -14957,7 +14609,7 @@
         </p:nvSpPr>
         <p:spPr>
           <a:xfrm>
-            <a:off x="9098280" y="2377440"/>
+            <a:off x="9098280" y="2103120"/>
             <a:ext cx="1005840" cy="1005840"/>
           </a:xfrm>
           <a:prstGeom prst="ellipse">
@@ -14976,7 +14628,7 @@
       </p:sp>
       <p:pic>
         <p:nvPicPr>
-          <p:cNvPr id="21" name="a5_icon" descr="Active community">    </p:cNvPr>
+          <p:cNvPr id="21" name="a5_icon" descr="Actively build a community">    </p:cNvPr>
           <p:cNvPicPr>
             <a:picLocks noChangeAspect="1"/>
           </p:cNvPicPr>
@@ -14990,7 +14642,7 @@
         </p:blipFill>
         <p:spPr>
           <a:xfrm>
-            <a:off x="9354312" y="2633472"/>
+            <a:off x="9354312" y="2359152"/>
             <a:ext cx="493776" cy="493776"/>
           </a:xfrm>
           <a:prstGeom prst="rect">
@@ -15006,7 +14658,7 @@
         </p:nvSpPr>
         <p:spPr>
           <a:xfrm>
-            <a:off x="9052560" y="3657600"/>
+            <a:off x="9052560" y="3383280"/>
             <a:ext cx="2560320" cy="457200"/>
           </a:xfrm>
           <a:prstGeom prst="rect">
@@ -15016,7 +14668,7 @@
           <a:ln/>
         </p:spPr>
         <p:txBody>
-          <a:bodyPr wrap="square" lIns="0" tIns="0" rIns="0" bIns="0" rtlCol="0" anchor="ctr"/>
+          <a:bodyPr wrap="square" lIns="0" tIns="0" rIns="0" bIns="0" rtlCol="0" anchor="t"/>
           <a:lstStyle/>
           <a:p>
             <a:pPr indent="0" marL="0">
@@ -15045,8 +14697,8 @@
         </p:nvSpPr>
         <p:spPr>
           <a:xfrm>
-            <a:off x="9052560" y="4114800"/>
-            <a:ext cx="2560320" cy="457200"/>
+            <a:off x="9052560" y="3840480"/>
+            <a:ext cx="2606040" cy="777240"/>
           </a:xfrm>
           <a:prstGeom prst="rect">
             <a:avLst/>
@@ -15055,14 +14707,14 @@
           <a:ln/>
         </p:spPr>
         <p:txBody>
-          <a:bodyPr wrap="square" lIns="0" tIns="0" rIns="0" bIns="0" rtlCol="0" anchor="ctr"/>
+          <a:bodyPr wrap="square" lIns="0" tIns="0" rIns="0" bIns="0" rtlCol="0" anchor="t"/>
           <a:lstStyle/>
           <a:p>
             <a:pPr indent="0" marL="0">
               <a:buNone/>
             </a:pPr>
             <a:r>
-              <a:rPr lang="en-US" sz="2000" b="1" dirty="0">
+              <a:rPr lang="en-US" sz="1900" b="1" dirty="0">
                 <a:solidFill>
                   <a:srgbClr val="FFFFFF"/>
                 </a:solidFill>
@@ -15070,9 +14722,9 @@
                 <a:ea typeface="Calibri" pitchFamily="34" charset="-122"/>
                 <a:cs typeface="Calibri" pitchFamily="34" charset="-120"/>
               </a:rPr>
-              <a:t>Active community</a:t>
+              <a:t>Actively build a community</a:t>
             </a:r>
-            <a:endParaRPr lang="en-US" sz="2000" dirty="0"/>
+            <a:endParaRPr lang="en-US" sz="1900" dirty="0"/>
           </a:p>
         </p:txBody>
       </p:sp>
@@ -15084,8 +14736,8 @@
         </p:nvSpPr>
         <p:spPr>
           <a:xfrm>
-            <a:off x="9052560" y="4617720"/>
-            <a:ext cx="2468880" cy="868680"/>
+            <a:off x="9052560" y="4663440"/>
+            <a:ext cx="2560320" cy="1188720"/>
           </a:xfrm>
           <a:prstGeom prst="rect">
             <a:avLst/>
@@ -15094,7 +14746,7 @@
           <a:ln/>
         </p:spPr>
         <p:txBody>
-          <a:bodyPr wrap="square" lIns="0" tIns="0" rIns="0" bIns="0" rtlCol="0" anchor="ctr"/>
+          <a:bodyPr wrap="square" lIns="0" tIns="0" rIns="0" bIns="0" rtlCol="0" anchor="t"/>
           <a:lstStyle/>
           <a:p>
             <a:pPr indent="0" marL="0">
@@ -15109,7 +14761,7 @@
                 <a:ea typeface="Calibri" pitchFamily="34" charset="-122"/>
                 <a:cs typeface="Calibri" pitchFamily="34" charset="-120"/>
               </a:rPr>
-              <a:t>Inviting customers to be part of the brand.</a:t>
+              <a:t>We will invite our customers to become a real part of the brand.</a:t>
             </a:r>
             <a:endParaRPr lang="en-US" sz="1500" dirty="0"/>
           </a:p>
@@ -16824,7 +16476,7 @@
                   <a:schemeClr val="accent1"/>
                 </a:solidFill>
               </a:rPr>
-              <a:t>OUR PROPOSAL</a:t>
+              <a:t>07 / 08</a:t>
             </a:r>
             <a:endParaRPr lang="en-US" sz="1300" dirty="0"/>
           </a:p>
@@ -16865,7 +16517,7 @@
                 <a:ea typeface="Arial Black" pitchFamily="34" charset="-122"/>
                 <a:cs typeface="Arial Black" pitchFamily="34" charset="-120"/>
               </a:rPr>
-              <a:t>Let's grow together</a:t>
+              <a:t>Our Proposal</a:t>
             </a:r>
             <a:endParaRPr lang="en-US" sz="3600" dirty="0"/>
           </a:p>
@@ -16879,7 +16531,7 @@
         </p:nvSpPr>
         <p:spPr>
           <a:xfrm>
-            <a:off x="548640" y="2011680"/>
+            <a:off x="548640" y="1920240"/>
             <a:ext cx="1097280" cy="1097280"/>
           </a:xfrm>
           <a:prstGeom prst="ellipse">
@@ -16907,7 +16559,7 @@
         </p:blipFill>
         <p:spPr>
           <a:xfrm>
-            <a:off x="844906" y="2307946"/>
+            <a:off x="844906" y="2216506"/>
             <a:ext cx="504749" cy="504749"/>
           </a:xfrm>
           <a:prstGeom prst="rect">
@@ -16923,8 +16575,8 @@
         </p:nvSpPr>
         <p:spPr>
           <a:xfrm>
-            <a:off x="548640" y="3337560"/>
-            <a:ext cx="4937760" cy="822960"/>
+            <a:off x="548640" y="3246120"/>
+            <a:ext cx="5120640" cy="822960"/>
           </a:xfrm>
           <a:prstGeom prst="rect">
             <a:avLst/>
@@ -16933,7 +16585,7 @@
           <a:ln/>
         </p:spPr>
         <p:txBody>
-          <a:bodyPr wrap="square" lIns="0" tIns="0" rIns="0" bIns="0" rtlCol="0" anchor="ctr"/>
+          <a:bodyPr wrap="square" lIns="0" tIns="0" rIns="0" bIns="0" rtlCol="0" anchor="t"/>
           <a:lstStyle/>
           <a:p>
             <a:pPr indent="0" marL="0">
@@ -16962,8 +16614,8 @@
         </p:nvSpPr>
         <p:spPr>
           <a:xfrm>
-            <a:off x="548640" y="4206240"/>
-            <a:ext cx="4937760" cy="1371600"/>
+            <a:off x="548640" y="4114800"/>
+            <a:ext cx="5120640" cy="1280160"/>
           </a:xfrm>
           <a:prstGeom prst="rect">
             <a:avLst/>
@@ -16972,14 +16624,14 @@
           <a:ln/>
         </p:spPr>
         <p:txBody>
-          <a:bodyPr wrap="square" lIns="0" tIns="0" rIns="0" bIns="0" rtlCol="0" anchor="ctr"/>
+          <a:bodyPr wrap="square" lIns="0" tIns="0" rIns="0" bIns="0" rtlCol="0" anchor="t"/>
           <a:lstStyle/>
           <a:p>
             <a:pPr indent="0" marL="0">
               <a:buNone/>
             </a:pPr>
             <a:r>
-              <a:rPr lang="en-US" sz="1700" dirty="0">
+              <a:rPr lang="en-US" sz="1800" dirty="0">
                 <a:solidFill>
                   <a:srgbClr val="5B6B80"/>
                 </a:solidFill>
@@ -16987,9 +16639,9 @@
                 <a:ea typeface="Calibri" pitchFamily="34" charset="-122"/>
                 <a:cs typeface="Calibri" pitchFamily="34" charset="-120"/>
               </a:rPr>
-              <a:t>We propose a strategic partnership where you gain visibility, a strong position with a young audience, and connection with new customers.</a:t>
+              <a:t>What we propose is a strategic partnership in which you gain visibility, a stronger position among young consumers and a connection with new audiences.</a:t>
             </a:r>
-            <a:endParaRPr lang="en-US" sz="1700" dirty="0"/>
+            <a:endParaRPr lang="en-US" sz="1800" dirty="0"/>
           </a:p>
         </p:txBody>
       </p:sp>
@@ -17040,7 +16692,7 @@
           <a:ln/>
         </p:spPr>
         <p:txBody>
-          <a:bodyPr wrap="square" lIns="0" tIns="0" rIns="0" bIns="0" rtlCol="0" anchor="ctr"/>
+          <a:bodyPr wrap="square" lIns="0" tIns="0" rIns="0" bIns="0" rtlCol="0" anchor="t"/>
           <a:lstStyle/>
           <a:p>
             <a:pPr indent="0" marL="0">
@@ -17055,7 +16707,7 @@
                 <a:ea typeface="Calibri" pitchFamily="34" charset="-122"/>
                 <a:cs typeface="Calibri" pitchFamily="34" charset="-120"/>
               </a:rPr>
-              <a:t>WITH YOUR SUPPORT WE CAN:</a:t>
+              <a:t>WITH YOUR SUPPORT, WE CAN:</a:t>
             </a:r>
             <a:endParaRPr lang="en-US" sz="1400" dirty="0"/>
           </a:p>
@@ -17304,7 +16956,7 @@
                 <a:ea typeface="Calibri" pitchFamily="34" charset="-122"/>
                 <a:cs typeface="Calibri" pitchFamily="34" charset="-120"/>
               </a:rPr>
-              <a:t>Build greater credibility and growth</a:t>
+              <a:t>Generate greater credibility and growth</a:t>
             </a:r>
             <a:endParaRPr lang="en-US" sz="1800" dirty="0"/>
           </a:p>
@@ -18611,7 +18263,7 @@
                   <a:schemeClr val="accent1"/>
                 </a:solidFill>
               </a:rPr>
-              <a:t>OUR GOALS</a:t>
+              <a:t>08 / 08</a:t>
             </a:r>
             <a:endParaRPr lang="en-US" sz="1300" dirty="0"/>
           </a:p>
@@ -18652,7 +18304,7 @@
                 <a:ea typeface="Arial Black" pitchFamily="34" charset="-122"/>
                 <a:cs typeface="Arial Black" pitchFamily="34" charset="-120"/>
               </a:rPr>
-              <a:t>What we expect to achieve</a:t>
+              <a:t>What We Expect to Achieve</a:t>
             </a:r>
             <a:endParaRPr lang="en-US" sz="3600" dirty="0"/>
           </a:p>
@@ -18757,7 +18409,7 @@
         </p:nvSpPr>
         <p:spPr>
           <a:xfrm>
-            <a:off x="1691640" y="1993392"/>
+            <a:off x="1691640" y="1965960"/>
             <a:ext cx="5486400" cy="457200"/>
           </a:xfrm>
           <a:prstGeom prst="rect">
@@ -18767,7 +18419,7 @@
           <a:ln/>
         </p:spPr>
         <p:txBody>
-          <a:bodyPr wrap="square" lIns="0" tIns="0" rIns="0" bIns="0" rtlCol="0" anchor="ctr"/>
+          <a:bodyPr wrap="square" lIns="0" tIns="0" rIns="0" bIns="0" rtlCol="0" anchor="t"/>
           <a:lstStyle/>
           <a:p>
             <a:pPr indent="0" marL="0">
@@ -18796,8 +18448,8 @@
         </p:nvSpPr>
         <p:spPr>
           <a:xfrm>
-            <a:off x="1691640" y="2423160"/>
-            <a:ext cx="5669280" cy="548640"/>
+            <a:off x="1691640" y="2395728"/>
+            <a:ext cx="5669280" cy="731520"/>
           </a:xfrm>
           <a:prstGeom prst="rect">
             <a:avLst/>
@@ -18806,7 +18458,7 @@
           <a:ln/>
         </p:spPr>
         <p:txBody>
-          <a:bodyPr wrap="square" lIns="0" tIns="0" rIns="0" bIns="0" rtlCol="0" anchor="ctr"/>
+          <a:bodyPr wrap="square" lIns="0" tIns="0" rIns="0" bIns="0" rtlCol="0" anchor="t"/>
           <a:lstStyle/>
           <a:p>
             <a:pPr indent="0" marL="0">
@@ -18821,7 +18473,7 @@
                 <a:ea typeface="Calibri" pitchFamily="34" charset="-122"/>
                 <a:cs typeface="Calibri" pitchFamily="34" charset="-120"/>
               </a:rPr>
-              <a:t>Build an active community around NutriPill.</a:t>
+              <a:t>Consolidate an active community around our brand.</a:t>
             </a:r>
             <a:endParaRPr lang="en-US" sz="1600" dirty="0"/>
           </a:p>
@@ -18879,7 +18531,7 @@
         </p:nvSpPr>
         <p:spPr>
           <a:xfrm>
-            <a:off x="1691640" y="3456432"/>
+            <a:off x="1691640" y="3429000"/>
             <a:ext cx="5486400" cy="457200"/>
           </a:xfrm>
           <a:prstGeom prst="rect">
@@ -18889,7 +18541,7 @@
           <a:ln/>
         </p:spPr>
         <p:txBody>
-          <a:bodyPr wrap="square" lIns="0" tIns="0" rIns="0" bIns="0" rtlCol="0" anchor="ctr"/>
+          <a:bodyPr wrap="square" lIns="0" tIns="0" rIns="0" bIns="0" rtlCol="0" anchor="t"/>
           <a:lstStyle/>
           <a:p>
             <a:pPr indent="0" marL="0">
@@ -18918,8 +18570,8 @@
         </p:nvSpPr>
         <p:spPr>
           <a:xfrm>
-            <a:off x="1691640" y="3886200"/>
-            <a:ext cx="5669280" cy="548640"/>
+            <a:off x="1691640" y="3858768"/>
+            <a:ext cx="5669280" cy="731520"/>
           </a:xfrm>
           <a:prstGeom prst="rect">
             <a:avLst/>
@@ -18928,7 +18580,7 @@
           <a:ln/>
         </p:spPr>
         <p:txBody>
-          <a:bodyPr wrap="square" lIns="0" tIns="0" rIns="0" bIns="0" rtlCol="0" anchor="ctr"/>
+          <a:bodyPr wrap="square" lIns="0" tIns="0" rIns="0" bIns="0" rtlCol="0" anchor="t"/>
           <a:lstStyle/>
           <a:p>
             <a:pPr indent="0" marL="0">
@@ -18943,7 +18595,7 @@
                 <a:ea typeface="Calibri" pitchFamily="34" charset="-122"/>
                 <a:cs typeface="Calibri" pitchFamily="34" charset="-120"/>
               </a:rPr>
-              <a:t>Grow our digital reach and double our customer base.</a:t>
+              <a:t>Increase our digital reach and double our customer base.</a:t>
             </a:r>
             <a:endParaRPr lang="en-US" sz="1600" dirty="0"/>
           </a:p>
@@ -18971,7 +18623,7 @@
       </p:sp>
       <p:pic>
         <p:nvPicPr>
-          <p:cNvPr id="15" name="a4_icon" descr="Long term">    </p:cNvPr>
+          <p:cNvPr id="15" name="a4_icon" descr="In the long term">    </p:cNvPr>
           <p:cNvPicPr>
             <a:picLocks noChangeAspect="1"/>
           </p:cNvPicPr>
@@ -19001,7 +18653,7 @@
         </p:nvSpPr>
         <p:spPr>
           <a:xfrm>
-            <a:off x="1691640" y="4919472"/>
+            <a:off x="1691640" y="4892040"/>
             <a:ext cx="5486400" cy="457200"/>
           </a:xfrm>
           <a:prstGeom prst="rect">
@@ -19011,7 +18663,7 @@
           <a:ln/>
         </p:spPr>
         <p:txBody>
-          <a:bodyPr wrap="square" lIns="0" tIns="0" rIns="0" bIns="0" rtlCol="0" anchor="ctr"/>
+          <a:bodyPr wrap="square" lIns="0" tIns="0" rIns="0" bIns="0" rtlCol="0" anchor="t"/>
           <a:lstStyle/>
           <a:p>
             <a:pPr indent="0" marL="0">
@@ -19026,7 +18678,7 @@
                 <a:ea typeface="Calibri" pitchFamily="34" charset="-122"/>
                 <a:cs typeface="Calibri" pitchFamily="34" charset="-120"/>
               </a:rPr>
-              <a:t>Long term</a:t>
+              <a:t>In the long term</a:t>
             </a:r>
             <a:endParaRPr lang="en-US" sz="2200" dirty="0"/>
           </a:p>
@@ -19040,8 +18692,8 @@
         </p:nvSpPr>
         <p:spPr>
           <a:xfrm>
-            <a:off x="1691640" y="5349240"/>
-            <a:ext cx="5669280" cy="548640"/>
+            <a:off x="1691640" y="5321808"/>
+            <a:ext cx="5669280" cy="731520"/>
           </a:xfrm>
           <a:prstGeom prst="rect">
             <a:avLst/>
@@ -19050,7 +18702,7 @@
           <a:ln/>
         </p:spPr>
         <p:txBody>
-          <a:bodyPr wrap="square" lIns="0" tIns="0" rIns="0" bIns="0" rtlCol="0" anchor="ctr"/>
+          <a:bodyPr wrap="square" lIns="0" tIns="0" rIns="0" bIns="0" rtlCol="0" anchor="t"/>
           <a:lstStyle/>
           <a:p>
             <a:pPr indent="0" marL="0">
@@ -19065,7 +18717,7 @@
                 <a:ea typeface="Calibri" pitchFamily="34" charset="-122"/>
                 <a:cs typeface="Calibri" pitchFamily="34" charset="-120"/>
               </a:rPr>
-              <a:t>Become a leader in the local market, then expand nationwide.</a:t>
+              <a:t>Establish ourselves as a leading brand in the local market, with expansion at a national level.</a:t>
             </a:r>
             <a:endParaRPr lang="en-US" sz="1600" dirty="0"/>
           </a:p>

</xml_diff>

<commit_message>
Rewrite slide text and speaker notes in a natural student voice
Co-Authored-By: Claude Opus 5.5 <noreply@anthropic.com>
Claude-Session: https://claude.ai/code/session_01TFmXfwWy7YkFL9ETqt4WJz
</commit_message>
<xml_diff>
--- a/NutriPill.pptx
+++ b/NutriPill.pptx
@@ -115,12 +115,12 @@
   <p:extLst>
     <p:ext uri="{521415D9-36F7-43E2-AB2F-B90AF26B5E84}">
       <p14:sectionLst xmlns:p14="http://schemas.microsoft.com/office/powerpoint/2010/main">
-        <p14:section name="Welcome" id="{7618d354-20c1-b2da-a740-03744aef400d}">
+        <p14:section name="Welcome" id="{ec5bf18b-fa49-3f1b-b7c4-db0735602784}">
           <p14:sldIdLst>
             <p14:sldId id="256"/>
           </p14:sldIdLst>
         </p14:section>
-        <p14:section name="The idea" id="{9c33d551-94bf-8a37-9215-53f94cbc8e53}">
+        <p14:section name="The idea" id="{37981842-716d-c190-c333-457e2b2e7667}">
           <p14:sldIdLst>
             <p14:sldId id="257"/>
             <p14:sldId id="258"/>
@@ -128,7 +128,7 @@
             <p14:sldId id="260"/>
           </p14:sldIdLst>
         </p14:section>
-        <p14:section name="The business" id="{4ed206d7-a2ad-d083-f884-9ca144e82f40}">
+        <p14:section name="The business" id="{72294eca-bdd6-7212-b855-e52d1783c183}">
           <p14:sldIdLst>
             <p14:sldId id="261"/>
             <p14:sldId id="262"/>
@@ -540,7 +540,7 @@
           <a:p>
             <a:r>
               <a:rPr lang="en-US" dirty="0"/>
-              <a:t>Good morning, everyone. We are Dani, Max, William and Miguel, and today we would like to present our business proposal: NutriPill, a product that brings essential nutrients to people with busy lives. Over the next few minutes, we will explain the problem we have identified, our solution, who it is for, and how we plan to turn this idea into a successful brand.</a:t>
+              <a:t>Hi everyone. We're Dani, Max, William and Miguel, and today we're going to present our business idea: NutriPill. The idea came from our own experience. As students, we often have days that are so busy that we don't have time to eat properly, so we asked ourselves: what if there was a simple way to get the nutrients you need on those days?</a:t>
             </a:r>
             <a:endParaRPr lang="en-US" dirty="0"/>
           </a:p>
@@ -628,7 +628,7 @@
           <a:p>
             <a:r>
               <a:rPr lang="en-US" dirty="0"/>
-              <a:t>Let's start with a simple question: have you ever been so busy that you simply didn't have time to eat? Most of us have experienced this at some point. Now, imagine a pill that could give your body the essential nutrients it needs on those days when there is no time for a proper meal. That is exactly what NutriPill is: a convenient way to get essential nutrients on the go. It is small, simple, and designed to fit perfectly into a busy lifestyle.</a:t>
+              <a:t>So, let me start with a question: have you ever been too busy to eat? Think about a normal day for a lot of us: classes in the morning, training or work in the afternoon, and homework at night. On days like that, lunch is often the first thing we skip. That's why we came up with NutriPill. It's one small pill with the nutrients your body needs, for the days when you can't sit down for a proper meal.</a:t>
             </a:r>
             <a:endParaRPr lang="en-US" dirty="0"/>
           </a:p>
@@ -716,7 +716,7 @@
           <a:p>
             <a:r>
               <a:rPr lang="en-US" dirty="0"/>
-              <a:t>So, what is the problem? Nowadays, many people have such busy schedules that they don't have enough time to prepare or eat proper meals. Students and workers, in particular, often skip meals because they are always in a hurry. As a result, they suffer from low energy, they find it difficult to concentrate, and, over time, their nutrition becomes poor. Clearly, what these people need is a quick and convenient way to get essential nutrients when there is simply no time to eat.</a:t>
+              <a:t>Now let's talk about the problem. These days, a lot of people simply don't have time to cook, or even to sit down and eat. Students go from one class to the next, and many workers eat at their desk or don't eat at all. And this has consequences. By the afternoon, you feel tired and slow. It's hard to concentrate in class or at work when you're hungry. And when people do eat in a hurry, they usually choose crisps, sweets or fast food, so their nutrition is poor. What these people need is something quick and easy that still gives their body what it needs.</a:t>
             </a:r>
             <a:endParaRPr lang="en-US" dirty="0"/>
           </a:p>
@@ -804,7 +804,7 @@
           <a:p>
             <a:r>
               <a:rPr lang="en-US" dirty="0"/>
-              <a:t>This is where our solution comes in. NutriPill is an innovative and convenient pill designed to provide essential nutrients when people don't have time to eat. It is small, easy to carry, and perfect for busy students and workers. Our main goal is to help people maintain their energy and get extra nutrients throughout the day. However, we want to be honest: NutriPill does not replace a complete meal. Instead, it offers a practical way to supplement your nutrition when life gets busy.</a:t>
+              <a:t>This is where NutriPill comes in. It's quick to take: you just need a glass of water. It's small, so you can carry it in your backpack, your gym bag or even your jacket. It gives you extra nutrients to help you stay active until your next meal, and it's made for those really busy days, like exam weeks or long shifts at work. But we want to be honest about one thing: NutriPill doesn't replace a real meal. It's there to help on the days when a proper meal just isn't possible.</a:t>
             </a:r>
             <a:endParaRPr lang="en-US" dirty="0"/>
           </a:p>
@@ -892,7 +892,7 @@
           <a:p>
             <a:r>
               <a:rPr lang="en-US" dirty="0"/>
-              <a:t>But who exactly is our brand directed to? NutriPill is designed for busy people who don't always have time to eat properly. Our main target audience includes students, who spend long days in class and studying; workers, who often skip lunch because of tight deadlines and meetings; athletes, who need a steady supply of nutrients for their training; and, in general, anyone with a hectic lifestyle. It is especially useful for those who need a quick and convenient way to supplement their nutrition during a busy day.</a:t>
+              <a:t>So, who is NutriPill for? Basically, people who want to eat well but often can't find the time, people a lot like us. First, students, because with early classes, exams and homework, lunch is usually the first thing we skip. Second, workers who do long hours and skip lunch to get everything done. Third, athletes, who train hard and need extra nutrients to recover. And finally, anyone with a hectic lifestyle, like parents or people who spend hours commuting.</a:t>
             </a:r>
             <a:endParaRPr lang="en-US" dirty="0"/>
           </a:p>
@@ -980,7 +980,7 @@
           <a:p>
             <a:r>
               <a:rPr lang="en-US" dirty="0"/>
-              <a:t>Now let's move on to our action plan. Our business model is built on three key pillars. Firstly, revenue: we will generate income through direct sales of NutriPill, as well as through experiences linked to the product. Secondly, channels: we will build a strong presence on the main social networks, combined with face-to-face experiences, so that people can get to know the brand in person. Finally, pricing: our prices will be affordable but with added value. In other words, NutriPill will be a premium option that remains accessible to everyone.</a:t>
+              <a:t>Now, how are we actually going to make this work? Our plan has three parts. First, revenue: we'll make money by selling NutriPill directly, both online and in person, and also through events and pop-up stands. Second, channels: we know our customers spend a lot of time on Instagram and TikTok, so that's where we'll focus. But we also want people to try the product in real life, so we'll set up stands at schools and gyms. And third, pricing: we want NutriPill to be cheap enough for a student to buy, but with the quality of a premium product.</a:t>
             </a:r>
             <a:endParaRPr lang="en-US" dirty="0"/>
           </a:p>
@@ -1068,7 +1068,7 @@
           <a:p>
             <a:r>
               <a:rPr lang="en-US" dirty="0"/>
-              <a:t>Of course, having a good product is not enough; we also need a clear growth strategy. It consists of four steps. First of all, we will create inspiring content on social media that shows a real, everyday lifestyle. Next, we will work with local influencers who truly represent our brand's philosophy. After that, we will create memorable experiences, such as events, personalised kits and collaborations. Last but not least, we will actively build a community by inviting our customers to become a real part of the brand.</a:t>
+              <a:t>To grow the brand, we have four steps. First, we'll post real content: short videos of a normal busy day, showing early classes, training, and NutriPill in between. We don't want fake, perfect adverts. Second, we'll work with local influencers, but only athletes and creators who actually live busy lives, not just anyone with a lot of followers. Third, we'll organise events, like free sample days, and offer personalised kits and collaborations with gyms and sports clubs. And finally, we'll listen to our customers: we'll ask for their opinions, share their stories, and let them help us shape new products.</a:t>
             </a:r>
             <a:endParaRPr lang="en-US" dirty="0"/>
           </a:p>
@@ -1156,7 +1156,7 @@
           <a:p>
             <a:r>
               <a:rPr lang="en-US" dirty="0"/>
-              <a:t>This brings us to our proposal. We are looking for brands that want to grow with us. What we propose is a strategic partnership in which our partners gain visibility, a stronger position among young consumers, and a connection with new audiences. With your support, we can develop joint products and experiences, increase our reach through advertising campaigns, and generate greater credibility and growth for both of us.</a:t>
+              <a:t>This brings us to our proposal. We're looking for brands that want to grow with us, for example a gym, a sports brand or a healthy café. The idea is simple: they help us reach more people, and in return they get noticed by young customers, who are usually hard to reach. Together, we could create joint products, like a gym pack that includes NutriPill. We could run campaigns together to reach more people. And we would both earn people's trust, because people believe in a new brand more when it's supported by a brand they already know.</a:t>
             </a:r>
             <a:endParaRPr lang="en-US" dirty="0"/>
           </a:p>
@@ -1244,7 +1244,7 @@
           <a:p>
             <a:r>
               <a:rPr lang="en-US" dirty="0"/>
-              <a:t>Finally, we would like to share what we expect to achieve. In six months, we aim to consolidate an active community around our brand. In twelve months, we hope to increase our digital reach and double our customer base. And in the long term, our goal is to establish ourselves as a leading brand in the local market, with expansion at a national level. To sum up, NutriPill is a simple solution to a very common problem. Thank you very much for your attention. Do you have any questions?</a:t>
+              <a:t>Finally, here's what we hope to achieve. In six months, we want to have a group of loyal customers who use NutriPill and talk about it online. In twelve months, we want to reach more people online and double the number of customers we have. And in the long term, our goal is to become a well-known brand in our city first, and then grow across the whole country. To sum up, NutriPill is a simple answer to a problem that a lot of us have every day. Thank you very much for listening. Do you have any questions?</a:t>
             </a:r>
             <a:endParaRPr lang="en-US" dirty="0"/>
           </a:p>
@@ -2248,7 +2248,7 @@
                 <a:ea typeface="Calibri" pitchFamily="34" charset="-122"/>
                 <a:cs typeface="Calibri" pitchFamily="34" charset="-120"/>
               </a:rPr>
-              <a:t>Essential nutrients for busy lives</a:t>
+              <a:t>Essential nutrients for busy days</a:t>
             </a:r>
             <a:endParaRPr lang="en-US" sz="2400" dirty="0"/>
           </a:p>
@@ -2982,7 +2982,7 @@
         <p:spPr>
           <a:xfrm>
             <a:off x="548640" y="1874520"/>
-            <a:ext cx="6400800" cy="914400"/>
+            <a:ext cx="6400800" cy="548640"/>
           </a:xfrm>
           <a:prstGeom prst="rect">
             <a:avLst/>
@@ -3006,7 +3006,7 @@
                 <a:ea typeface="Calibri" pitchFamily="34" charset="-122"/>
                 <a:cs typeface="Calibri" pitchFamily="34" charset="-120"/>
               </a:rPr>
-              <a:t>Have you ever been so busy that you simply didn't have time to eat?</a:t>
+              <a:t>Have you ever been too busy to eat?</a:t>
             </a:r>
             <a:endParaRPr lang="en-US" sz="2400" dirty="0"/>
           </a:p>
@@ -3020,8 +3020,8 @@
         </p:nvSpPr>
         <p:spPr>
           <a:xfrm>
-            <a:off x="548640" y="2788920"/>
-            <a:ext cx="6400800" cy="822960"/>
+            <a:off x="548640" y="2560320"/>
+            <a:ext cx="6400800" cy="1097280"/>
           </a:xfrm>
           <a:prstGeom prst="rect">
             <a:avLst/>
@@ -3045,7 +3045,7 @@
                 <a:ea typeface="Calibri" pitchFamily="34" charset="-122"/>
                 <a:cs typeface="Calibri" pitchFamily="34" charset="-120"/>
               </a:rPr>
-              <a:t>Imagine a pill that could give your body the essential nutrients it needs on those days when there is no time for a proper meal.</a:t>
+              <a:t>Think about a day with classes in the morning, training in the afternoon and homework at night. Sometimes, lunch just doesn't happen.</a:t>
             </a:r>
             <a:endParaRPr lang="en-US" sz="1800" dirty="0"/>
           </a:p>
@@ -3137,7 +3137,7 @@
                 <a:ea typeface="Calibri" pitchFamily="34" charset="-122"/>
                 <a:cs typeface="Calibri" pitchFamily="34" charset="-120"/>
               </a:rPr>
-              <a:t>Meet NutriPill: a convenient way to get essential nutrients on the go. Small, simple, and designed to fit perfectly into your busy lifestyle.</a:t>
+              <a:t>That's why we came up with NutriPill: one small pill with the nutrients your body needs, for the days when you can't sit down for a proper meal.</a:t>
             </a:r>
             <a:endParaRPr lang="en-US" sz="1500" dirty="0"/>
           </a:p>
@@ -4505,7 +4505,7 @@
                 <a:ea typeface="Calibri" pitchFamily="34" charset="-122"/>
                 <a:cs typeface="Calibri" pitchFamily="34" charset="-120"/>
               </a:rPr>
-              <a:t>Nowadays, many people have such busy schedules that they don't have enough time to prepare or eat proper meals. Students and workers, in particular, often skip meals because they are always in a hurry.</a:t>
+              <a:t>A lot of people don't have time to cook, or even to sit down and eat. Students rush from one class to the next, and many workers eat at their desk, or don't eat at all.</a:t>
             </a:r>
             <a:endParaRPr lang="en-US" sz="1800" dirty="0"/>
           </a:p>
@@ -4658,7 +4658,7 @@
                 <a:ea typeface="Calibri" pitchFamily="34" charset="-122"/>
                 <a:cs typeface="Calibri" pitchFamily="34" charset="-120"/>
               </a:rPr>
-              <a:t>Without regular meals, the body runs out of fuel long before the day is over.</a:t>
+              <a:t>By the afternoon you feel tired and slow, even if you slept well.</a:t>
             </a:r>
             <a:endParaRPr lang="en-US" sz="1400" dirty="0"/>
           </a:p>
@@ -4772,7 +4772,7 @@
                 <a:ea typeface="Calibri" pitchFamily="34" charset="-122"/>
                 <a:cs typeface="Calibri" pitchFamily="34" charset="-120"/>
               </a:rPr>
-              <a:t>Difficulty concentrating</a:t>
+              <a:t>Hard to concentrate</a:t>
             </a:r>
             <a:endParaRPr lang="en-US" sz="1900" dirty="0"/>
           </a:p>
@@ -4811,7 +4811,7 @@
                 <a:ea typeface="Calibri" pitchFamily="34" charset="-122"/>
                 <a:cs typeface="Calibri" pitchFamily="34" charset="-120"/>
               </a:rPr>
-              <a:t>Skipping meals makes it much harder to stay focused in class or at work.</a:t>
+              <a:t>It's really difficult to pay attention in class or at work when you're hungry.</a:t>
             </a:r>
             <a:endParaRPr lang="en-US" sz="1400" dirty="0"/>
           </a:p>
@@ -4964,7 +4964,7 @@
                 <a:ea typeface="Calibri" pitchFamily="34" charset="-122"/>
                 <a:cs typeface="Calibri" pitchFamily="34" charset="-120"/>
               </a:rPr>
-              <a:t>Over time, the body misses out on the nutrients it needs to stay healthy.</a:t>
+              <a:t>When people do eat in a hurry, it's usually crisps, sweets or fast food.</a:t>
             </a:r>
             <a:endParaRPr lang="en-US" sz="1400" dirty="0"/>
           </a:p>
@@ -5025,7 +5025,7 @@
                 <a:ea typeface="Calibri" pitchFamily="34" charset="-122"/>
                 <a:cs typeface="Calibri" pitchFamily="34" charset="-120"/>
               </a:rPr>
-              <a:t>What they need is a quick and convenient way to get essential nutrients when there is no time to eat.</a:t>
+              <a:t>They need something quick and easy that still gives their body what it needs.</a:t>
             </a:r>
             <a:endParaRPr lang="en-US" sz="1700" dirty="0"/>
           </a:p>
@@ -6714,7 +6714,7 @@
                 <a:ea typeface="Calibri" pitchFamily="34" charset="-122"/>
                 <a:cs typeface="Calibri" pitchFamily="34" charset="-120"/>
               </a:rPr>
-              <a:t>Innovative</a:t>
+              <a:t>Quick to take</a:t>
             </a:r>
             <a:endParaRPr lang="en-US" sz="1500" dirty="0"/>
           </a:p>
@@ -6753,7 +6753,7 @@
                 <a:ea typeface="Calibri" pitchFamily="34" charset="-122"/>
                 <a:cs typeface="Calibri" pitchFamily="34" charset="-120"/>
               </a:rPr>
-              <a:t>A brand-new way of getting essential nutrients in seconds.</a:t>
+              <a:t>Just take it with a glass of water and you're done.</a:t>
             </a:r>
             <a:endParaRPr lang="en-US" sz="1400" dirty="0"/>
           </a:p>
@@ -6865,7 +6865,7 @@
                 <a:ea typeface="Calibri" pitchFamily="34" charset="-122"/>
                 <a:cs typeface="Calibri" pitchFamily="34" charset="-120"/>
               </a:rPr>
-              <a:t>Small and easy to carry</a:t>
+              <a:t>Fits in your pocket</a:t>
             </a:r>
             <a:endParaRPr lang="en-US" sz="1500" dirty="0"/>
           </a:p>
@@ -6904,7 +6904,7 @@
                 <a:ea typeface="Calibri" pitchFamily="34" charset="-122"/>
                 <a:cs typeface="Calibri" pitchFamily="34" charset="-120"/>
               </a:rPr>
-              <a:t>It fits easily into a pocket, backpack or bag.</a:t>
+              <a:t>Carry it in your backpack, gym bag or jacket.</a:t>
             </a:r>
             <a:endParaRPr lang="en-US" sz="1400" dirty="0"/>
           </a:p>
@@ -7016,7 +7016,7 @@
                 <a:ea typeface="Calibri" pitchFamily="34" charset="-122"/>
                 <a:cs typeface="Calibri" pitchFamily="34" charset="-120"/>
               </a:rPr>
-              <a:t>Keeps your energy up</a:t>
+              <a:t>Keeps you going</a:t>
             </a:r>
             <a:endParaRPr lang="en-US" sz="1500" dirty="0"/>
           </a:p>
@@ -7055,7 +7055,7 @@
                 <a:ea typeface="Calibri" pitchFamily="34" charset="-122"/>
                 <a:cs typeface="Calibri" pitchFamily="34" charset="-120"/>
               </a:rPr>
-              <a:t>It helps you maintain your energy throughout the day.</a:t>
+              <a:t>Extra nutrients to keep you active until your next meal.</a:t>
             </a:r>
             <a:endParaRPr lang="en-US" sz="1400" dirty="0"/>
           </a:p>
@@ -7167,7 +7167,7 @@
                 <a:ea typeface="Calibri" pitchFamily="34" charset="-122"/>
                 <a:cs typeface="Calibri" pitchFamily="34" charset="-120"/>
               </a:rPr>
-              <a:t>Perfect for busy people</a:t>
+              <a:t>Made for busy days</a:t>
             </a:r>
             <a:endParaRPr lang="en-US" sz="1500" dirty="0"/>
           </a:p>
@@ -7206,7 +7206,7 @@
                 <a:ea typeface="Calibri" pitchFamily="34" charset="-122"/>
                 <a:cs typeface="Calibri" pitchFamily="34" charset="-120"/>
               </a:rPr>
-              <a:t>Ideal for students and workers with demanding schedules.</a:t>
+              <a:t>For exam weeks, long shifts or non-stop days.</a:t>
             </a:r>
             <a:endParaRPr lang="en-US" sz="1400" dirty="0"/>
           </a:p>
@@ -7267,7 +7267,7 @@
                 <a:ea typeface="Calibri" pitchFamily="34" charset="-122"/>
                 <a:cs typeface="Calibri" pitchFamily="34" charset="-120"/>
               </a:rPr>
-              <a:t>Please note: </a:t>
+              <a:t>To be clear: </a:t>
             </a:r>
             <a:pPr indent="0" marL="0">
               <a:buNone/>
@@ -7281,7 +7281,7 @@
                 <a:ea typeface="Calibri" pitchFamily="34" charset="-122"/>
                 <a:cs typeface="Calibri" pitchFamily="34" charset="-120"/>
               </a:rPr>
-              <a:t>although NutriPill does not replace a complete meal, it offers a practical way to supplement your nutrition when life gets busy.</a:t>
+              <a:t>NutriPill doesn't replace a real meal. It's there for the days when a proper meal just isn't possible.</a:t>
             </a:r>
             <a:endParaRPr lang="en-US" sz="1400" dirty="0"/>
           </a:p>
@@ -9211,7 +9211,7 @@
                 <a:ea typeface="Calibri" pitchFamily="34" charset="-122"/>
                 <a:cs typeface="Calibri" pitchFamily="34" charset="-120"/>
               </a:rPr>
-              <a:t>NutriPill is designed for busy people who don't always have time to eat properly, especially those who need a quick and convenient way to supplement their nutrition during a hectic day.</a:t>
+              <a:t>We're thinking about people who want to eat well but often can't find the time, people a lot like us.</a:t>
             </a:r>
             <a:endParaRPr lang="en-US" sz="1800" dirty="0"/>
           </a:p>
@@ -9362,7 +9362,7 @@
                 <a:ea typeface="Calibri" pitchFamily="34" charset="-122"/>
                 <a:cs typeface="Calibri" pitchFamily="34" charset="-120"/>
               </a:rPr>
-              <a:t>Long days of classes, exams and homework often leave little time for lunch.</a:t>
+              <a:t>Early classes, exams and homework. Lunch is often the first thing we skip.</a:t>
             </a:r>
             <a:endParaRPr lang="en-US" sz="1400" dirty="0"/>
           </a:p>
@@ -9513,7 +9513,7 @@
                 <a:ea typeface="Calibri" pitchFamily="34" charset="-122"/>
                 <a:cs typeface="Calibri" pitchFamily="34" charset="-120"/>
               </a:rPr>
-              <a:t>Tight deadlines and back-to-back meetings mean meals are often skipped.</a:t>
+              <a:t>People who work long hours and skip lunch to get everything done.</a:t>
             </a:r>
             <a:endParaRPr lang="en-US" sz="1400" dirty="0"/>
           </a:p>
@@ -9664,7 +9664,7 @@
                 <a:ea typeface="Calibri" pitchFamily="34" charset="-122"/>
                 <a:cs typeface="Calibri" pitchFamily="34" charset="-120"/>
               </a:rPr>
-              <a:t>Intense training requires a steady supply of essential nutrients.</a:t>
+              <a:t>They train hard and need extra nutrients to recover and perform well.</a:t>
             </a:r>
             <a:endParaRPr lang="en-US" sz="1400" dirty="0"/>
           </a:p>
@@ -9815,7 +9815,7 @@
                 <a:ea typeface="Calibri" pitchFamily="34" charset="-122"/>
                 <a:cs typeface="Calibri" pitchFamily="34" charset="-120"/>
               </a:rPr>
-              <a:t>Anyone who is constantly on the move and short on time.</a:t>
+              <a:t>Parents, commuters, anyone whose day never seems to stop.</a:t>
             </a:r>
             <a:endParaRPr lang="en-US" sz="1400" dirty="0"/>
           </a:p>
@@ -11610,7 +11610,7 @@
                 <a:ea typeface="Calibri" pitchFamily="34" charset="-122"/>
                 <a:cs typeface="Calibri" pitchFamily="34" charset="-120"/>
               </a:rPr>
-              <a:t>Our business model is built on three key pillars:</a:t>
+              <a:t>How NutriPill will make money and reach people:</a:t>
             </a:r>
             <a:endParaRPr lang="en-US" sz="1800" dirty="0"/>
           </a:p>
@@ -11800,7 +11800,7 @@
                 <a:ea typeface="Calibri" pitchFamily="34" charset="-122"/>
                 <a:cs typeface="Calibri" pitchFamily="34" charset="-120"/>
               </a:rPr>
-              <a:t>We will generate income through direct sales of NutriPill, as well as experiences linked to the product.</a:t>
+              <a:t>We'll sell NutriPill directly, online and in person, and also earn money from events and pop-up stands.</a:t>
             </a:r>
             <a:endParaRPr lang="en-US" sz="1600" dirty="0"/>
           </a:p>
@@ -11990,7 +11990,7 @@
                 <a:ea typeface="Calibri" pitchFamily="34" charset="-122"/>
                 <a:cs typeface="Calibri" pitchFamily="34" charset="-120"/>
               </a:rPr>
-              <a:t>We will build a strong presence on the main social networks, combined with face-to-face experiences.</a:t>
+              <a:t>Our customers are on Instagram and TikTok, so that's where we'll be. We'll also have stands at schools and gyms.</a:t>
             </a:r>
             <a:endParaRPr lang="en-US" sz="1600" dirty="0"/>
           </a:p>
@@ -12180,7 +12180,7 @@
                 <a:ea typeface="Calibri" pitchFamily="34" charset="-122"/>
                 <a:cs typeface="Calibri" pitchFamily="34" charset="-120"/>
               </a:rPr>
-              <a:t>Our prices will be affordable but with added value: a premium option that remains accessible to everyone.</a:t>
+              <a:t>Cheap enough for a student to buy, but with the quality of a premium product.</a:t>
             </a:r>
             <a:endParaRPr lang="en-US" sz="1600" dirty="0"/>
           </a:p>
@@ -14130,7 +14130,7 @@
       </p:sp>
       <p:pic>
         <p:nvPicPr>
-          <p:cNvPr id="6" name="a2_icon" descr="Create inspiring content">    </p:cNvPr>
+          <p:cNvPr id="6" name="a2_icon" descr="Post real content">    </p:cNvPr>
           <p:cNvPicPr>
             <a:picLocks noChangeAspect="1"/>
           </p:cNvPicPr>
@@ -14224,7 +14224,7 @@
                 <a:ea typeface="Calibri" pitchFamily="34" charset="-122"/>
                 <a:cs typeface="Calibri" pitchFamily="34" charset="-120"/>
               </a:rPr>
-              <a:t>Create inspiring content</a:t>
+              <a:t>Post real content</a:t>
             </a:r>
             <a:endParaRPr lang="en-US" sz="1900" dirty="0"/>
           </a:p>
@@ -14263,7 +14263,7 @@
                 <a:ea typeface="Calibri" pitchFamily="34" charset="-122"/>
                 <a:cs typeface="Calibri" pitchFamily="34" charset="-120"/>
               </a:rPr>
-              <a:t>We will share content on social media that shows a real, everyday lifestyle.</a:t>
+              <a:t>Short videos of a normal busy day: early class, training, and NutriPill in between.</a:t>
             </a:r>
             <a:endParaRPr lang="en-US" sz="1500" dirty="0"/>
           </a:p>
@@ -14429,7 +14429,7 @@
                 <a:ea typeface="Calibri" pitchFamily="34" charset="-122"/>
                 <a:cs typeface="Calibri" pitchFamily="34" charset="-120"/>
               </a:rPr>
-              <a:t>We will partner with influencers who truly represent our brand's philosophy.</a:t>
+              <a:t>Local athletes and creators who actually live busy lives, not just anyone with followers.</a:t>
             </a:r>
             <a:endParaRPr lang="en-US" sz="1500" dirty="0"/>
           </a:p>
@@ -14462,7 +14462,7 @@
       </p:sp>
       <p:pic>
         <p:nvPicPr>
-          <p:cNvPr id="16" name="a4_icon" descr="Create memorable experiences">    </p:cNvPr>
+          <p:cNvPr id="16" name="a4_icon" descr="Organise events">    </p:cNvPr>
           <p:cNvPicPr>
             <a:picLocks noChangeAspect="1"/>
           </p:cNvPicPr>
@@ -14556,7 +14556,7 @@
                 <a:ea typeface="Calibri" pitchFamily="34" charset="-122"/>
                 <a:cs typeface="Calibri" pitchFamily="34" charset="-120"/>
               </a:rPr>
-              <a:t>Create memorable experiences</a:t>
+              <a:t>Organise events</a:t>
             </a:r>
             <a:endParaRPr lang="en-US" sz="1900" dirty="0"/>
           </a:p>
@@ -14595,7 +14595,7 @@
                 <a:ea typeface="Calibri" pitchFamily="34" charset="-122"/>
                 <a:cs typeface="Calibri" pitchFamily="34" charset="-120"/>
               </a:rPr>
-              <a:t>We will organise events, offer personalised kits and develop collaborations.</a:t>
+              <a:t>Free sample days, personalised kits and collaborations with gyms and sports clubs.</a:t>
             </a:r>
             <a:endParaRPr lang="en-US" sz="1500" dirty="0"/>
           </a:p>
@@ -14628,7 +14628,7 @@
       </p:sp>
       <p:pic>
         <p:nvPicPr>
-          <p:cNvPr id="21" name="a5_icon" descr="Actively build a community">    </p:cNvPr>
+          <p:cNvPr id="21" name="a5_icon" descr="Listen to our customers">    </p:cNvPr>
           <p:cNvPicPr>
             <a:picLocks noChangeAspect="1"/>
           </p:cNvPicPr>
@@ -14722,7 +14722,7 @@
                 <a:ea typeface="Calibri" pitchFamily="34" charset="-122"/>
                 <a:cs typeface="Calibri" pitchFamily="34" charset="-120"/>
               </a:rPr>
-              <a:t>Actively build a community</a:t>
+              <a:t>Listen to our customers</a:t>
             </a:r>
             <a:endParaRPr lang="en-US" sz="1900" dirty="0"/>
           </a:p>
@@ -14761,7 +14761,7 @@
                 <a:ea typeface="Calibri" pitchFamily="34" charset="-122"/>
                 <a:cs typeface="Calibri" pitchFamily="34" charset="-120"/>
               </a:rPr>
-              <a:t>We will invite our customers to become a real part of the brand.</a:t>
+              <a:t>Ask for their opinions, share their stories and let them help shape new products.</a:t>
             </a:r>
             <a:endParaRPr lang="en-US" sz="1500" dirty="0"/>
           </a:p>
@@ -16615,7 +16615,7 @@
         <p:spPr>
           <a:xfrm>
             <a:off x="548640" y="4114800"/>
-            <a:ext cx="5120640" cy="1280160"/>
+            <a:ext cx="5120640" cy="1737360"/>
           </a:xfrm>
           <a:prstGeom prst="rect">
             <a:avLst/>
@@ -16639,7 +16639,7 @@
                 <a:ea typeface="Calibri" pitchFamily="34" charset="-122"/>
                 <a:cs typeface="Calibri" pitchFamily="34" charset="-120"/>
               </a:rPr>
-              <a:t>What we propose is a strategic partnership in which you gain visibility, a stronger position among young consumers and a connection with new audiences.</a:t>
+              <a:t>For example, a gym, a sports brand or a healthy café. They help us reach more people, and in return they get noticed by young customers who are hard to reach.</a:t>
             </a:r>
             <a:endParaRPr lang="en-US" sz="1800" dirty="0"/>
           </a:p>
@@ -16707,7 +16707,7 @@
                 <a:ea typeface="Calibri" pitchFamily="34" charset="-122"/>
                 <a:cs typeface="Calibri" pitchFamily="34" charset="-120"/>
               </a:rPr>
-              <a:t>WITH YOUR SUPPORT, WE CAN:</a:t>
+              <a:t>TOGETHER, WE COULD:</a:t>
             </a:r>
             <a:endParaRPr lang="en-US" sz="1400" dirty="0"/>
           </a:p>
@@ -16790,7 +16790,7 @@
                 <a:ea typeface="Calibri" pitchFamily="34" charset="-122"/>
                 <a:cs typeface="Calibri" pitchFamily="34" charset="-120"/>
               </a:rPr>
-              <a:t>Develop joint products and experiences</a:t>
+              <a:t>Create joint products, like a gym pack with NutriPill</a:t>
             </a:r>
             <a:endParaRPr lang="en-US" sz="1800" dirty="0"/>
           </a:p>
@@ -16873,7 +16873,7 @@
                 <a:ea typeface="Calibri" pitchFamily="34" charset="-122"/>
                 <a:cs typeface="Calibri" pitchFamily="34" charset="-120"/>
               </a:rPr>
-              <a:t>Increase our reach through campaigns</a:t>
+              <a:t>Run campaigns together to reach more people</a:t>
             </a:r>
             <a:endParaRPr lang="en-US" sz="1800" dirty="0"/>
           </a:p>
@@ -16956,7 +16956,7 @@
                 <a:ea typeface="Calibri" pitchFamily="34" charset="-122"/>
                 <a:cs typeface="Calibri" pitchFamily="34" charset="-120"/>
               </a:rPr>
-              <a:t>Generate greater credibility and growth</a:t>
+              <a:t>Earn trust, because a partner people know makes us more believable</a:t>
             </a:r>
             <a:endParaRPr lang="en-US" sz="1800" dirty="0"/>
           </a:p>
@@ -18473,7 +18473,7 @@
                 <a:ea typeface="Calibri" pitchFamily="34" charset="-122"/>
                 <a:cs typeface="Calibri" pitchFamily="34" charset="-120"/>
               </a:rPr>
-              <a:t>Consolidate an active community around our brand.</a:t>
+              <a:t>Have a group of loyal customers who use NutriPill and talk about it online.</a:t>
             </a:r>
             <a:endParaRPr lang="en-US" sz="1600" dirty="0"/>
           </a:p>
@@ -18595,7 +18595,7 @@
                 <a:ea typeface="Calibri" pitchFamily="34" charset="-122"/>
                 <a:cs typeface="Calibri" pitchFamily="34" charset="-120"/>
               </a:rPr>
-              <a:t>Increase our digital reach and double our customer base.</a:t>
+              <a:t>Reach more people online and double the number of customers we have.</a:t>
             </a:r>
             <a:endParaRPr lang="en-US" sz="1600" dirty="0"/>
           </a:p>
@@ -18717,7 +18717,7 @@
                 <a:ea typeface="Calibri" pitchFamily="34" charset="-122"/>
                 <a:cs typeface="Calibri" pitchFamily="34" charset="-120"/>
               </a:rPr>
-              <a:t>Establish ourselves as a leading brand in the local market, with expansion at a national level.</a:t>
+              <a:t>Become a well-known brand in our city first, and then grow across the whole country.</a:t>
             </a:r>
             <a:endParaRPr lang="en-US" sz="1600" dirty="0"/>
           </a:p>

</xml_diff>

<commit_message>
Add Mercadona to goals and SWOT to match the company vision
Co-Authored-By: Claude Opus 5.5 <noreply@anthropic.com>
Claude-Session: https://claude.ai/code/session_01TFmXfwWy7YkFL9ETqt4WJz
</commit_message>
<xml_diff>
--- a/NutriPill.pptx
+++ b/NutriPill.pptx
@@ -120,12 +120,12 @@
   <p:extLst>
     <p:ext uri="{521415D9-36F7-43E2-AB2F-B90AF26B5E84}">
       <p14:sectionLst xmlns:p14="http://schemas.microsoft.com/office/powerpoint/2010/main">
-        <p14:section name="Welcome" id="{1c401149-ec7a-3a61-0bbf-a6b23228165a}">
+        <p14:section name="Welcome" id="{c9d6ba24-7186-177b-35b1-2052b7f2033a}">
           <p14:sldIdLst>
             <p14:sldId id="256"/>
           </p14:sldIdLst>
         </p14:section>
-        <p14:section name="The idea" id="{66b87272-c7e0-f07f-dcbd-7e637c14f963}">
+        <p14:section name="The idea" id="{241d812d-15ad-2637-4ef3-9af83bc0e644}">
           <p14:sldIdLst>
             <p14:sldId id="257"/>
             <p14:sldId id="258"/>
@@ -134,14 +134,14 @@
             <p14:sldId id="261"/>
           </p14:sldIdLst>
         </p14:section>
-        <p14:section name="Our company" id="{8711b04c-a358-aae9-a0bc-c88919f72d55}">
+        <p14:section name="Our company" id="{7d9ad606-a592-cafa-f178-5addf9466ebc}">
           <p14:sldIdLst>
             <p14:sldId id="262"/>
             <p14:sldId id="263"/>
             <p14:sldId id="264"/>
           </p14:sldIdLst>
         </p14:section>
-        <p14:section name="The business" id="{e2a3e8e2-9510-c46b-6748-bbcac2b69300}">
+        <p14:section name="The business" id="{3d8e0ab3-5d62-36d5-452b-cde8542b7f8b}">
           <p14:sldIdLst>
             <p14:sldId id="265"/>
             <p14:sldId id="266"/>
@@ -818,7 +818,7 @@
           <a:p>
             <a:r>
               <a:rPr lang="en-US" dirty="0"/>
-              <a:t>Before going further, we did a SWOT analysis to look at NutriPill honestly. Our strengths are that it's small, cheap and easy to carry, it's very quick to take, and it uses natural ingredients. But we also have weaknesses: it doesn't replace a real meal, we're a new brand that nobody knows yet, and some people simply don't trust supplements. On the other hand, there are big opportunities: more people have busy lives every year, healthy living is a huge trend on social media, and we could partner with gyms and supermarkets. Finally, the main threats are big supplement brands, energy drinks and protein bars, and the strict health rules for new products.</a:t>
+              <a:t>Before going further, we did a SWOT analysis to look at NutriPill honestly. Our strengths are that it's small, cheap and easy to carry, it's very quick to take, and it uses natural ingredients. But we also have weaknesses: it doesn't replace a real meal, we're a new brand that nobody knows yet, and some people simply don't trust supplements. On the other hand, there are big opportunities: more people have busy lives every year, healthy living is a huge trend on social media, and supermarkets like Mercadona could sell NutriPill to millions of people. Finally, the main threats are big supplement brands, energy drinks and protein bars, and the strict health rules for new products.</a:t>
             </a:r>
             <a:endParaRPr lang="en-US" dirty="0"/>
           </a:p>
@@ -994,7 +994,7 @@
           <a:p>
             <a:r>
               <a:rPr lang="en-US" dirty="0"/>
-              <a:t>Finally, here's what we hope to achieve. In six months, we want to have a group of loyal customers who use NutriPill and talk about it online. In twelve months, we want to reach more people online and double the number of customers we have. And in the long term, our goal is to become a well-known brand in our city first, and then grow across the whole country. To sum up, NutriPill is a simple answer to a problem that a lot of us have every day. Thank you very much for listening. Do you have any questions?</a:t>
+              <a:t>Finally, here's what we hope to achieve. In six months, we want to have a group of loyal customers who use NutriPill and talk about it online. In twelve months, we want to reach more people online and double the number of customers we have. And in five to ten years, our big dream is to see NutriPill on the shelves of big supermarkets like Mercadona here in Spain and Walmart in America, and to reach customers all over the world, in Europe, Asia, Africa and the Americas. To sum up, NutriPill is a simple answer to a problem that a lot of us have every day. Thank you very much for listening. Do you have any questions?</a:t>
             </a:r>
             <a:endParaRPr lang="en-US" dirty="0"/>
           </a:p>
@@ -9057,7 +9057,7 @@
                 <a:ea typeface="Calibri" pitchFamily="34" charset="-122"/>
                 <a:cs typeface="Calibri" pitchFamily="34" charset="-120"/>
               </a:rPr>
-              <a:t>Partnerships with gyms and supermarkets</a:t>
+              <a:t>Selling in supermarkets like Mercadona</a:t>
             </a:r>
             <a:endParaRPr lang="en-US" sz="1500" dirty="0"/>
           </a:p>
@@ -13361,7 +13361,7 @@
       </p:sp>
       <p:pic>
         <p:nvPicPr>
-          <p:cNvPr id="15" name="a4_icon" descr="In the long term">    </p:cNvPr>
+          <p:cNvPr id="15" name="a4_icon" descr="In 5 to 10 years">    </p:cNvPr>
           <p:cNvPicPr>
             <a:picLocks noChangeAspect="1"/>
           </p:cNvPicPr>
@@ -13416,7 +13416,7 @@
                 <a:ea typeface="Calibri" pitchFamily="34" charset="-122"/>
                 <a:cs typeface="Calibri" pitchFamily="34" charset="-120"/>
               </a:rPr>
-              <a:t>In the long term</a:t>
+              <a:t>In 5 to 10 years</a:t>
             </a:r>
             <a:endParaRPr lang="en-US" sz="2200" dirty="0"/>
           </a:p>
@@ -13455,9 +13455,179 @@
                 <a:ea typeface="Calibri" pitchFamily="34" charset="-122"/>
                 <a:cs typeface="Calibri" pitchFamily="34" charset="-120"/>
               </a:rPr>
-              <a:t>Become a well-known brand in our city first, and then grow across the whole country.</a:t>
+              <a:t>Be on the shelves of big supermarkets like Mercadona in Spain and Walmart in America, and reach customers all over the world.</a:t>
             </a:r>
             <a:endParaRPr lang="en-US" sz="1600" dirty="0"/>
+          </a:p>
+        </p:txBody>
+      </p:sp>
+      <p:sp>
+        <p:nvSpPr>
+          <p:cNvPr id="18" name="a5_chip"/>
+          <p:cNvSpPr/>
+          <p:nvPr/>
+        </p:nvSpPr>
+        <p:spPr>
+          <a:xfrm>
+            <a:off x="1691640" y="5897880"/>
+            <a:ext cx="1600200" cy="411480"/>
+          </a:xfrm>
+          <a:prstGeom prst="roundRect">
+            <a:avLst>
+              <a:gd name="adj" fmla="val 48889"/>
+            </a:avLst>
+          </a:prstGeom>
+          <a:solidFill>
+            <a:srgbClr val="FFFFFF"/>
+          </a:solidFill>
+          <a:ln/>
+        </p:spPr>
+      </p:sp>
+      <p:pic>
+        <p:nvPicPr>
+          <p:cNvPr id="19" name="a5_store" descr="store">    </p:cNvPr>
+          <p:cNvPicPr>
+            <a:picLocks noChangeAspect="1"/>
+          </p:cNvPicPr>
+          <p:nvPr/>
+        </p:nvPicPr>
+        <p:blipFill>
+          <a:blip r:embed="rId5"/>
+          <a:stretch>
+            <a:fillRect/>
+          </a:stretch>
+        </p:blipFill>
+        <p:spPr>
+          <a:xfrm>
+            <a:off x="1828800" y="5989320"/>
+            <a:ext cx="228600" cy="228600"/>
+          </a:xfrm>
+          <a:prstGeom prst="rect">
+            <a:avLst/>
+          </a:prstGeom>
+        </p:spPr>
+      </p:pic>
+      <p:sp>
+        <p:nvSpPr>
+          <p:cNvPr id="20" name="a5_chiptext"/>
+          <p:cNvSpPr txBox="1"/>
+          <p:nvPr/>
+        </p:nvSpPr>
+        <p:spPr>
+          <a:xfrm>
+            <a:off x="2103120" y="5897880"/>
+            <a:ext cx="1143000" cy="411480"/>
+          </a:xfrm>
+          <a:prstGeom prst="rect">
+            <a:avLst/>
+          </a:prstGeom>
+          <a:noFill/>
+          <a:ln/>
+        </p:spPr>
+        <p:txBody>
+          <a:bodyPr wrap="square" lIns="0" tIns="0" rIns="0" bIns="0" rtlCol="0" anchor="ctr"/>
+          <a:lstStyle/>
+          <a:p>
+            <a:pPr indent="0" marL="0">
+              <a:buNone/>
+            </a:pPr>
+            <a:r>
+              <a:rPr lang="en-US" sz="1400" b="1" dirty="0">
+                <a:solidFill>
+                  <a:srgbClr val="0B1F3A"/>
+                </a:solidFill>
+                <a:latin typeface="Calibri" pitchFamily="34" charset="0"/>
+                <a:ea typeface="Calibri" pitchFamily="34" charset="-122"/>
+                <a:cs typeface="Calibri" pitchFamily="34" charset="-120"/>
+              </a:rPr>
+              <a:t>Mercadona</a:t>
+            </a:r>
+            <a:endParaRPr lang="en-US" sz="1400" dirty="0"/>
+          </a:p>
+        </p:txBody>
+      </p:sp>
+      <p:sp>
+        <p:nvSpPr>
+          <p:cNvPr id="21" name="a5_chip"/>
+          <p:cNvSpPr/>
+          <p:nvPr/>
+        </p:nvSpPr>
+        <p:spPr>
+          <a:xfrm>
+            <a:off x="3429000" y="5897880"/>
+            <a:ext cx="1371600" cy="411480"/>
+          </a:xfrm>
+          <a:prstGeom prst="roundRect">
+            <a:avLst>
+              <a:gd name="adj" fmla="val 48889"/>
+            </a:avLst>
+          </a:prstGeom>
+          <a:solidFill>
+            <a:srgbClr val="FFFFFF"/>
+          </a:solidFill>
+          <a:ln/>
+        </p:spPr>
+      </p:sp>
+      <p:pic>
+        <p:nvPicPr>
+          <p:cNvPr id="22" name="a5_store" descr="store">    </p:cNvPr>
+          <p:cNvPicPr>
+            <a:picLocks noChangeAspect="1"/>
+          </p:cNvPicPr>
+          <p:nvPr/>
+        </p:nvPicPr>
+        <p:blipFill>
+          <a:blip r:embed="rId6"/>
+          <a:stretch>
+            <a:fillRect/>
+          </a:stretch>
+        </p:blipFill>
+        <p:spPr>
+          <a:xfrm>
+            <a:off x="3566160" y="5989320"/>
+            <a:ext cx="228600" cy="228600"/>
+          </a:xfrm>
+          <a:prstGeom prst="rect">
+            <a:avLst/>
+          </a:prstGeom>
+        </p:spPr>
+      </p:pic>
+      <p:sp>
+        <p:nvSpPr>
+          <p:cNvPr id="23" name="a5_chiptext"/>
+          <p:cNvSpPr txBox="1"/>
+          <p:nvPr/>
+        </p:nvSpPr>
+        <p:spPr>
+          <a:xfrm>
+            <a:off x="3840480" y="5897880"/>
+            <a:ext cx="914400" cy="411480"/>
+          </a:xfrm>
+          <a:prstGeom prst="rect">
+            <a:avLst/>
+          </a:prstGeom>
+          <a:noFill/>
+          <a:ln/>
+        </p:spPr>
+        <p:txBody>
+          <a:bodyPr wrap="square" lIns="0" tIns="0" rIns="0" bIns="0" rtlCol="0" anchor="ctr"/>
+          <a:lstStyle/>
+          <a:p>
+            <a:pPr indent="0" marL="0">
+              <a:buNone/>
+            </a:pPr>
+            <a:r>
+              <a:rPr lang="en-US" sz="1400" b="1" dirty="0">
+                <a:solidFill>
+                  <a:srgbClr val="0B1F3A"/>
+                </a:solidFill>
+                <a:latin typeface="Calibri" pitchFamily="34" charset="0"/>
+                <a:ea typeface="Calibri" pitchFamily="34" charset="-122"/>
+                <a:cs typeface="Calibri" pitchFamily="34" charset="-120"/>
+              </a:rPr>
+              <a:t>Walmart</a:t>
+            </a:r>
+            <a:endParaRPr lang="en-US" sz="1400" dirty="0"/>
           </a:p>
         </p:txBody>
       </p:sp>
@@ -13523,7 +13693,7 @@
               <p:cTn id="2" dur="indefinite" nodeType="mainSeq">
                 <p:childTnLst>
                   <p:par>
-                    <p:cTn id="83" fill="hold">
+                    <p:cTn id="113" fill="hold">
                       <p:stCondLst>
                         <p:cond delay="indefinite"/>
                         <p:cond evt="onBegin" delay="0">
@@ -14579,6 +14749,408 @@
                                         <p:cTn id="82" dur="600" decel="100000" fill="hold"/>
                                         <p:tgtEl>
                                           <p:spTgt spid="17"/>
+                                        </p:tgtEl>
+                                        <p:attrNameLst>
+                                          <p:attrName>ppt_y</p:attrName>
+                                        </p:attrNameLst>
+                                      </p:cBhvr>
+                                      <p:tavLst>
+                                        <p:tav tm="0">
+                                          <p:val>
+                                            <p:strVal val="#ppt_y+0.04"/>
+                                          </p:val>
+                                        </p:tav>
+                                        <p:tav tm="100000">
+                                          <p:val>
+                                            <p:strVal val="#ppt_y"/>
+                                          </p:val>
+                                        </p:tav>
+                                      </p:tavLst>
+                                    </p:anim>
+                                  </p:childTnLst>
+                                </p:cTn>
+                              </p:par>
+                            </p:childTnLst>
+                          </p:cTn>
+                        </p:par>
+                        <p:par>
+                          <p:cTn id="83" fill="hold">
+                            <p:stCondLst>
+                              <p:cond delay="0"/>
+                            </p:stCondLst>
+                            <p:childTnLst>
+                              <p:par>
+                                <p:cTn id="84" presetID="42" presetClass="entr" presetSubtype="0" fill="hold" grpId="0" nodeType="afterEffect">
+                                  <p:stCondLst>
+                                    <p:cond delay="0"/>
+                                  </p:stCondLst>
+                                  <p:childTnLst>
+                                    <p:set>
+                                      <p:cBhvr>
+                                        <p:cTn id="85" dur="1" fill="hold">
+                                          <p:stCondLst>
+                                            <p:cond delay="0"/>
+                                          </p:stCondLst>
+                                        </p:cTn>
+                                        <p:tgtEl>
+                                          <p:spTgt spid="18"/>
+                                        </p:tgtEl>
+                                        <p:attrNameLst>
+                                          <p:attrName>style.visibility</p:attrName>
+                                        </p:attrNameLst>
+                                      </p:cBhvr>
+                                      <p:to>
+                                        <p:strVal val="visible"/>
+                                      </p:to>
+                                    </p:set>
+                                    <p:animEffect transition="in" filter="fade">
+                                      <p:cBhvr>
+                                        <p:cTn id="86" dur="600"/>
+                                        <p:tgtEl>
+                                          <p:spTgt spid="18"/>
+                                        </p:tgtEl>
+                                      </p:cBhvr>
+                                    </p:animEffect>
+                                    <p:anim calcmode="lin" valueType="num">
+                                      <p:cBhvr>
+                                        <p:cTn id="87" dur="600" decel="100000" fill="hold"/>
+                                        <p:tgtEl>
+                                          <p:spTgt spid="18"/>
+                                        </p:tgtEl>
+                                        <p:attrNameLst>
+                                          <p:attrName>ppt_y</p:attrName>
+                                        </p:attrNameLst>
+                                      </p:cBhvr>
+                                      <p:tavLst>
+                                        <p:tav tm="0">
+                                          <p:val>
+                                            <p:strVal val="#ppt_y+0.04"/>
+                                          </p:val>
+                                        </p:tav>
+                                        <p:tav tm="100000">
+                                          <p:val>
+                                            <p:strVal val="#ppt_y"/>
+                                          </p:val>
+                                        </p:tav>
+                                      </p:tavLst>
+                                    </p:anim>
+                                  </p:childTnLst>
+                                </p:cTn>
+                              </p:par>
+                            </p:childTnLst>
+                          </p:cTn>
+                        </p:par>
+                        <p:par>
+                          <p:cTn id="88" fill="hold">
+                            <p:stCondLst>
+                              <p:cond delay="0"/>
+                            </p:stCondLst>
+                            <p:childTnLst>
+                              <p:par>
+                                <p:cTn id="89" presetID="42" presetClass="entr" presetSubtype="0" fill="hold" grpId="0" nodeType="withEffect">
+                                  <p:stCondLst>
+                                    <p:cond delay="0"/>
+                                  </p:stCondLst>
+                                  <p:childTnLst>
+                                    <p:set>
+                                      <p:cBhvr>
+                                        <p:cTn id="90" dur="1" fill="hold">
+                                          <p:stCondLst>
+                                            <p:cond delay="0"/>
+                                          </p:stCondLst>
+                                        </p:cTn>
+                                        <p:tgtEl>
+                                          <p:spTgt spid="19"/>
+                                        </p:tgtEl>
+                                        <p:attrNameLst>
+                                          <p:attrName>style.visibility</p:attrName>
+                                        </p:attrNameLst>
+                                      </p:cBhvr>
+                                      <p:to>
+                                        <p:strVal val="visible"/>
+                                      </p:to>
+                                    </p:set>
+                                    <p:animEffect transition="in" filter="fade">
+                                      <p:cBhvr>
+                                        <p:cTn id="91" dur="600"/>
+                                        <p:tgtEl>
+                                          <p:spTgt spid="19"/>
+                                        </p:tgtEl>
+                                      </p:cBhvr>
+                                    </p:animEffect>
+                                    <p:anim calcmode="lin" valueType="num">
+                                      <p:cBhvr>
+                                        <p:cTn id="92" dur="600" decel="100000" fill="hold"/>
+                                        <p:tgtEl>
+                                          <p:spTgt spid="19"/>
+                                        </p:tgtEl>
+                                        <p:attrNameLst>
+                                          <p:attrName>ppt_y</p:attrName>
+                                        </p:attrNameLst>
+                                      </p:cBhvr>
+                                      <p:tavLst>
+                                        <p:tav tm="0">
+                                          <p:val>
+                                            <p:strVal val="#ppt_y+0.04"/>
+                                          </p:val>
+                                        </p:tav>
+                                        <p:tav tm="100000">
+                                          <p:val>
+                                            <p:strVal val="#ppt_y"/>
+                                          </p:val>
+                                        </p:tav>
+                                      </p:tavLst>
+                                    </p:anim>
+                                  </p:childTnLst>
+                                </p:cTn>
+                              </p:par>
+                            </p:childTnLst>
+                          </p:cTn>
+                        </p:par>
+                        <p:par>
+                          <p:cTn id="93" fill="hold">
+                            <p:stCondLst>
+                              <p:cond delay="0"/>
+                            </p:stCondLst>
+                            <p:childTnLst>
+                              <p:par>
+                                <p:cTn id="94" presetID="42" presetClass="entr" presetSubtype="0" fill="hold" grpId="0" nodeType="withEffect">
+                                  <p:stCondLst>
+                                    <p:cond delay="0"/>
+                                  </p:stCondLst>
+                                  <p:childTnLst>
+                                    <p:set>
+                                      <p:cBhvr>
+                                        <p:cTn id="95" dur="1" fill="hold">
+                                          <p:stCondLst>
+                                            <p:cond delay="0"/>
+                                          </p:stCondLst>
+                                        </p:cTn>
+                                        <p:tgtEl>
+                                          <p:spTgt spid="20"/>
+                                        </p:tgtEl>
+                                        <p:attrNameLst>
+                                          <p:attrName>style.visibility</p:attrName>
+                                        </p:attrNameLst>
+                                      </p:cBhvr>
+                                      <p:to>
+                                        <p:strVal val="visible"/>
+                                      </p:to>
+                                    </p:set>
+                                    <p:animEffect transition="in" filter="fade">
+                                      <p:cBhvr>
+                                        <p:cTn id="96" dur="600"/>
+                                        <p:tgtEl>
+                                          <p:spTgt spid="20"/>
+                                        </p:tgtEl>
+                                      </p:cBhvr>
+                                    </p:animEffect>
+                                    <p:anim calcmode="lin" valueType="num">
+                                      <p:cBhvr>
+                                        <p:cTn id="97" dur="600" decel="100000" fill="hold"/>
+                                        <p:tgtEl>
+                                          <p:spTgt spid="20"/>
+                                        </p:tgtEl>
+                                        <p:attrNameLst>
+                                          <p:attrName>ppt_y</p:attrName>
+                                        </p:attrNameLst>
+                                      </p:cBhvr>
+                                      <p:tavLst>
+                                        <p:tav tm="0">
+                                          <p:val>
+                                            <p:strVal val="#ppt_y+0.04"/>
+                                          </p:val>
+                                        </p:tav>
+                                        <p:tav tm="100000">
+                                          <p:val>
+                                            <p:strVal val="#ppt_y"/>
+                                          </p:val>
+                                        </p:tav>
+                                      </p:tavLst>
+                                    </p:anim>
+                                  </p:childTnLst>
+                                </p:cTn>
+                              </p:par>
+                            </p:childTnLst>
+                          </p:cTn>
+                        </p:par>
+                        <p:par>
+                          <p:cTn id="98" fill="hold">
+                            <p:stCondLst>
+                              <p:cond delay="0"/>
+                            </p:stCondLst>
+                            <p:childTnLst>
+                              <p:par>
+                                <p:cTn id="99" presetID="42" presetClass="entr" presetSubtype="0" fill="hold" grpId="0" nodeType="withEffect">
+                                  <p:stCondLst>
+                                    <p:cond delay="0"/>
+                                  </p:stCondLst>
+                                  <p:childTnLst>
+                                    <p:set>
+                                      <p:cBhvr>
+                                        <p:cTn id="100" dur="1" fill="hold">
+                                          <p:stCondLst>
+                                            <p:cond delay="0"/>
+                                          </p:stCondLst>
+                                        </p:cTn>
+                                        <p:tgtEl>
+                                          <p:spTgt spid="21"/>
+                                        </p:tgtEl>
+                                        <p:attrNameLst>
+                                          <p:attrName>style.visibility</p:attrName>
+                                        </p:attrNameLst>
+                                      </p:cBhvr>
+                                      <p:to>
+                                        <p:strVal val="visible"/>
+                                      </p:to>
+                                    </p:set>
+                                    <p:animEffect transition="in" filter="fade">
+                                      <p:cBhvr>
+                                        <p:cTn id="101" dur="600"/>
+                                        <p:tgtEl>
+                                          <p:spTgt spid="21"/>
+                                        </p:tgtEl>
+                                      </p:cBhvr>
+                                    </p:animEffect>
+                                    <p:anim calcmode="lin" valueType="num">
+                                      <p:cBhvr>
+                                        <p:cTn id="102" dur="600" decel="100000" fill="hold"/>
+                                        <p:tgtEl>
+                                          <p:spTgt spid="21"/>
+                                        </p:tgtEl>
+                                        <p:attrNameLst>
+                                          <p:attrName>ppt_y</p:attrName>
+                                        </p:attrNameLst>
+                                      </p:cBhvr>
+                                      <p:tavLst>
+                                        <p:tav tm="0">
+                                          <p:val>
+                                            <p:strVal val="#ppt_y+0.04"/>
+                                          </p:val>
+                                        </p:tav>
+                                        <p:tav tm="100000">
+                                          <p:val>
+                                            <p:strVal val="#ppt_y"/>
+                                          </p:val>
+                                        </p:tav>
+                                      </p:tavLst>
+                                    </p:anim>
+                                  </p:childTnLst>
+                                </p:cTn>
+                              </p:par>
+                            </p:childTnLst>
+                          </p:cTn>
+                        </p:par>
+                        <p:par>
+                          <p:cTn id="103" fill="hold">
+                            <p:stCondLst>
+                              <p:cond delay="0"/>
+                            </p:stCondLst>
+                            <p:childTnLst>
+                              <p:par>
+                                <p:cTn id="104" presetID="42" presetClass="entr" presetSubtype="0" fill="hold" grpId="0" nodeType="withEffect">
+                                  <p:stCondLst>
+                                    <p:cond delay="0"/>
+                                  </p:stCondLst>
+                                  <p:childTnLst>
+                                    <p:set>
+                                      <p:cBhvr>
+                                        <p:cTn id="105" dur="1" fill="hold">
+                                          <p:stCondLst>
+                                            <p:cond delay="0"/>
+                                          </p:stCondLst>
+                                        </p:cTn>
+                                        <p:tgtEl>
+                                          <p:spTgt spid="22"/>
+                                        </p:tgtEl>
+                                        <p:attrNameLst>
+                                          <p:attrName>style.visibility</p:attrName>
+                                        </p:attrNameLst>
+                                      </p:cBhvr>
+                                      <p:to>
+                                        <p:strVal val="visible"/>
+                                      </p:to>
+                                    </p:set>
+                                    <p:animEffect transition="in" filter="fade">
+                                      <p:cBhvr>
+                                        <p:cTn id="106" dur="600"/>
+                                        <p:tgtEl>
+                                          <p:spTgt spid="22"/>
+                                        </p:tgtEl>
+                                      </p:cBhvr>
+                                    </p:animEffect>
+                                    <p:anim calcmode="lin" valueType="num">
+                                      <p:cBhvr>
+                                        <p:cTn id="107" dur="600" decel="100000" fill="hold"/>
+                                        <p:tgtEl>
+                                          <p:spTgt spid="22"/>
+                                        </p:tgtEl>
+                                        <p:attrNameLst>
+                                          <p:attrName>ppt_y</p:attrName>
+                                        </p:attrNameLst>
+                                      </p:cBhvr>
+                                      <p:tavLst>
+                                        <p:tav tm="0">
+                                          <p:val>
+                                            <p:strVal val="#ppt_y+0.04"/>
+                                          </p:val>
+                                        </p:tav>
+                                        <p:tav tm="100000">
+                                          <p:val>
+                                            <p:strVal val="#ppt_y"/>
+                                          </p:val>
+                                        </p:tav>
+                                      </p:tavLst>
+                                    </p:anim>
+                                  </p:childTnLst>
+                                </p:cTn>
+                              </p:par>
+                            </p:childTnLst>
+                          </p:cTn>
+                        </p:par>
+                        <p:par>
+                          <p:cTn id="108" fill="hold">
+                            <p:stCondLst>
+                              <p:cond delay="0"/>
+                            </p:stCondLst>
+                            <p:childTnLst>
+                              <p:par>
+                                <p:cTn id="109" presetID="42" presetClass="entr" presetSubtype="0" fill="hold" grpId="0" nodeType="withEffect">
+                                  <p:stCondLst>
+                                    <p:cond delay="0"/>
+                                  </p:stCondLst>
+                                  <p:childTnLst>
+                                    <p:set>
+                                      <p:cBhvr>
+                                        <p:cTn id="110" dur="1" fill="hold">
+                                          <p:stCondLst>
+                                            <p:cond delay="0"/>
+                                          </p:stCondLst>
+                                        </p:cTn>
+                                        <p:tgtEl>
+                                          <p:spTgt spid="23"/>
+                                        </p:tgtEl>
+                                        <p:attrNameLst>
+                                          <p:attrName>style.visibility</p:attrName>
+                                        </p:attrNameLst>
+                                      </p:cBhvr>
+                                      <p:to>
+                                        <p:strVal val="visible"/>
+                                      </p:to>
+                                    </p:set>
+                                    <p:animEffect transition="in" filter="fade">
+                                      <p:cBhvr>
+                                        <p:cTn id="111" dur="600"/>
+                                        <p:tgtEl>
+                                          <p:spTgt spid="23"/>
+                                        </p:tgtEl>
+                                      </p:cBhvr>
+                                    </p:animEffect>
+                                    <p:anim calcmode="lin" valueType="num">
+                                      <p:cBhvr>
+                                        <p:cTn id="112" dur="600" decel="100000" fill="hold"/>
+                                        <p:tgtEl>
+                                          <p:spTgt spid="23"/>
                                         </p:tgtEl>
                                         <p:attrNameLst>
                                           <p:attrName>ppt_y</p:attrName>
@@ -14640,6 +15212,10 @@
       <p:bldP spid="14" grpId="0" animBg="1"/>
       <p:bldP spid="16" grpId="0" animBg="1"/>
       <p:bldP spid="17" grpId="0" animBg="1"/>
+      <p:bldP spid="18" grpId="0" animBg="1"/>
+      <p:bldP spid="20" grpId="0" animBg="1"/>
+      <p:bldP spid="21" grpId="0" animBg="1"/>
+      <p:bldP spid="23" grpId="0" animBg="1"/>
     </p:bldLst>
   </p:timing>
 </p:sld>

</xml_diff>